<commit_message>
Presentation: fill the empty space on slides 2, 3, 7, 9, 11 and 12
Icons on the A/B/C cards, a 10x10 grid for the 82% slide, a 0-347 scale for
the guess slide, a larger app screenshot for the demo, and icon cards for the
conclusion. Speaker script updated to match the new notes.

Co-Authored-By: Claude Opus 5.5 <noreply@anthropic.com>
Claude-Session: https://claude.ai/code/session_01NSSQLuCunKxZVNza71ab7L
</commit_message>
<xml_diff>
--- a/presentation/HeatCast_NCR_Presentation.pptx
+++ b/presentation/HeatCast_NCR_Presentation.pptx
@@ -120,7 +120,7 @@
   <p:extLst>
     <p:ext uri="{521415D9-36F7-43E2-AB2F-B90AF26B5E84}">
       <p14:sectionLst xmlns:p14="http://schemas.microsoft.com/office/powerpoint/2010/main">
-        <p14:section name="Introduction" id="{66f7195a-d497-9a38-7751-ad456cf6d727}">
+        <p14:section name="Introduction" id="{3538d1c1-eef5-ad91-c4a2-a3a4a40bfbcd}">
           <p14:sldIdLst>
             <p14:sldId id="256"/>
             <p14:sldId id="257"/>
@@ -128,26 +128,26 @@
             <p14:sldId id="259"/>
           </p14:sldIdLst>
         </p14:section>
-        <p14:section name="Data" id="{827fd5d6-e4a6-9c20-0b31-12830a74f306}">
+        <p14:section name="Data" id="{80136c03-d1cb-a20c-8e70-ea1bf42a4662}">
           <p14:sldIdLst>
             <p14:sldId id="260"/>
           </p14:sldIdLst>
         </p14:section>
-        <p14:section name="Method" id="{fcba3789-e958-2332-910e-c7fc67b264ac}">
+        <p14:section name="Method" id="{406ff36f-d6fd-2b78-def8-344786839f78}">
           <p14:sldIdLst>
             <p14:sldId id="261"/>
             <p14:sldId id="262"/>
             <p14:sldId id="263"/>
           </p14:sldIdLst>
         </p14:section>
-        <p14:section name="Results" id="{8b6e1c08-744a-6e92-b408-646ba337c0d1}">
+        <p14:section name="Results" id="{cea43a8e-b401-b285-ef3e-de463edee67d}">
           <p14:sldIdLst>
             <p14:sldId id="264"/>
             <p14:sldId id="265"/>
             <p14:sldId id="266"/>
           </p14:sldIdLst>
         </p14:section>
-        <p14:section name="Conclusion" id="{4cc20098-2c67-fe6b-0bcc-8021c61e28b2}">
+        <p14:section name="Conclusion" id="{887be380-5587-ae5c-a807-03710bdb4315}">
           <p14:sldIdLst>
             <p14:sldId id="267"/>
             <p14:sldId id="268"/>
@@ -2380,7 +2380,7 @@
             <a:r>
               <a:rPr lang="en-US" dirty="0"/>
               <a:t>EDRIAN (30 seconds)
-Show of hands. Today Manila's heat index reached 44 degrees, which is Danger. Tomorrow will be: A, hotter; B, the same level; C, cooler. Who says A? B? C? (Count quickly.) Let's see how often the same level is right.</a:t>
+Show of hands. Today Manila's heat index reached 44 degrees, which is Danger. Tomorrow will be: A, hotter, Extreme Danger; B, the same level, Danger again; C, cooler. Who says A? B? C? (Count quickly.) Let's see how often the same level is right.</a:t>
             </a:r>
             <a:endParaRPr lang="en-US" dirty="0"/>
           </a:p>
@@ -2469,7 +2469,7 @@
             <a:r>
               <a:rPr lang="en-US" dirty="0"/>
               <a:t>EDRIAN (20 seconds)
-In 2025, for 82 out of every 100 city-days, tomorrow's level was the same as today's. So the simplest forecast, copy today, is already right most of the time. We call it the copy-today rule, and the real question of our project is whether machine learning can beat it.</a:t>
+Each square here is one percent of the city-days in 2025. In 82 out of every 100, tomorrow's level was the same as today's. So the simplest forecast, copy today, is already right most of the time. We call it the copy-today rule, and the real question of our project is whether machine learning can beat it.</a:t>
             </a:r>
             <a:endParaRPr lang="en-US" dirty="0"/>
           </a:p>
@@ -2825,7 +2825,7 @@
             <a:r>
               <a:rPr lang="en-US" dirty="0"/>
               <a:t>MARC (40 seconds)
-Every forecast makes mistakes, so we had to decide which mistake hurts more. Vote with your hands: A, missing a real Danger day, so nobody prepares; or B, a false alarm, activities are moved for nothing. Who says A? B? We agreed A is worse: a missed Danger day can hurt people, while a false alarm costs a change of plans. That is why our rule asks a model to catch more Danger days first. Keep this in mind for the results.</a:t>
+Every forecast makes mistakes, so we had to decide which mistake hurts more. Vote with your hands: A, missing a real Danger day, so nobody prepares and someone may get sick; or B, a false alarm, activities are moved for nothing. Who says A? B? We agreed A is worse: a missed Danger day can hurt people, while a false alarm costs a change of plans. That is why our rule asks a model to catch more Danger days first. Keep this in mind for the results.</a:t>
             </a:r>
             <a:endParaRPr lang="en-US" dirty="0"/>
           </a:p>
@@ -3005,7 +3005,7 @@
             <a:r>
               <a:rPr lang="en-US" dirty="0"/>
               <a:t>MARC (20 seconds)
-Now the final exam, 2025, which we opened only once. There were 347 Danger days across the 16 cities. How many did our model catch: about 100, about 200 or about 300? Hands up for A... B... C...</a:t>
+Now the final exam, 2025, which we opened only once. There were 347 Danger days across the 16 cities. How many did our model catch: about 100, about 200 or about 300? A hint: copying today caught 207. Hands up for A... B... C...</a:t>
             </a:r>
             <a:endParaRPr lang="en-US" dirty="0"/>
           </a:p>
@@ -4640,8 +4640,8 @@
         </p:nvSpPr>
         <p:spPr>
           <a:xfrm>
-            <a:off x="1691640" y="2103120"/>
-            <a:ext cx="5394960" cy="1097280"/>
+            <a:off x="1645920" y="2103120"/>
+            <a:ext cx="3749040" cy="1143000"/>
           </a:xfrm>
           <a:prstGeom prst="rect">
             <a:avLst/>
@@ -4674,12 +4674,12 @@
               <a:buNone/>
             </a:pPr>
             <a:r>
-              <a:rPr lang="en-US" sz="1500" dirty="0">
+              <a:rPr lang="en-US" sz="1400" dirty="0">
                 <a:solidFill>
                   <a:srgbClr val="6F5C51"/>
                 </a:solidFill>
               </a:rPr>
-              <a:t>Call out any of the 16 cities. We type a hot day: heat index 45.5 °C, lowest 29 °C, no rain, 1,008 hPa, sunshine 7,000.</a:t>
+              <a:t>Call out a city. We type a hot day: heat index 45.5 °C, lowest 29 °C, no rain, 1,008 hPa, sunshine 7,000.</a:t>
             </a:r>
             <a:endParaRPr lang="en-US" sz="2000" dirty="0"/>
           </a:p>
@@ -4752,8 +4752,8 @@
         </p:nvSpPr>
         <p:spPr>
           <a:xfrm>
-            <a:off x="1691640" y="3291840"/>
-            <a:ext cx="5394960" cy="1097280"/>
+            <a:off x="1645920" y="3291840"/>
+            <a:ext cx="3749040" cy="1143000"/>
           </a:xfrm>
           <a:prstGeom prst="rect">
             <a:avLst/>
@@ -4786,7 +4786,7 @@
               <a:buNone/>
             </a:pPr>
             <a:r>
-              <a:rPr lang="en-US" sz="1500" dirty="0">
+              <a:rPr lang="en-US" sz="1400" dirty="0">
                 <a:solidFill>
                   <a:srgbClr val="6F5C51"/>
                 </a:solidFill>
@@ -4864,8 +4864,8 @@
         </p:nvSpPr>
         <p:spPr>
           <a:xfrm>
-            <a:off x="1691640" y="4480560"/>
-            <a:ext cx="5394960" cy="1097280"/>
+            <a:off x="1645920" y="4480560"/>
+            <a:ext cx="3749040" cy="1143000"/>
           </a:xfrm>
           <a:prstGeom prst="rect">
             <a:avLst/>
@@ -4898,7 +4898,7 @@
               <a:buNone/>
             </a:pPr>
             <a:r>
-              <a:rPr lang="en-US" sz="1500" dirty="0">
+              <a:rPr lang="en-US" sz="1400" dirty="0">
                 <a:solidFill>
                   <a:srgbClr val="6F5C51"/>
                 </a:solidFill>
@@ -4918,7 +4918,7 @@
         <p:spPr>
           <a:xfrm>
             <a:off x="868680" y="5715000"/>
-            <a:ext cx="6035040" cy="320040"/>
+            <a:ext cx="4526280" cy="320040"/>
           </a:xfrm>
           <a:prstGeom prst="rect">
             <a:avLst/>
@@ -4934,14 +4934,14 @@
               <a:buNone/>
             </a:pPr>
             <a:r>
-              <a:rPr lang="en-US" sz="1300" i="1" dirty="0">
+              <a:rPr lang="en-US" sz="1200" i="1" dirty="0">
                 <a:solidFill>
                   <a:srgbClr val="6F5C51"/>
                 </a:solidFill>
               </a:rPr>
               <a:t>The app uses the same saved Random Forest that took the final exam.</a:t>
             </a:r>
-            <a:endParaRPr lang="en-US" sz="1300" dirty="0"/>
+            <a:endParaRPr lang="en-US" sz="1200" dirty="0"/>
           </a:p>
         </p:txBody>
       </p:sp>
@@ -4961,8 +4961,8 @@
         </p:blipFill>
         <p:spPr>
           <a:xfrm>
-            <a:off x="8212266" y="1965960"/>
-            <a:ext cx="3126294" cy="4069080"/>
+            <a:off x="5550150" y="1965960"/>
+            <a:ext cx="5788410" cy="4069080"/>
           </a:xfrm>
           <a:prstGeom prst="rect">
             <a:avLst/>
@@ -4977,8 +4977,8 @@
         </p:nvSpPr>
         <p:spPr>
           <a:xfrm>
-            <a:off x="8212266" y="1965960"/>
-            <a:ext cx="3126294" cy="4069080"/>
+            <a:off x="5550150" y="1965960"/>
+            <a:ext cx="5788410" cy="4069080"/>
           </a:xfrm>
           <a:prstGeom prst="rect">
             <a:avLst/>
@@ -5202,15 +5202,39 @@
           </a:p>
         </p:txBody>
       </p:sp>
-      <p:sp>
-        <p:nvSpPr>
-          <p:cNvPr id="6" name="Text 4"/>
+      <p:pic>
+        <p:nvPicPr>
+          <p:cNvPr id="6" name="Conclusion icon 01" descr="The answer">    </p:cNvPr>
+          <p:cNvPicPr>
+            <a:picLocks noChangeAspect="1"/>
+          </p:cNvPicPr>
+          <p:nvPr/>
+        </p:nvPicPr>
+        <p:blipFill>
+          <a:blip r:embed="rId1"/>
+          <a:stretch>
+            <a:fillRect/>
+          </a:stretch>
+        </p:blipFill>
+        <p:spPr>
+          <a:xfrm>
+            <a:off x="3191256" y="2331720"/>
+            <a:ext cx="731520" cy="731520"/>
+          </a:xfrm>
+          <a:prstGeom prst="rect">
+            <a:avLst/>
+          </a:prstGeom>
+        </p:spPr>
+      </p:pic>
+      <p:sp>
+        <p:nvSpPr>
+          <p:cNvPr id="7" name="Text 4"/>
           <p:cNvSpPr txBox="1"/>
           <p:nvPr/>
         </p:nvSpPr>
         <p:spPr>
           <a:xfrm>
-            <a:off x="1143000" y="3200400"/>
+            <a:off x="1143000" y="3246120"/>
             <a:ext cx="2834640" cy="2377440"/>
           </a:xfrm>
           <a:prstGeom prst="rect">
@@ -5230,7 +5254,7 @@
               <a:buNone/>
             </a:pPr>
             <a:r>
-              <a:rPr lang="en-US" sz="2100" dirty="0">
+              <a:rPr lang="en-US" sz="2400" dirty="0">
                 <a:solidFill>
                   <a:srgbClr val="2E1406"/>
                 </a:solidFill>
@@ -5240,7 +5264,7 @@
               </a:rPr>
               <a:t>The answer</a:t>
             </a:r>
-            <a:endParaRPr lang="en-US" sz="2100" dirty="0"/>
+            <a:endParaRPr lang="en-US" sz="2400" dirty="0"/>
           </a:p>
           <a:p>
             <a:pPr indent="0" marL="0">
@@ -5250,20 +5274,20 @@
               <a:buNone/>
             </a:pPr>
             <a:r>
-              <a:rPr lang="en-US" sz="1600" dirty="0">
+              <a:rPr lang="en-US" sz="1900" dirty="0">
                 <a:solidFill>
                   <a:srgbClr val="2E1406"/>
                 </a:solidFill>
               </a:rPr>
               <a:t>No. None of our models beat copying today's level on overall score: tomorrow's heat is mostly today's heat.</a:t>
             </a:r>
-            <a:endParaRPr lang="en-US" sz="2100" dirty="0"/>
-          </a:p>
-        </p:txBody>
-      </p:sp>
-      <p:sp>
-        <p:nvSpPr>
-          <p:cNvPr id="7" name="Conclusion 02"/>
+            <a:endParaRPr lang="en-US" sz="2400" dirty="0"/>
+          </a:p>
+        </p:txBody>
+      </p:sp>
+      <p:sp>
+        <p:nvSpPr>
+          <p:cNvPr id="8" name="Conclusion 02"/>
           <p:cNvSpPr/>
           <p:nvPr/>
         </p:nvSpPr>
@@ -5283,7 +5307,7 @@
       </p:sp>
       <p:sp>
         <p:nvSpPr>
-          <p:cNvPr id="8" name="Text 6"/>
+          <p:cNvPr id="9" name="Text 6"/>
           <p:cNvSpPr txBox="1"/>
           <p:nvPr/>
         </p:nvSpPr>
@@ -5320,15 +5344,39 @@
           </a:p>
         </p:txBody>
       </p:sp>
-      <p:sp>
-        <p:nvSpPr>
-          <p:cNvPr id="9" name="Text 7"/>
+      <p:pic>
+        <p:nvPicPr>
+          <p:cNvPr id="10" name="Conclusion icon 02" descr="What ML adds">    </p:cNvPr>
+          <p:cNvPicPr>
+            <a:picLocks noChangeAspect="1"/>
+          </p:cNvPicPr>
+          <p:nvPr/>
+        </p:nvPicPr>
+        <p:blipFill>
+          <a:blip r:embed="rId2"/>
+          <a:stretch>
+            <a:fillRect/>
+          </a:stretch>
+        </p:blipFill>
+        <p:spPr>
+          <a:xfrm>
+            <a:off x="6739128" y="2331720"/>
+            <a:ext cx="731520" cy="731520"/>
+          </a:xfrm>
+          <a:prstGeom prst="rect">
+            <a:avLst/>
+          </a:prstGeom>
+        </p:spPr>
+      </p:pic>
+      <p:sp>
+        <p:nvSpPr>
+          <p:cNvPr id="11" name="Text 7"/>
           <p:cNvSpPr txBox="1"/>
           <p:nvPr/>
         </p:nvSpPr>
         <p:spPr>
           <a:xfrm>
-            <a:off x="4690872" y="3200400"/>
+            <a:off x="4690872" y="3246120"/>
             <a:ext cx="2834640" cy="2377440"/>
           </a:xfrm>
           <a:prstGeom prst="rect">
@@ -5348,7 +5396,7 @@
               <a:buNone/>
             </a:pPr>
             <a:r>
-              <a:rPr lang="en-US" sz="2100" dirty="0">
+              <a:rPr lang="en-US" sz="2400" dirty="0">
                 <a:solidFill>
                   <a:srgbClr val="2E1406"/>
                 </a:solidFill>
@@ -5358,7 +5406,7 @@
               </a:rPr>
               <a:t>What ML adds</a:t>
             </a:r>
-            <a:endParaRPr lang="en-US" sz="2100" dirty="0"/>
+            <a:endParaRPr lang="en-US" sz="2400" dirty="0"/>
           </a:p>
           <a:p>
             <a:pPr indent="0" marL="0">
@@ -5368,20 +5416,20 @@
               <a:buNone/>
             </a:pPr>
             <a:r>
-              <a:rPr lang="en-US" sz="1600" dirty="0">
+              <a:rPr lang="en-US" sz="1900" dirty="0">
                 <a:solidFill>
                   <a:srgbClr val="2E1406"/>
                 </a:solidFill>
               </a:rPr>
               <a:t>Told that Danger days matter more, the Random Forest caught 84% of them in 2025. We deployed it as an early warning.</a:t>
             </a:r>
-            <a:endParaRPr lang="en-US" sz="2100" dirty="0"/>
-          </a:p>
-        </p:txBody>
-      </p:sp>
-      <p:sp>
-        <p:nvSpPr>
-          <p:cNvPr id="10" name="Conclusion 03"/>
+            <a:endParaRPr lang="en-US" sz="2400" dirty="0"/>
+          </a:p>
+        </p:txBody>
+      </p:sp>
+      <p:sp>
+        <p:nvSpPr>
+          <p:cNvPr id="12" name="Conclusion 03"/>
           <p:cNvSpPr/>
           <p:nvPr/>
         </p:nvSpPr>
@@ -5401,7 +5449,7 @@
       </p:sp>
       <p:sp>
         <p:nvSpPr>
-          <p:cNvPr id="11" name="Text 9"/>
+          <p:cNvPr id="13" name="Text 9"/>
           <p:cNvSpPr txBox="1"/>
           <p:nvPr/>
         </p:nvSpPr>
@@ -5438,15 +5486,39 @@
           </a:p>
         </p:txBody>
       </p:sp>
-      <p:sp>
-        <p:nvSpPr>
-          <p:cNvPr id="12" name="Text 10"/>
+      <p:pic>
+        <p:nvPicPr>
+          <p:cNvPr id="14" name="Conclusion icon 03" descr="Limits and next steps">    </p:cNvPr>
+          <p:cNvPicPr>
+            <a:picLocks noChangeAspect="1"/>
+          </p:cNvPicPr>
+          <p:nvPr/>
+        </p:nvPicPr>
+        <p:blipFill>
+          <a:blip r:embed="rId3"/>
+          <a:stretch>
+            <a:fillRect/>
+          </a:stretch>
+        </p:blipFill>
+        <p:spPr>
+          <a:xfrm>
+            <a:off x="10287000" y="2331720"/>
+            <a:ext cx="731520" cy="731520"/>
+          </a:xfrm>
+          <a:prstGeom prst="rect">
+            <a:avLst/>
+          </a:prstGeom>
+        </p:spPr>
+      </p:pic>
+      <p:sp>
+        <p:nvSpPr>
+          <p:cNvPr id="15" name="Text 10"/>
           <p:cNvSpPr txBox="1"/>
           <p:nvPr/>
         </p:nvSpPr>
         <p:spPr>
           <a:xfrm>
-            <a:off x="8238744" y="3200400"/>
+            <a:off x="8238744" y="3246120"/>
             <a:ext cx="2834640" cy="2377440"/>
           </a:xfrm>
           <a:prstGeom prst="rect">
@@ -5466,7 +5538,7 @@
               <a:buNone/>
             </a:pPr>
             <a:r>
-              <a:rPr lang="en-US" sz="2100" dirty="0">
+              <a:rPr lang="en-US" sz="2400" dirty="0">
                 <a:solidFill>
                   <a:srgbClr val="2E1406"/>
                 </a:solidFill>
@@ -5476,7 +5548,7 @@
               </a:rPr>
               <a:t>Limits and next steps</a:t>
             </a:r>
-            <a:endParaRPr lang="en-US" sz="2100" dirty="0"/>
+            <a:endParaRPr lang="en-US" sz="2400" dirty="0"/>
           </a:p>
           <a:p>
             <a:pPr indent="0" marL="0">
@@ -5486,14 +5558,14 @@
               <a:buNone/>
             </a:pPr>
             <a:r>
-              <a:rPr lang="en-US" sz="1600" dirty="0">
+              <a:rPr lang="en-US" sz="1900" dirty="0">
                 <a:solidFill>
                   <a:srgbClr val="2E1406"/>
                 </a:solidFill>
               </a:rPr>
               <a:t>Weather estimates, not station readings; only five years. Next: add the month and recent days, a weather forecast, and more years.</a:t>
             </a:r>
-            <a:endParaRPr lang="en-US" sz="2100" dirty="0"/>
+            <a:endParaRPr lang="en-US" sz="2400" dirty="0"/>
           </a:p>
         </p:txBody>
       </p:sp>
@@ -7224,7 +7296,7 @@
         </p:nvSpPr>
         <p:spPr>
           <a:xfrm>
-            <a:off x="1280160" y="2148840"/>
+            <a:off x="1280160" y="2011680"/>
             <a:ext cx="9631375" cy="914400"/>
           </a:xfrm>
           <a:prstGeom prst="rect">
@@ -7263,8 +7335,8 @@
         </p:nvSpPr>
         <p:spPr>
           <a:xfrm>
-            <a:off x="868680" y="3429000"/>
-            <a:ext cx="3307080" cy="2331720"/>
+            <a:off x="868680" y="3154680"/>
+            <a:ext cx="3374136" cy="2834640"/>
           </a:xfrm>
           <a:prstGeom prst="rect">
             <a:avLst/>
@@ -7283,7 +7355,7 @@
         </p:nvSpPr>
         <p:spPr>
           <a:xfrm>
-            <a:off x="1143000" y="3703320"/>
+            <a:off x="1143000" y="3429000"/>
             <a:ext cx="640080" cy="640080"/>
           </a:xfrm>
           <a:prstGeom prst="ellipse">
@@ -7303,7 +7375,7 @@
         </p:nvSpPr>
         <p:spPr>
           <a:xfrm>
-            <a:off x="1143000" y="3703320"/>
+            <a:off x="1143000" y="3429000"/>
             <a:ext cx="640080" cy="640080"/>
           </a:xfrm>
           <a:prstGeom prst="rect">
@@ -7334,16 +7406,40 @@
           </a:p>
         </p:txBody>
       </p:sp>
-      <p:sp>
-        <p:nvSpPr>
-          <p:cNvPr id="8" name="Option text A"/>
+      <p:pic>
+        <p:nvPicPr>
+          <p:cNvPr id="8" name="Option icon A" descr="Hotter">    </p:cNvPr>
+          <p:cNvPicPr>
+            <a:picLocks noChangeAspect="1"/>
+          </p:cNvPicPr>
+          <p:nvPr/>
+        </p:nvPicPr>
+        <p:blipFill>
+          <a:blip r:embed="rId1"/>
+          <a:stretch>
+            <a:fillRect/>
+          </a:stretch>
+        </p:blipFill>
+        <p:spPr>
+          <a:xfrm>
+            <a:off x="3191256" y="3410712"/>
+            <a:ext cx="731520" cy="731520"/>
+          </a:xfrm>
+          <a:prstGeom prst="rect">
+            <a:avLst/>
+          </a:prstGeom>
+        </p:spPr>
+      </p:pic>
+      <p:sp>
+        <p:nvSpPr>
+          <p:cNvPr id="9" name="Option head A"/>
           <p:cNvSpPr txBox="1"/>
           <p:nvPr/>
         </p:nvSpPr>
         <p:spPr>
           <a:xfrm>
-            <a:off x="1143000" y="4480560"/>
-            <a:ext cx="2758440" cy="1097280"/>
+            <a:off x="1143000" y="4251960"/>
+            <a:ext cx="2825496" cy="548640"/>
           </a:xfrm>
           <a:prstGeom prst="rect">
             <a:avLst/>
@@ -7352,98 +7448,22 @@
           <a:ln/>
         </p:spPr>
         <p:txBody>
-          <a:bodyPr wrap="square" lIns="0" tIns="0" rIns="0" bIns="0" rtlCol="0" anchor="t"/>
+          <a:bodyPr wrap="square" lIns="0" tIns="0" rIns="0" bIns="0" rtlCol="0" anchor="ctr"/>
           <a:lstStyle/>
           <a:p>
             <a:pPr indent="0" marL="0">
               <a:buNone/>
             </a:pPr>
             <a:r>
-              <a:rPr lang="en-US" sz="2400" dirty="0">
+              <a:rPr lang="en-US" sz="2600" dirty="0">
                 <a:solidFill>
                   <a:srgbClr val="2E1406"/>
-                </a:solidFill>
-              </a:rPr>
-              <a:t>Hotter: Extreme Danger</a:t>
-            </a:r>
-            <a:endParaRPr lang="en-US" sz="2400" dirty="0"/>
-          </a:p>
-        </p:txBody>
-      </p:sp>
-      <p:sp>
-        <p:nvSpPr>
-          <p:cNvPr id="9" name="Option B"/>
-          <p:cNvSpPr/>
-          <p:nvPr/>
-        </p:nvSpPr>
-        <p:spPr>
-          <a:xfrm>
-            <a:off x="4450080" y="3429000"/>
-            <a:ext cx="3307080" cy="2331720"/>
-          </a:xfrm>
-          <a:prstGeom prst="rect">
-            <a:avLst/>
-          </a:prstGeom>
-          <a:solidFill>
-            <a:srgbClr val="FDEBDC"/>
-          </a:solidFill>
-          <a:ln/>
-        </p:spPr>
-      </p:sp>
-      <p:sp>
-        <p:nvSpPr>
-          <p:cNvPr id="10" name="Option dot B"/>
-          <p:cNvSpPr/>
-          <p:nvPr/>
-        </p:nvSpPr>
-        <p:spPr>
-          <a:xfrm>
-            <a:off x="4724400" y="3703320"/>
-            <a:ext cx="640080" cy="640080"/>
-          </a:xfrm>
-          <a:prstGeom prst="ellipse">
-            <a:avLst/>
-          </a:prstGeom>
-          <a:solidFill>
-            <a:srgbClr val="A63A0C"/>
-          </a:solidFill>
-          <a:ln/>
-        </p:spPr>
-      </p:sp>
-      <p:sp>
-        <p:nvSpPr>
-          <p:cNvPr id="11" name="Text 9"/>
-          <p:cNvSpPr txBox="1"/>
-          <p:nvPr/>
-        </p:nvSpPr>
-        <p:spPr>
-          <a:xfrm>
-            <a:off x="4724400" y="3703320"/>
-            <a:ext cx="640080" cy="640080"/>
-          </a:xfrm>
-          <a:prstGeom prst="rect">
-            <a:avLst/>
-          </a:prstGeom>
-          <a:noFill/>
-          <a:ln/>
-        </p:spPr>
-        <p:txBody>
-          <a:bodyPr wrap="square" lIns="0" tIns="0" rIns="0" bIns="0" rtlCol="0" anchor="ctr"/>
-          <a:lstStyle/>
-          <a:p>
-            <a:pPr algn="ctr" indent="0" marL="0">
-              <a:buNone/>
-            </a:pPr>
-            <a:r>
-              <a:rPr lang="en-US" sz="2600" dirty="0">
-                <a:solidFill>
-                  <a:srgbClr val="FFFFFF"/>
                 </a:solidFill>
                 <a:latin typeface="Cambria" pitchFamily="34" charset="0"/>
                 <a:ea typeface="Cambria" pitchFamily="34" charset="-122"/>
                 <a:cs typeface="Cambria" pitchFamily="34" charset="-120"/>
               </a:rPr>
-              <a:t>B</a:t>
+              <a:t>Hotter</a:t>
             </a:r>
             <a:endParaRPr lang="en-US" sz="2600" dirty="0"/>
           </a:p>
@@ -7451,50 +7471,66 @@
       </p:sp>
       <p:sp>
         <p:nvSpPr>
-          <p:cNvPr id="12" name="Option text B"/>
+          <p:cNvPr id="10" name="Option level A"/>
           <p:cNvSpPr txBox="1"/>
           <p:nvPr/>
         </p:nvSpPr>
         <p:spPr>
           <a:xfrm>
-            <a:off x="4724400" y="4480560"/>
-            <a:ext cx="2758440" cy="1097280"/>
-          </a:xfrm>
-          <a:prstGeom prst="rect">
-            <a:avLst/>
-          </a:prstGeom>
-          <a:noFill/>
-          <a:ln/>
-        </p:spPr>
-        <p:txBody>
-          <a:bodyPr wrap="square" lIns="0" tIns="0" rIns="0" bIns="0" rtlCol="0" anchor="t"/>
-          <a:lstStyle/>
-          <a:p>
-            <a:pPr indent="0" marL="0">
-              <a:buNone/>
-            </a:pPr>
-            <a:r>
-              <a:rPr lang="en-US" sz="2400" dirty="0">
-                <a:solidFill>
-                  <a:srgbClr val="2E1406"/>
-                </a:solidFill>
-              </a:rPr>
-              <a:t>The same level: Danger again</a:t>
-            </a:r>
-            <a:endParaRPr lang="en-US" sz="2400" dirty="0"/>
-          </a:p>
-        </p:txBody>
-      </p:sp>
-      <p:sp>
-        <p:nvSpPr>
-          <p:cNvPr id="13" name="Option C"/>
-          <p:cNvSpPr/>
-          <p:nvPr/>
-        </p:nvSpPr>
-        <p:spPr>
-          <a:xfrm>
-            <a:off x="8031480" y="3429000"/>
-            <a:ext cx="3307080" cy="2331720"/>
+            <a:off x="1143000" y="4937760"/>
+            <a:ext cx="2825496" cy="777240"/>
+          </a:xfrm>
+          <a:prstGeom prst="rect">
+            <a:avLst/>
+          </a:prstGeom>
+          <a:solidFill>
+            <a:srgbClr val="6E0000"/>
+          </a:solidFill>
+          <a:ln/>
+        </p:spPr>
+        <p:txBody>
+          <a:bodyPr wrap="square" lIns="50800" tIns="50800" rIns="50800" bIns="50800" rtlCol="0" anchor="ctr"/>
+          <a:lstStyle/>
+          <a:p>
+            <a:pPr algn="ctr" indent="0" marL="0">
+              <a:buNone/>
+            </a:pPr>
+            <a:r>
+              <a:rPr lang="en-US" sz="1600" b="1" dirty="0">
+                <a:solidFill>
+                  <a:srgbClr val="FFFFFF"/>
+                </a:solidFill>
+              </a:rPr>
+              <a:t>Extreme Danger</a:t>
+            </a:r>
+            <a:endParaRPr lang="en-US" sz="1600" dirty="0"/>
+          </a:p>
+          <a:p>
+            <a:pPr algn="ctr" indent="0" marL="0">
+              <a:buNone/>
+            </a:pPr>
+            <a:r>
+              <a:rPr lang="en-US" sz="1600" dirty="0">
+                <a:solidFill>
+                  <a:srgbClr val="FFFFFF"/>
+                </a:solidFill>
+              </a:rPr>
+              <a:t>52 °C and up</a:t>
+            </a:r>
+            <a:endParaRPr lang="en-US" sz="1600" dirty="0"/>
+          </a:p>
+        </p:txBody>
+      </p:sp>
+      <p:sp>
+        <p:nvSpPr>
+          <p:cNvPr id="11" name="Option B"/>
+          <p:cNvSpPr/>
+          <p:nvPr/>
+        </p:nvSpPr>
+        <p:spPr>
+          <a:xfrm>
+            <a:off x="4416552" y="3154680"/>
+            <a:ext cx="3374136" cy="2834640"/>
           </a:xfrm>
           <a:prstGeom prst="rect">
             <a:avLst/>
@@ -7507,13 +7543,13 @@
       </p:sp>
       <p:sp>
         <p:nvSpPr>
-          <p:cNvPr id="14" name="Option dot C"/>
-          <p:cNvSpPr/>
-          <p:nvPr/>
-        </p:nvSpPr>
-        <p:spPr>
-          <a:xfrm>
-            <a:off x="8305800" y="3703320"/>
+          <p:cNvPr id="12" name="Option dot B"/>
+          <p:cNvSpPr/>
+          <p:nvPr/>
+        </p:nvSpPr>
+        <p:spPr>
+          <a:xfrm>
+            <a:off x="4690872" y="3429000"/>
             <a:ext cx="640080" cy="640080"/>
           </a:xfrm>
           <a:prstGeom prst="ellipse">
@@ -7527,13 +7563,13 @@
       </p:sp>
       <p:sp>
         <p:nvSpPr>
-          <p:cNvPr id="15" name="Text 13"/>
+          <p:cNvPr id="13" name="Text 10"/>
           <p:cNvSpPr txBox="1"/>
           <p:nvPr/>
         </p:nvSpPr>
         <p:spPr>
           <a:xfrm>
-            <a:off x="8305800" y="3703320"/>
+            <a:off x="4690872" y="3429000"/>
             <a:ext cx="640080" cy="640080"/>
           </a:xfrm>
           <a:prstGeom prst="rect">
@@ -7558,22 +7594,240 @@
                 <a:ea typeface="Cambria" pitchFamily="34" charset="-122"/>
                 <a:cs typeface="Cambria" pitchFamily="34" charset="-120"/>
               </a:rPr>
+              <a:t>B</a:t>
+            </a:r>
+            <a:endParaRPr lang="en-US" sz="2600" dirty="0"/>
+          </a:p>
+        </p:txBody>
+      </p:sp>
+      <p:pic>
+        <p:nvPicPr>
+          <p:cNvPr id="14" name="Option icon B" descr="The same level">    </p:cNvPr>
+          <p:cNvPicPr>
+            <a:picLocks noChangeAspect="1"/>
+          </p:cNvPicPr>
+          <p:nvPr/>
+        </p:nvPicPr>
+        <p:blipFill>
+          <a:blip r:embed="rId2"/>
+          <a:stretch>
+            <a:fillRect/>
+          </a:stretch>
+        </p:blipFill>
+        <p:spPr>
+          <a:xfrm>
+            <a:off x="6739128" y="3410712"/>
+            <a:ext cx="731520" cy="731520"/>
+          </a:xfrm>
+          <a:prstGeom prst="rect">
+            <a:avLst/>
+          </a:prstGeom>
+        </p:spPr>
+      </p:pic>
+      <p:sp>
+        <p:nvSpPr>
+          <p:cNvPr id="15" name="Option head B"/>
+          <p:cNvSpPr txBox="1"/>
+          <p:nvPr/>
+        </p:nvSpPr>
+        <p:spPr>
+          <a:xfrm>
+            <a:off x="4690872" y="4251960"/>
+            <a:ext cx="2825496" cy="548640"/>
+          </a:xfrm>
+          <a:prstGeom prst="rect">
+            <a:avLst/>
+          </a:prstGeom>
+          <a:noFill/>
+          <a:ln/>
+        </p:spPr>
+        <p:txBody>
+          <a:bodyPr wrap="square" lIns="0" tIns="0" rIns="0" bIns="0" rtlCol="0" anchor="ctr"/>
+          <a:lstStyle/>
+          <a:p>
+            <a:pPr indent="0" marL="0">
+              <a:buNone/>
+            </a:pPr>
+            <a:r>
+              <a:rPr lang="en-US" sz="2600" dirty="0">
+                <a:solidFill>
+                  <a:srgbClr val="2E1406"/>
+                </a:solidFill>
+                <a:latin typeface="Cambria" pitchFamily="34" charset="0"/>
+                <a:ea typeface="Cambria" pitchFamily="34" charset="-122"/>
+                <a:cs typeface="Cambria" pitchFamily="34" charset="-120"/>
+              </a:rPr>
+              <a:t>The same level</a:t>
+            </a:r>
+            <a:endParaRPr lang="en-US" sz="2600" dirty="0"/>
+          </a:p>
+        </p:txBody>
+      </p:sp>
+      <p:sp>
+        <p:nvSpPr>
+          <p:cNvPr id="16" name="Option level B"/>
+          <p:cNvSpPr txBox="1"/>
+          <p:nvPr/>
+        </p:nvSpPr>
+        <p:spPr>
+          <a:xfrm>
+            <a:off x="4690872" y="4937760"/>
+            <a:ext cx="2825496" cy="777240"/>
+          </a:xfrm>
+          <a:prstGeom prst="rect">
+            <a:avLst/>
+          </a:prstGeom>
+          <a:solidFill>
+            <a:srgbClr val="C0392B"/>
+          </a:solidFill>
+          <a:ln/>
+        </p:spPr>
+        <p:txBody>
+          <a:bodyPr wrap="square" lIns="50800" tIns="50800" rIns="50800" bIns="50800" rtlCol="0" anchor="ctr"/>
+          <a:lstStyle/>
+          <a:p>
+            <a:pPr algn="ctr" indent="0" marL="0">
+              <a:buNone/>
+            </a:pPr>
+            <a:r>
+              <a:rPr lang="en-US" sz="1600" b="1" dirty="0">
+                <a:solidFill>
+                  <a:srgbClr val="FFFFFF"/>
+                </a:solidFill>
+              </a:rPr>
+              <a:t>Danger again</a:t>
+            </a:r>
+            <a:endParaRPr lang="en-US" sz="1600" dirty="0"/>
+          </a:p>
+          <a:p>
+            <a:pPr algn="ctr" indent="0" marL="0">
+              <a:buNone/>
+            </a:pPr>
+            <a:r>
+              <a:rPr lang="en-US" sz="1600" dirty="0">
+                <a:solidFill>
+                  <a:srgbClr val="FFFFFF"/>
+                </a:solidFill>
+              </a:rPr>
+              <a:t>42 to 51 °C</a:t>
+            </a:r>
+            <a:endParaRPr lang="en-US" sz="1600" dirty="0"/>
+          </a:p>
+        </p:txBody>
+      </p:sp>
+      <p:sp>
+        <p:nvSpPr>
+          <p:cNvPr id="17" name="Option C"/>
+          <p:cNvSpPr/>
+          <p:nvPr/>
+        </p:nvSpPr>
+        <p:spPr>
+          <a:xfrm>
+            <a:off x="7964424" y="3154680"/>
+            <a:ext cx="3374136" cy="2834640"/>
+          </a:xfrm>
+          <a:prstGeom prst="rect">
+            <a:avLst/>
+          </a:prstGeom>
+          <a:solidFill>
+            <a:srgbClr val="FDEBDC"/>
+          </a:solidFill>
+          <a:ln/>
+        </p:spPr>
+      </p:sp>
+      <p:sp>
+        <p:nvSpPr>
+          <p:cNvPr id="18" name="Option dot C"/>
+          <p:cNvSpPr/>
+          <p:nvPr/>
+        </p:nvSpPr>
+        <p:spPr>
+          <a:xfrm>
+            <a:off x="8238744" y="3429000"/>
+            <a:ext cx="640080" cy="640080"/>
+          </a:xfrm>
+          <a:prstGeom prst="ellipse">
+            <a:avLst/>
+          </a:prstGeom>
+          <a:solidFill>
+            <a:srgbClr val="A63A0C"/>
+          </a:solidFill>
+          <a:ln/>
+        </p:spPr>
+      </p:sp>
+      <p:sp>
+        <p:nvSpPr>
+          <p:cNvPr id="19" name="Text 15"/>
+          <p:cNvSpPr txBox="1"/>
+          <p:nvPr/>
+        </p:nvSpPr>
+        <p:spPr>
+          <a:xfrm>
+            <a:off x="8238744" y="3429000"/>
+            <a:ext cx="640080" cy="640080"/>
+          </a:xfrm>
+          <a:prstGeom prst="rect">
+            <a:avLst/>
+          </a:prstGeom>
+          <a:noFill/>
+          <a:ln/>
+        </p:spPr>
+        <p:txBody>
+          <a:bodyPr wrap="square" lIns="0" tIns="0" rIns="0" bIns="0" rtlCol="0" anchor="ctr"/>
+          <a:lstStyle/>
+          <a:p>
+            <a:pPr algn="ctr" indent="0" marL="0">
+              <a:buNone/>
+            </a:pPr>
+            <a:r>
+              <a:rPr lang="en-US" sz="2600" dirty="0">
+                <a:solidFill>
+                  <a:srgbClr val="FFFFFF"/>
+                </a:solidFill>
+                <a:latin typeface="Cambria" pitchFamily="34" charset="0"/>
+                <a:ea typeface="Cambria" pitchFamily="34" charset="-122"/>
+                <a:cs typeface="Cambria" pitchFamily="34" charset="-120"/>
+              </a:rPr>
               <a:t>C</a:t>
             </a:r>
             <a:endParaRPr lang="en-US" sz="2600" dirty="0"/>
           </a:p>
         </p:txBody>
       </p:sp>
-      <p:sp>
-        <p:nvSpPr>
-          <p:cNvPr id="16" name="Option text C"/>
+      <p:pic>
+        <p:nvPicPr>
+          <p:cNvPr id="20" name="Option icon C" descr="Cooler">    </p:cNvPr>
+          <p:cNvPicPr>
+            <a:picLocks noChangeAspect="1"/>
+          </p:cNvPicPr>
+          <p:nvPr/>
+        </p:nvPicPr>
+        <p:blipFill>
+          <a:blip r:embed="rId3"/>
+          <a:stretch>
+            <a:fillRect/>
+          </a:stretch>
+        </p:blipFill>
+        <p:spPr>
+          <a:xfrm>
+            <a:off x="10287000" y="3410712"/>
+            <a:ext cx="731520" cy="731520"/>
+          </a:xfrm>
+          <a:prstGeom prst="rect">
+            <a:avLst/>
+          </a:prstGeom>
+        </p:spPr>
+      </p:pic>
+      <p:sp>
+        <p:nvSpPr>
+          <p:cNvPr id="21" name="Option head C"/>
           <p:cNvSpPr txBox="1"/>
           <p:nvPr/>
         </p:nvSpPr>
         <p:spPr>
           <a:xfrm>
-            <a:off x="8305800" y="4480560"/>
-            <a:ext cx="2758440" cy="1097280"/>
+            <a:off x="8238744" y="4251960"/>
+            <a:ext cx="2825496" cy="548640"/>
           </a:xfrm>
           <a:prstGeom prst="rect">
             <a:avLst/>
@@ -7582,21 +7836,76 @@
           <a:ln/>
         </p:spPr>
         <p:txBody>
-          <a:bodyPr wrap="square" lIns="0" tIns="0" rIns="0" bIns="0" rtlCol="0" anchor="t"/>
+          <a:bodyPr wrap="square" lIns="0" tIns="0" rIns="0" bIns="0" rtlCol="0" anchor="ctr"/>
           <a:lstStyle/>
           <a:p>
             <a:pPr indent="0" marL="0">
               <a:buNone/>
             </a:pPr>
             <a:r>
-              <a:rPr lang="en-US" sz="2400" dirty="0">
+              <a:rPr lang="en-US" sz="2600" dirty="0">
                 <a:solidFill>
                   <a:srgbClr val="2E1406"/>
                 </a:solidFill>
-              </a:rPr>
-              <a:t>Cooler: Extreme Caution or lower</a:t>
-            </a:r>
-            <a:endParaRPr lang="en-US" sz="2400" dirty="0"/>
+                <a:latin typeface="Cambria" pitchFamily="34" charset="0"/>
+                <a:ea typeface="Cambria" pitchFamily="34" charset="-122"/>
+                <a:cs typeface="Cambria" pitchFamily="34" charset="-120"/>
+              </a:rPr>
+              <a:t>Cooler</a:t>
+            </a:r>
+            <a:endParaRPr lang="en-US" sz="2600" dirty="0"/>
+          </a:p>
+        </p:txBody>
+      </p:sp>
+      <p:sp>
+        <p:nvSpPr>
+          <p:cNvPr id="22" name="Option level C"/>
+          <p:cNvSpPr txBox="1"/>
+          <p:nvPr/>
+        </p:nvSpPr>
+        <p:spPr>
+          <a:xfrm>
+            <a:off x="8238744" y="4937760"/>
+            <a:ext cx="2825496" cy="777240"/>
+          </a:xfrm>
+          <a:prstGeom prst="rect">
+            <a:avLst/>
+          </a:prstGeom>
+          <a:solidFill>
+            <a:srgbClr val="F28C28"/>
+          </a:solidFill>
+          <a:ln/>
+        </p:spPr>
+        <p:txBody>
+          <a:bodyPr wrap="square" lIns="50800" tIns="50800" rIns="50800" bIns="50800" rtlCol="0" anchor="ctr"/>
+          <a:lstStyle/>
+          <a:p>
+            <a:pPr algn="ctr" indent="0" marL="0">
+              <a:buNone/>
+            </a:pPr>
+            <a:r>
+              <a:rPr lang="en-US" sz="1600" b="1" dirty="0">
+                <a:solidFill>
+                  <a:srgbClr val="2E1406"/>
+                </a:solidFill>
+              </a:rPr>
+              <a:t>Extreme Caution or lower</a:t>
+            </a:r>
+            <a:endParaRPr lang="en-US" sz="1600" dirty="0"/>
+          </a:p>
+          <a:p>
+            <a:pPr algn="ctr" indent="0" marL="0">
+              <a:buNone/>
+            </a:pPr>
+            <a:r>
+              <a:rPr lang="en-US" sz="1600" dirty="0">
+                <a:solidFill>
+                  <a:srgbClr val="2E1406"/>
+                </a:solidFill>
+              </a:rPr>
+              <a:t>below 42 °C</a:t>
+            </a:r>
+            <a:endParaRPr lang="en-US" sz="1600" dirty="0"/>
           </a:p>
         </p:txBody>
       </p:sp>
@@ -7681,8 +7990,8 @@
         </p:nvSpPr>
         <p:spPr>
           <a:xfrm>
-            <a:off x="822960" y="1234440"/>
-            <a:ext cx="10545775" cy="1737360"/>
+            <a:off x="914400" y="1097280"/>
+            <a:ext cx="6035040" cy="1737360"/>
           </a:xfrm>
           <a:prstGeom prst="rect">
             <a:avLst/>
@@ -7691,10 +8000,10 @@
           <a:ln/>
         </p:spPr>
         <p:txBody>
-          <a:bodyPr wrap="square" rtlCol="0" anchor="ctr"/>
-          <a:lstStyle/>
-          <a:p>
-            <a:pPr algn="ctr" indent="0" marL="0">
+          <a:bodyPr wrap="square" lIns="0" tIns="0" rIns="0" bIns="0" rtlCol="0" anchor="ctr"/>
+          <a:lstStyle/>
+          <a:p>
+            <a:pPr algn="l" indent="0" marL="0">
               <a:buNone/>
             </a:pPr>
             <a:r>
@@ -7720,8 +8029,8 @@
         </p:nvSpPr>
         <p:spPr>
           <a:xfrm>
-            <a:off x="1280160" y="3017520"/>
-            <a:ext cx="9631375" cy="822960"/>
+            <a:off x="914400" y="2926080"/>
+            <a:ext cx="5852160" cy="1188720"/>
           </a:xfrm>
           <a:prstGeom prst="rect">
             <a:avLst/>
@@ -7730,10 +8039,10 @@
           <a:ln/>
         </p:spPr>
         <p:txBody>
-          <a:bodyPr wrap="square" rtlCol="0" anchor="ctr"/>
-          <a:lstStyle/>
-          <a:p>
-            <a:pPr algn="ctr" indent="0" marL="0">
+          <a:bodyPr wrap="square" lIns="0" tIns="0" rIns="0" bIns="0" rtlCol="0" anchor="t"/>
+          <a:lstStyle/>
+          <a:p>
+            <a:pPr algn="l" indent="0" marL="0">
               <a:buNone/>
             </a:pPr>
             <a:r>
@@ -7759,8 +8068,8 @@
         </p:nvSpPr>
         <p:spPr>
           <a:xfrm>
-            <a:off x="1828800" y="4160520"/>
-            <a:ext cx="8534095" cy="914400"/>
+            <a:off x="914400" y="4343400"/>
+            <a:ext cx="5669280" cy="1188720"/>
           </a:xfrm>
           <a:prstGeom prst="rect">
             <a:avLst/>
@@ -7769,10 +8078,10 @@
           <a:ln/>
         </p:spPr>
         <p:txBody>
-          <a:bodyPr wrap="square" rtlCol="0" anchor="t"/>
-          <a:lstStyle/>
-          <a:p>
-            <a:pPr algn="ctr" indent="0" marL="0">
+          <a:bodyPr wrap="square" lIns="0" tIns="0" rIns="0" bIns="0" rtlCol="0" anchor="t"/>
+          <a:lstStyle/>
+          <a:p>
+            <a:pPr algn="l" indent="0" marL="0">
               <a:buNone/>
             </a:pPr>
             <a:r>
@@ -7784,6 +8093,2092 @@
               <a:t>So simply copying today's level is already a strong forecast. We call it the copy-today rule, and it is the rule our models had to beat.</a:t>
             </a:r>
             <a:endParaRPr lang="en-US" sz="2000" dirty="0"/>
+          </a:p>
+        </p:txBody>
+      </p:sp>
+      <p:sp>
+        <p:nvSpPr>
+          <p:cNvPr id="5" name="Square 1"/>
+          <p:cNvSpPr/>
+          <p:nvPr/>
+        </p:nvSpPr>
+        <p:spPr>
+          <a:xfrm>
+            <a:off x="7543800" y="1143000"/>
+            <a:ext cx="310896" cy="310896"/>
+          </a:xfrm>
+          <a:prstGeom prst="rect">
+            <a:avLst/>
+          </a:prstGeom>
+          <a:solidFill>
+            <a:srgbClr val="F6C9A0"/>
+          </a:solidFill>
+          <a:ln/>
+        </p:spPr>
+      </p:sp>
+      <p:sp>
+        <p:nvSpPr>
+          <p:cNvPr id="6" name="Square 2"/>
+          <p:cNvSpPr/>
+          <p:nvPr/>
+        </p:nvSpPr>
+        <p:spPr>
+          <a:xfrm>
+            <a:off x="7909560" y="1143000"/>
+            <a:ext cx="310896" cy="310896"/>
+          </a:xfrm>
+          <a:prstGeom prst="rect">
+            <a:avLst/>
+          </a:prstGeom>
+          <a:solidFill>
+            <a:srgbClr val="F6C9A0"/>
+          </a:solidFill>
+          <a:ln/>
+        </p:spPr>
+      </p:sp>
+      <p:sp>
+        <p:nvSpPr>
+          <p:cNvPr id="7" name="Square 3"/>
+          <p:cNvSpPr/>
+          <p:nvPr/>
+        </p:nvSpPr>
+        <p:spPr>
+          <a:xfrm>
+            <a:off x="8275320" y="1143000"/>
+            <a:ext cx="310896" cy="310896"/>
+          </a:xfrm>
+          <a:prstGeom prst="rect">
+            <a:avLst/>
+          </a:prstGeom>
+          <a:solidFill>
+            <a:srgbClr val="F6C9A0"/>
+          </a:solidFill>
+          <a:ln/>
+        </p:spPr>
+      </p:sp>
+      <p:sp>
+        <p:nvSpPr>
+          <p:cNvPr id="8" name="Square 4"/>
+          <p:cNvSpPr/>
+          <p:nvPr/>
+        </p:nvSpPr>
+        <p:spPr>
+          <a:xfrm>
+            <a:off x="8641080" y="1143000"/>
+            <a:ext cx="310896" cy="310896"/>
+          </a:xfrm>
+          <a:prstGeom prst="rect">
+            <a:avLst/>
+          </a:prstGeom>
+          <a:solidFill>
+            <a:srgbClr val="F6C9A0"/>
+          </a:solidFill>
+          <a:ln/>
+        </p:spPr>
+      </p:sp>
+      <p:sp>
+        <p:nvSpPr>
+          <p:cNvPr id="9" name="Square 5"/>
+          <p:cNvSpPr/>
+          <p:nvPr/>
+        </p:nvSpPr>
+        <p:spPr>
+          <a:xfrm>
+            <a:off x="9006840" y="1143000"/>
+            <a:ext cx="310896" cy="310896"/>
+          </a:xfrm>
+          <a:prstGeom prst="rect">
+            <a:avLst/>
+          </a:prstGeom>
+          <a:solidFill>
+            <a:srgbClr val="F6C9A0"/>
+          </a:solidFill>
+          <a:ln/>
+        </p:spPr>
+      </p:sp>
+      <p:sp>
+        <p:nvSpPr>
+          <p:cNvPr id="10" name="Square 6"/>
+          <p:cNvSpPr/>
+          <p:nvPr/>
+        </p:nvSpPr>
+        <p:spPr>
+          <a:xfrm>
+            <a:off x="9372600" y="1143000"/>
+            <a:ext cx="310896" cy="310896"/>
+          </a:xfrm>
+          <a:prstGeom prst="rect">
+            <a:avLst/>
+          </a:prstGeom>
+          <a:solidFill>
+            <a:srgbClr val="F6C9A0"/>
+          </a:solidFill>
+          <a:ln/>
+        </p:spPr>
+      </p:sp>
+      <p:sp>
+        <p:nvSpPr>
+          <p:cNvPr id="11" name="Square 7"/>
+          <p:cNvSpPr/>
+          <p:nvPr/>
+        </p:nvSpPr>
+        <p:spPr>
+          <a:xfrm>
+            <a:off x="9738360" y="1143000"/>
+            <a:ext cx="310896" cy="310896"/>
+          </a:xfrm>
+          <a:prstGeom prst="rect">
+            <a:avLst/>
+          </a:prstGeom>
+          <a:solidFill>
+            <a:srgbClr val="F6C9A0"/>
+          </a:solidFill>
+          <a:ln/>
+        </p:spPr>
+      </p:sp>
+      <p:sp>
+        <p:nvSpPr>
+          <p:cNvPr id="12" name="Square 8"/>
+          <p:cNvSpPr/>
+          <p:nvPr/>
+        </p:nvSpPr>
+        <p:spPr>
+          <a:xfrm>
+            <a:off x="10104120" y="1143000"/>
+            <a:ext cx="310896" cy="310896"/>
+          </a:xfrm>
+          <a:prstGeom prst="rect">
+            <a:avLst/>
+          </a:prstGeom>
+          <a:solidFill>
+            <a:srgbClr val="F6C9A0"/>
+          </a:solidFill>
+          <a:ln/>
+        </p:spPr>
+      </p:sp>
+      <p:sp>
+        <p:nvSpPr>
+          <p:cNvPr id="13" name="Square 9"/>
+          <p:cNvSpPr/>
+          <p:nvPr/>
+        </p:nvSpPr>
+        <p:spPr>
+          <a:xfrm>
+            <a:off x="10469880" y="1143000"/>
+            <a:ext cx="310896" cy="310896"/>
+          </a:xfrm>
+          <a:prstGeom prst="rect">
+            <a:avLst/>
+          </a:prstGeom>
+          <a:solidFill>
+            <a:srgbClr val="F6C9A0"/>
+          </a:solidFill>
+          <a:ln/>
+        </p:spPr>
+      </p:sp>
+      <p:sp>
+        <p:nvSpPr>
+          <p:cNvPr id="14" name="Square 10"/>
+          <p:cNvSpPr/>
+          <p:nvPr/>
+        </p:nvSpPr>
+        <p:spPr>
+          <a:xfrm>
+            <a:off x="10835640" y="1143000"/>
+            <a:ext cx="310896" cy="310896"/>
+          </a:xfrm>
+          <a:prstGeom prst="rect">
+            <a:avLst/>
+          </a:prstGeom>
+          <a:solidFill>
+            <a:srgbClr val="F6C9A0"/>
+          </a:solidFill>
+          <a:ln/>
+        </p:spPr>
+      </p:sp>
+      <p:sp>
+        <p:nvSpPr>
+          <p:cNvPr id="15" name="Square 11"/>
+          <p:cNvSpPr/>
+          <p:nvPr/>
+        </p:nvSpPr>
+        <p:spPr>
+          <a:xfrm>
+            <a:off x="7543800" y="1508760"/>
+            <a:ext cx="310896" cy="310896"/>
+          </a:xfrm>
+          <a:prstGeom prst="rect">
+            <a:avLst/>
+          </a:prstGeom>
+          <a:solidFill>
+            <a:srgbClr val="F6C9A0"/>
+          </a:solidFill>
+          <a:ln/>
+        </p:spPr>
+      </p:sp>
+      <p:sp>
+        <p:nvSpPr>
+          <p:cNvPr id="16" name="Square 12"/>
+          <p:cNvSpPr/>
+          <p:nvPr/>
+        </p:nvSpPr>
+        <p:spPr>
+          <a:xfrm>
+            <a:off x="7909560" y="1508760"/>
+            <a:ext cx="310896" cy="310896"/>
+          </a:xfrm>
+          <a:prstGeom prst="rect">
+            <a:avLst/>
+          </a:prstGeom>
+          <a:solidFill>
+            <a:srgbClr val="F6C9A0"/>
+          </a:solidFill>
+          <a:ln/>
+        </p:spPr>
+      </p:sp>
+      <p:sp>
+        <p:nvSpPr>
+          <p:cNvPr id="17" name="Square 13"/>
+          <p:cNvSpPr/>
+          <p:nvPr/>
+        </p:nvSpPr>
+        <p:spPr>
+          <a:xfrm>
+            <a:off x="8275320" y="1508760"/>
+            <a:ext cx="310896" cy="310896"/>
+          </a:xfrm>
+          <a:prstGeom prst="rect">
+            <a:avLst/>
+          </a:prstGeom>
+          <a:solidFill>
+            <a:srgbClr val="F6C9A0"/>
+          </a:solidFill>
+          <a:ln/>
+        </p:spPr>
+      </p:sp>
+      <p:sp>
+        <p:nvSpPr>
+          <p:cNvPr id="18" name="Square 14"/>
+          <p:cNvSpPr/>
+          <p:nvPr/>
+        </p:nvSpPr>
+        <p:spPr>
+          <a:xfrm>
+            <a:off x="8641080" y="1508760"/>
+            <a:ext cx="310896" cy="310896"/>
+          </a:xfrm>
+          <a:prstGeom prst="rect">
+            <a:avLst/>
+          </a:prstGeom>
+          <a:solidFill>
+            <a:srgbClr val="F6C9A0"/>
+          </a:solidFill>
+          <a:ln/>
+        </p:spPr>
+      </p:sp>
+      <p:sp>
+        <p:nvSpPr>
+          <p:cNvPr id="19" name="Square 15"/>
+          <p:cNvSpPr/>
+          <p:nvPr/>
+        </p:nvSpPr>
+        <p:spPr>
+          <a:xfrm>
+            <a:off x="9006840" y="1508760"/>
+            <a:ext cx="310896" cy="310896"/>
+          </a:xfrm>
+          <a:prstGeom prst="rect">
+            <a:avLst/>
+          </a:prstGeom>
+          <a:solidFill>
+            <a:srgbClr val="F6C9A0"/>
+          </a:solidFill>
+          <a:ln/>
+        </p:spPr>
+      </p:sp>
+      <p:sp>
+        <p:nvSpPr>
+          <p:cNvPr id="20" name="Square 16"/>
+          <p:cNvSpPr/>
+          <p:nvPr/>
+        </p:nvSpPr>
+        <p:spPr>
+          <a:xfrm>
+            <a:off x="9372600" y="1508760"/>
+            <a:ext cx="310896" cy="310896"/>
+          </a:xfrm>
+          <a:prstGeom prst="rect">
+            <a:avLst/>
+          </a:prstGeom>
+          <a:solidFill>
+            <a:srgbClr val="F6C9A0"/>
+          </a:solidFill>
+          <a:ln/>
+        </p:spPr>
+      </p:sp>
+      <p:sp>
+        <p:nvSpPr>
+          <p:cNvPr id="21" name="Square 17"/>
+          <p:cNvSpPr/>
+          <p:nvPr/>
+        </p:nvSpPr>
+        <p:spPr>
+          <a:xfrm>
+            <a:off x="9738360" y="1508760"/>
+            <a:ext cx="310896" cy="310896"/>
+          </a:xfrm>
+          <a:prstGeom prst="rect">
+            <a:avLst/>
+          </a:prstGeom>
+          <a:solidFill>
+            <a:srgbClr val="F6C9A0"/>
+          </a:solidFill>
+          <a:ln/>
+        </p:spPr>
+      </p:sp>
+      <p:sp>
+        <p:nvSpPr>
+          <p:cNvPr id="22" name="Square 18"/>
+          <p:cNvSpPr/>
+          <p:nvPr/>
+        </p:nvSpPr>
+        <p:spPr>
+          <a:xfrm>
+            <a:off x="10104120" y="1508760"/>
+            <a:ext cx="310896" cy="310896"/>
+          </a:xfrm>
+          <a:prstGeom prst="rect">
+            <a:avLst/>
+          </a:prstGeom>
+          <a:solidFill>
+            <a:srgbClr val="F6C9A0"/>
+          </a:solidFill>
+          <a:ln/>
+        </p:spPr>
+      </p:sp>
+      <p:sp>
+        <p:nvSpPr>
+          <p:cNvPr id="23" name="Square 19"/>
+          <p:cNvSpPr/>
+          <p:nvPr/>
+        </p:nvSpPr>
+        <p:spPr>
+          <a:xfrm>
+            <a:off x="10469880" y="1508760"/>
+            <a:ext cx="310896" cy="310896"/>
+          </a:xfrm>
+          <a:prstGeom prst="rect">
+            <a:avLst/>
+          </a:prstGeom>
+          <a:solidFill>
+            <a:srgbClr val="F6C9A0"/>
+          </a:solidFill>
+          <a:ln/>
+        </p:spPr>
+      </p:sp>
+      <p:sp>
+        <p:nvSpPr>
+          <p:cNvPr id="24" name="Square 20"/>
+          <p:cNvSpPr/>
+          <p:nvPr/>
+        </p:nvSpPr>
+        <p:spPr>
+          <a:xfrm>
+            <a:off x="10835640" y="1508760"/>
+            <a:ext cx="310896" cy="310896"/>
+          </a:xfrm>
+          <a:prstGeom prst="rect">
+            <a:avLst/>
+          </a:prstGeom>
+          <a:solidFill>
+            <a:srgbClr val="F6C9A0"/>
+          </a:solidFill>
+          <a:ln/>
+        </p:spPr>
+      </p:sp>
+      <p:sp>
+        <p:nvSpPr>
+          <p:cNvPr id="25" name="Square 21"/>
+          <p:cNvSpPr/>
+          <p:nvPr/>
+        </p:nvSpPr>
+        <p:spPr>
+          <a:xfrm>
+            <a:off x="7543800" y="1874520"/>
+            <a:ext cx="310896" cy="310896"/>
+          </a:xfrm>
+          <a:prstGeom prst="rect">
+            <a:avLst/>
+          </a:prstGeom>
+          <a:solidFill>
+            <a:srgbClr val="F6C9A0"/>
+          </a:solidFill>
+          <a:ln/>
+        </p:spPr>
+      </p:sp>
+      <p:sp>
+        <p:nvSpPr>
+          <p:cNvPr id="26" name="Square 22"/>
+          <p:cNvSpPr/>
+          <p:nvPr/>
+        </p:nvSpPr>
+        <p:spPr>
+          <a:xfrm>
+            <a:off x="7909560" y="1874520"/>
+            <a:ext cx="310896" cy="310896"/>
+          </a:xfrm>
+          <a:prstGeom prst="rect">
+            <a:avLst/>
+          </a:prstGeom>
+          <a:solidFill>
+            <a:srgbClr val="F6C9A0"/>
+          </a:solidFill>
+          <a:ln/>
+        </p:spPr>
+      </p:sp>
+      <p:sp>
+        <p:nvSpPr>
+          <p:cNvPr id="27" name="Square 23"/>
+          <p:cNvSpPr/>
+          <p:nvPr/>
+        </p:nvSpPr>
+        <p:spPr>
+          <a:xfrm>
+            <a:off x="8275320" y="1874520"/>
+            <a:ext cx="310896" cy="310896"/>
+          </a:xfrm>
+          <a:prstGeom prst="rect">
+            <a:avLst/>
+          </a:prstGeom>
+          <a:solidFill>
+            <a:srgbClr val="F6C9A0"/>
+          </a:solidFill>
+          <a:ln/>
+        </p:spPr>
+      </p:sp>
+      <p:sp>
+        <p:nvSpPr>
+          <p:cNvPr id="28" name="Square 24"/>
+          <p:cNvSpPr/>
+          <p:nvPr/>
+        </p:nvSpPr>
+        <p:spPr>
+          <a:xfrm>
+            <a:off x="8641080" y="1874520"/>
+            <a:ext cx="310896" cy="310896"/>
+          </a:xfrm>
+          <a:prstGeom prst="rect">
+            <a:avLst/>
+          </a:prstGeom>
+          <a:solidFill>
+            <a:srgbClr val="F6C9A0"/>
+          </a:solidFill>
+          <a:ln/>
+        </p:spPr>
+      </p:sp>
+      <p:sp>
+        <p:nvSpPr>
+          <p:cNvPr id="29" name="Square 25"/>
+          <p:cNvSpPr/>
+          <p:nvPr/>
+        </p:nvSpPr>
+        <p:spPr>
+          <a:xfrm>
+            <a:off x="9006840" y="1874520"/>
+            <a:ext cx="310896" cy="310896"/>
+          </a:xfrm>
+          <a:prstGeom prst="rect">
+            <a:avLst/>
+          </a:prstGeom>
+          <a:solidFill>
+            <a:srgbClr val="F6C9A0"/>
+          </a:solidFill>
+          <a:ln/>
+        </p:spPr>
+      </p:sp>
+      <p:sp>
+        <p:nvSpPr>
+          <p:cNvPr id="30" name="Square 26"/>
+          <p:cNvSpPr/>
+          <p:nvPr/>
+        </p:nvSpPr>
+        <p:spPr>
+          <a:xfrm>
+            <a:off x="9372600" y="1874520"/>
+            <a:ext cx="310896" cy="310896"/>
+          </a:xfrm>
+          <a:prstGeom prst="rect">
+            <a:avLst/>
+          </a:prstGeom>
+          <a:solidFill>
+            <a:srgbClr val="F6C9A0"/>
+          </a:solidFill>
+          <a:ln/>
+        </p:spPr>
+      </p:sp>
+      <p:sp>
+        <p:nvSpPr>
+          <p:cNvPr id="31" name="Square 27"/>
+          <p:cNvSpPr/>
+          <p:nvPr/>
+        </p:nvSpPr>
+        <p:spPr>
+          <a:xfrm>
+            <a:off x="9738360" y="1874520"/>
+            <a:ext cx="310896" cy="310896"/>
+          </a:xfrm>
+          <a:prstGeom prst="rect">
+            <a:avLst/>
+          </a:prstGeom>
+          <a:solidFill>
+            <a:srgbClr val="F6C9A0"/>
+          </a:solidFill>
+          <a:ln/>
+        </p:spPr>
+      </p:sp>
+      <p:sp>
+        <p:nvSpPr>
+          <p:cNvPr id="32" name="Square 28"/>
+          <p:cNvSpPr/>
+          <p:nvPr/>
+        </p:nvSpPr>
+        <p:spPr>
+          <a:xfrm>
+            <a:off x="10104120" y="1874520"/>
+            <a:ext cx="310896" cy="310896"/>
+          </a:xfrm>
+          <a:prstGeom prst="rect">
+            <a:avLst/>
+          </a:prstGeom>
+          <a:solidFill>
+            <a:srgbClr val="F6C9A0"/>
+          </a:solidFill>
+          <a:ln/>
+        </p:spPr>
+      </p:sp>
+      <p:sp>
+        <p:nvSpPr>
+          <p:cNvPr id="33" name="Square 29"/>
+          <p:cNvSpPr/>
+          <p:nvPr/>
+        </p:nvSpPr>
+        <p:spPr>
+          <a:xfrm>
+            <a:off x="10469880" y="1874520"/>
+            <a:ext cx="310896" cy="310896"/>
+          </a:xfrm>
+          <a:prstGeom prst="rect">
+            <a:avLst/>
+          </a:prstGeom>
+          <a:solidFill>
+            <a:srgbClr val="F6C9A0"/>
+          </a:solidFill>
+          <a:ln/>
+        </p:spPr>
+      </p:sp>
+      <p:sp>
+        <p:nvSpPr>
+          <p:cNvPr id="34" name="Square 30"/>
+          <p:cNvSpPr/>
+          <p:nvPr/>
+        </p:nvSpPr>
+        <p:spPr>
+          <a:xfrm>
+            <a:off x="10835640" y="1874520"/>
+            <a:ext cx="310896" cy="310896"/>
+          </a:xfrm>
+          <a:prstGeom prst="rect">
+            <a:avLst/>
+          </a:prstGeom>
+          <a:solidFill>
+            <a:srgbClr val="F6C9A0"/>
+          </a:solidFill>
+          <a:ln/>
+        </p:spPr>
+      </p:sp>
+      <p:sp>
+        <p:nvSpPr>
+          <p:cNvPr id="35" name="Square 31"/>
+          <p:cNvSpPr/>
+          <p:nvPr/>
+        </p:nvSpPr>
+        <p:spPr>
+          <a:xfrm>
+            <a:off x="7543800" y="2240280"/>
+            <a:ext cx="310896" cy="310896"/>
+          </a:xfrm>
+          <a:prstGeom prst="rect">
+            <a:avLst/>
+          </a:prstGeom>
+          <a:solidFill>
+            <a:srgbClr val="F6C9A0"/>
+          </a:solidFill>
+          <a:ln/>
+        </p:spPr>
+      </p:sp>
+      <p:sp>
+        <p:nvSpPr>
+          <p:cNvPr id="36" name="Square 32"/>
+          <p:cNvSpPr/>
+          <p:nvPr/>
+        </p:nvSpPr>
+        <p:spPr>
+          <a:xfrm>
+            <a:off x="7909560" y="2240280"/>
+            <a:ext cx="310896" cy="310896"/>
+          </a:xfrm>
+          <a:prstGeom prst="rect">
+            <a:avLst/>
+          </a:prstGeom>
+          <a:solidFill>
+            <a:srgbClr val="F6C9A0"/>
+          </a:solidFill>
+          <a:ln/>
+        </p:spPr>
+      </p:sp>
+      <p:sp>
+        <p:nvSpPr>
+          <p:cNvPr id="37" name="Square 33"/>
+          <p:cNvSpPr/>
+          <p:nvPr/>
+        </p:nvSpPr>
+        <p:spPr>
+          <a:xfrm>
+            <a:off x="8275320" y="2240280"/>
+            <a:ext cx="310896" cy="310896"/>
+          </a:xfrm>
+          <a:prstGeom prst="rect">
+            <a:avLst/>
+          </a:prstGeom>
+          <a:solidFill>
+            <a:srgbClr val="F6C9A0"/>
+          </a:solidFill>
+          <a:ln/>
+        </p:spPr>
+      </p:sp>
+      <p:sp>
+        <p:nvSpPr>
+          <p:cNvPr id="38" name="Square 34"/>
+          <p:cNvSpPr/>
+          <p:nvPr/>
+        </p:nvSpPr>
+        <p:spPr>
+          <a:xfrm>
+            <a:off x="8641080" y="2240280"/>
+            <a:ext cx="310896" cy="310896"/>
+          </a:xfrm>
+          <a:prstGeom prst="rect">
+            <a:avLst/>
+          </a:prstGeom>
+          <a:solidFill>
+            <a:srgbClr val="F6C9A0"/>
+          </a:solidFill>
+          <a:ln/>
+        </p:spPr>
+      </p:sp>
+      <p:sp>
+        <p:nvSpPr>
+          <p:cNvPr id="39" name="Square 35"/>
+          <p:cNvSpPr/>
+          <p:nvPr/>
+        </p:nvSpPr>
+        <p:spPr>
+          <a:xfrm>
+            <a:off x="9006840" y="2240280"/>
+            <a:ext cx="310896" cy="310896"/>
+          </a:xfrm>
+          <a:prstGeom prst="rect">
+            <a:avLst/>
+          </a:prstGeom>
+          <a:solidFill>
+            <a:srgbClr val="F6C9A0"/>
+          </a:solidFill>
+          <a:ln/>
+        </p:spPr>
+      </p:sp>
+      <p:sp>
+        <p:nvSpPr>
+          <p:cNvPr id="40" name="Square 36"/>
+          <p:cNvSpPr/>
+          <p:nvPr/>
+        </p:nvSpPr>
+        <p:spPr>
+          <a:xfrm>
+            <a:off x="9372600" y="2240280"/>
+            <a:ext cx="310896" cy="310896"/>
+          </a:xfrm>
+          <a:prstGeom prst="rect">
+            <a:avLst/>
+          </a:prstGeom>
+          <a:solidFill>
+            <a:srgbClr val="F6C9A0"/>
+          </a:solidFill>
+          <a:ln/>
+        </p:spPr>
+      </p:sp>
+      <p:sp>
+        <p:nvSpPr>
+          <p:cNvPr id="41" name="Square 37"/>
+          <p:cNvSpPr/>
+          <p:nvPr/>
+        </p:nvSpPr>
+        <p:spPr>
+          <a:xfrm>
+            <a:off x="9738360" y="2240280"/>
+            <a:ext cx="310896" cy="310896"/>
+          </a:xfrm>
+          <a:prstGeom prst="rect">
+            <a:avLst/>
+          </a:prstGeom>
+          <a:solidFill>
+            <a:srgbClr val="F6C9A0"/>
+          </a:solidFill>
+          <a:ln/>
+        </p:spPr>
+      </p:sp>
+      <p:sp>
+        <p:nvSpPr>
+          <p:cNvPr id="42" name="Square 38"/>
+          <p:cNvSpPr/>
+          <p:nvPr/>
+        </p:nvSpPr>
+        <p:spPr>
+          <a:xfrm>
+            <a:off x="10104120" y="2240280"/>
+            <a:ext cx="310896" cy="310896"/>
+          </a:xfrm>
+          <a:prstGeom prst="rect">
+            <a:avLst/>
+          </a:prstGeom>
+          <a:solidFill>
+            <a:srgbClr val="F6C9A0"/>
+          </a:solidFill>
+          <a:ln/>
+        </p:spPr>
+      </p:sp>
+      <p:sp>
+        <p:nvSpPr>
+          <p:cNvPr id="43" name="Square 39"/>
+          <p:cNvSpPr/>
+          <p:nvPr/>
+        </p:nvSpPr>
+        <p:spPr>
+          <a:xfrm>
+            <a:off x="10469880" y="2240280"/>
+            <a:ext cx="310896" cy="310896"/>
+          </a:xfrm>
+          <a:prstGeom prst="rect">
+            <a:avLst/>
+          </a:prstGeom>
+          <a:solidFill>
+            <a:srgbClr val="F6C9A0"/>
+          </a:solidFill>
+          <a:ln/>
+        </p:spPr>
+      </p:sp>
+      <p:sp>
+        <p:nvSpPr>
+          <p:cNvPr id="44" name="Square 40"/>
+          <p:cNvSpPr/>
+          <p:nvPr/>
+        </p:nvSpPr>
+        <p:spPr>
+          <a:xfrm>
+            <a:off x="10835640" y="2240280"/>
+            <a:ext cx="310896" cy="310896"/>
+          </a:xfrm>
+          <a:prstGeom prst="rect">
+            <a:avLst/>
+          </a:prstGeom>
+          <a:solidFill>
+            <a:srgbClr val="F6C9A0"/>
+          </a:solidFill>
+          <a:ln/>
+        </p:spPr>
+      </p:sp>
+      <p:sp>
+        <p:nvSpPr>
+          <p:cNvPr id="45" name="Square 41"/>
+          <p:cNvSpPr/>
+          <p:nvPr/>
+        </p:nvSpPr>
+        <p:spPr>
+          <a:xfrm>
+            <a:off x="7543800" y="2606040"/>
+            <a:ext cx="310896" cy="310896"/>
+          </a:xfrm>
+          <a:prstGeom prst="rect">
+            <a:avLst/>
+          </a:prstGeom>
+          <a:solidFill>
+            <a:srgbClr val="F6C9A0"/>
+          </a:solidFill>
+          <a:ln/>
+        </p:spPr>
+      </p:sp>
+      <p:sp>
+        <p:nvSpPr>
+          <p:cNvPr id="46" name="Square 42"/>
+          <p:cNvSpPr/>
+          <p:nvPr/>
+        </p:nvSpPr>
+        <p:spPr>
+          <a:xfrm>
+            <a:off x="7909560" y="2606040"/>
+            <a:ext cx="310896" cy="310896"/>
+          </a:xfrm>
+          <a:prstGeom prst="rect">
+            <a:avLst/>
+          </a:prstGeom>
+          <a:solidFill>
+            <a:srgbClr val="F6C9A0"/>
+          </a:solidFill>
+          <a:ln/>
+        </p:spPr>
+      </p:sp>
+      <p:sp>
+        <p:nvSpPr>
+          <p:cNvPr id="47" name="Square 43"/>
+          <p:cNvSpPr/>
+          <p:nvPr/>
+        </p:nvSpPr>
+        <p:spPr>
+          <a:xfrm>
+            <a:off x="8275320" y="2606040"/>
+            <a:ext cx="310896" cy="310896"/>
+          </a:xfrm>
+          <a:prstGeom prst="rect">
+            <a:avLst/>
+          </a:prstGeom>
+          <a:solidFill>
+            <a:srgbClr val="F6C9A0"/>
+          </a:solidFill>
+          <a:ln/>
+        </p:spPr>
+      </p:sp>
+      <p:sp>
+        <p:nvSpPr>
+          <p:cNvPr id="48" name="Square 44"/>
+          <p:cNvSpPr/>
+          <p:nvPr/>
+        </p:nvSpPr>
+        <p:spPr>
+          <a:xfrm>
+            <a:off x="8641080" y="2606040"/>
+            <a:ext cx="310896" cy="310896"/>
+          </a:xfrm>
+          <a:prstGeom prst="rect">
+            <a:avLst/>
+          </a:prstGeom>
+          <a:solidFill>
+            <a:srgbClr val="F6C9A0"/>
+          </a:solidFill>
+          <a:ln/>
+        </p:spPr>
+      </p:sp>
+      <p:sp>
+        <p:nvSpPr>
+          <p:cNvPr id="49" name="Square 45"/>
+          <p:cNvSpPr/>
+          <p:nvPr/>
+        </p:nvSpPr>
+        <p:spPr>
+          <a:xfrm>
+            <a:off x="9006840" y="2606040"/>
+            <a:ext cx="310896" cy="310896"/>
+          </a:xfrm>
+          <a:prstGeom prst="rect">
+            <a:avLst/>
+          </a:prstGeom>
+          <a:solidFill>
+            <a:srgbClr val="F6C9A0"/>
+          </a:solidFill>
+          <a:ln/>
+        </p:spPr>
+      </p:sp>
+      <p:sp>
+        <p:nvSpPr>
+          <p:cNvPr id="50" name="Square 46"/>
+          <p:cNvSpPr/>
+          <p:nvPr/>
+        </p:nvSpPr>
+        <p:spPr>
+          <a:xfrm>
+            <a:off x="9372600" y="2606040"/>
+            <a:ext cx="310896" cy="310896"/>
+          </a:xfrm>
+          <a:prstGeom prst="rect">
+            <a:avLst/>
+          </a:prstGeom>
+          <a:solidFill>
+            <a:srgbClr val="F6C9A0"/>
+          </a:solidFill>
+          <a:ln/>
+        </p:spPr>
+      </p:sp>
+      <p:sp>
+        <p:nvSpPr>
+          <p:cNvPr id="51" name="Square 47"/>
+          <p:cNvSpPr/>
+          <p:nvPr/>
+        </p:nvSpPr>
+        <p:spPr>
+          <a:xfrm>
+            <a:off x="9738360" y="2606040"/>
+            <a:ext cx="310896" cy="310896"/>
+          </a:xfrm>
+          <a:prstGeom prst="rect">
+            <a:avLst/>
+          </a:prstGeom>
+          <a:solidFill>
+            <a:srgbClr val="F6C9A0"/>
+          </a:solidFill>
+          <a:ln/>
+        </p:spPr>
+      </p:sp>
+      <p:sp>
+        <p:nvSpPr>
+          <p:cNvPr id="52" name="Square 48"/>
+          <p:cNvSpPr/>
+          <p:nvPr/>
+        </p:nvSpPr>
+        <p:spPr>
+          <a:xfrm>
+            <a:off x="10104120" y="2606040"/>
+            <a:ext cx="310896" cy="310896"/>
+          </a:xfrm>
+          <a:prstGeom prst="rect">
+            <a:avLst/>
+          </a:prstGeom>
+          <a:solidFill>
+            <a:srgbClr val="F6C9A0"/>
+          </a:solidFill>
+          <a:ln/>
+        </p:spPr>
+      </p:sp>
+      <p:sp>
+        <p:nvSpPr>
+          <p:cNvPr id="53" name="Square 49"/>
+          <p:cNvSpPr/>
+          <p:nvPr/>
+        </p:nvSpPr>
+        <p:spPr>
+          <a:xfrm>
+            <a:off x="10469880" y="2606040"/>
+            <a:ext cx="310896" cy="310896"/>
+          </a:xfrm>
+          <a:prstGeom prst="rect">
+            <a:avLst/>
+          </a:prstGeom>
+          <a:solidFill>
+            <a:srgbClr val="F6C9A0"/>
+          </a:solidFill>
+          <a:ln/>
+        </p:spPr>
+      </p:sp>
+      <p:sp>
+        <p:nvSpPr>
+          <p:cNvPr id="54" name="Square 50"/>
+          <p:cNvSpPr/>
+          <p:nvPr/>
+        </p:nvSpPr>
+        <p:spPr>
+          <a:xfrm>
+            <a:off x="10835640" y="2606040"/>
+            <a:ext cx="310896" cy="310896"/>
+          </a:xfrm>
+          <a:prstGeom prst="rect">
+            <a:avLst/>
+          </a:prstGeom>
+          <a:solidFill>
+            <a:srgbClr val="F6C9A0"/>
+          </a:solidFill>
+          <a:ln/>
+        </p:spPr>
+      </p:sp>
+      <p:sp>
+        <p:nvSpPr>
+          <p:cNvPr id="55" name="Square 51"/>
+          <p:cNvSpPr/>
+          <p:nvPr/>
+        </p:nvSpPr>
+        <p:spPr>
+          <a:xfrm>
+            <a:off x="7543800" y="2971800"/>
+            <a:ext cx="310896" cy="310896"/>
+          </a:xfrm>
+          <a:prstGeom prst="rect">
+            <a:avLst/>
+          </a:prstGeom>
+          <a:solidFill>
+            <a:srgbClr val="F6C9A0"/>
+          </a:solidFill>
+          <a:ln/>
+        </p:spPr>
+      </p:sp>
+      <p:sp>
+        <p:nvSpPr>
+          <p:cNvPr id="56" name="Square 52"/>
+          <p:cNvSpPr/>
+          <p:nvPr/>
+        </p:nvSpPr>
+        <p:spPr>
+          <a:xfrm>
+            <a:off x="7909560" y="2971800"/>
+            <a:ext cx="310896" cy="310896"/>
+          </a:xfrm>
+          <a:prstGeom prst="rect">
+            <a:avLst/>
+          </a:prstGeom>
+          <a:solidFill>
+            <a:srgbClr val="F6C9A0"/>
+          </a:solidFill>
+          <a:ln/>
+        </p:spPr>
+      </p:sp>
+      <p:sp>
+        <p:nvSpPr>
+          <p:cNvPr id="57" name="Square 53"/>
+          <p:cNvSpPr/>
+          <p:nvPr/>
+        </p:nvSpPr>
+        <p:spPr>
+          <a:xfrm>
+            <a:off x="8275320" y="2971800"/>
+            <a:ext cx="310896" cy="310896"/>
+          </a:xfrm>
+          <a:prstGeom prst="rect">
+            <a:avLst/>
+          </a:prstGeom>
+          <a:solidFill>
+            <a:srgbClr val="F6C9A0"/>
+          </a:solidFill>
+          <a:ln/>
+        </p:spPr>
+      </p:sp>
+      <p:sp>
+        <p:nvSpPr>
+          <p:cNvPr id="58" name="Square 54"/>
+          <p:cNvSpPr/>
+          <p:nvPr/>
+        </p:nvSpPr>
+        <p:spPr>
+          <a:xfrm>
+            <a:off x="8641080" y="2971800"/>
+            <a:ext cx="310896" cy="310896"/>
+          </a:xfrm>
+          <a:prstGeom prst="rect">
+            <a:avLst/>
+          </a:prstGeom>
+          <a:solidFill>
+            <a:srgbClr val="F6C9A0"/>
+          </a:solidFill>
+          <a:ln/>
+        </p:spPr>
+      </p:sp>
+      <p:sp>
+        <p:nvSpPr>
+          <p:cNvPr id="59" name="Square 55"/>
+          <p:cNvSpPr/>
+          <p:nvPr/>
+        </p:nvSpPr>
+        <p:spPr>
+          <a:xfrm>
+            <a:off x="9006840" y="2971800"/>
+            <a:ext cx="310896" cy="310896"/>
+          </a:xfrm>
+          <a:prstGeom prst="rect">
+            <a:avLst/>
+          </a:prstGeom>
+          <a:solidFill>
+            <a:srgbClr val="F6C9A0"/>
+          </a:solidFill>
+          <a:ln/>
+        </p:spPr>
+      </p:sp>
+      <p:sp>
+        <p:nvSpPr>
+          <p:cNvPr id="60" name="Square 56"/>
+          <p:cNvSpPr/>
+          <p:nvPr/>
+        </p:nvSpPr>
+        <p:spPr>
+          <a:xfrm>
+            <a:off x="9372600" y="2971800"/>
+            <a:ext cx="310896" cy="310896"/>
+          </a:xfrm>
+          <a:prstGeom prst="rect">
+            <a:avLst/>
+          </a:prstGeom>
+          <a:solidFill>
+            <a:srgbClr val="F6C9A0"/>
+          </a:solidFill>
+          <a:ln/>
+        </p:spPr>
+      </p:sp>
+      <p:sp>
+        <p:nvSpPr>
+          <p:cNvPr id="61" name="Square 57"/>
+          <p:cNvSpPr/>
+          <p:nvPr/>
+        </p:nvSpPr>
+        <p:spPr>
+          <a:xfrm>
+            <a:off x="9738360" y="2971800"/>
+            <a:ext cx="310896" cy="310896"/>
+          </a:xfrm>
+          <a:prstGeom prst="rect">
+            <a:avLst/>
+          </a:prstGeom>
+          <a:solidFill>
+            <a:srgbClr val="F6C9A0"/>
+          </a:solidFill>
+          <a:ln/>
+        </p:spPr>
+      </p:sp>
+      <p:sp>
+        <p:nvSpPr>
+          <p:cNvPr id="62" name="Square 58"/>
+          <p:cNvSpPr/>
+          <p:nvPr/>
+        </p:nvSpPr>
+        <p:spPr>
+          <a:xfrm>
+            <a:off x="10104120" y="2971800"/>
+            <a:ext cx="310896" cy="310896"/>
+          </a:xfrm>
+          <a:prstGeom prst="rect">
+            <a:avLst/>
+          </a:prstGeom>
+          <a:solidFill>
+            <a:srgbClr val="F6C9A0"/>
+          </a:solidFill>
+          <a:ln/>
+        </p:spPr>
+      </p:sp>
+      <p:sp>
+        <p:nvSpPr>
+          <p:cNvPr id="63" name="Square 59"/>
+          <p:cNvSpPr/>
+          <p:nvPr/>
+        </p:nvSpPr>
+        <p:spPr>
+          <a:xfrm>
+            <a:off x="10469880" y="2971800"/>
+            <a:ext cx="310896" cy="310896"/>
+          </a:xfrm>
+          <a:prstGeom prst="rect">
+            <a:avLst/>
+          </a:prstGeom>
+          <a:solidFill>
+            <a:srgbClr val="F6C9A0"/>
+          </a:solidFill>
+          <a:ln/>
+        </p:spPr>
+      </p:sp>
+      <p:sp>
+        <p:nvSpPr>
+          <p:cNvPr id="64" name="Square 60"/>
+          <p:cNvSpPr/>
+          <p:nvPr/>
+        </p:nvSpPr>
+        <p:spPr>
+          <a:xfrm>
+            <a:off x="10835640" y="2971800"/>
+            <a:ext cx="310896" cy="310896"/>
+          </a:xfrm>
+          <a:prstGeom prst="rect">
+            <a:avLst/>
+          </a:prstGeom>
+          <a:solidFill>
+            <a:srgbClr val="F6C9A0"/>
+          </a:solidFill>
+          <a:ln/>
+        </p:spPr>
+      </p:sp>
+      <p:sp>
+        <p:nvSpPr>
+          <p:cNvPr id="65" name="Square 61"/>
+          <p:cNvSpPr/>
+          <p:nvPr/>
+        </p:nvSpPr>
+        <p:spPr>
+          <a:xfrm>
+            <a:off x="7543800" y="3337560"/>
+            <a:ext cx="310896" cy="310896"/>
+          </a:xfrm>
+          <a:prstGeom prst="rect">
+            <a:avLst/>
+          </a:prstGeom>
+          <a:solidFill>
+            <a:srgbClr val="F6C9A0"/>
+          </a:solidFill>
+          <a:ln/>
+        </p:spPr>
+      </p:sp>
+      <p:sp>
+        <p:nvSpPr>
+          <p:cNvPr id="66" name="Square 62"/>
+          <p:cNvSpPr/>
+          <p:nvPr/>
+        </p:nvSpPr>
+        <p:spPr>
+          <a:xfrm>
+            <a:off x="7909560" y="3337560"/>
+            <a:ext cx="310896" cy="310896"/>
+          </a:xfrm>
+          <a:prstGeom prst="rect">
+            <a:avLst/>
+          </a:prstGeom>
+          <a:solidFill>
+            <a:srgbClr val="F6C9A0"/>
+          </a:solidFill>
+          <a:ln/>
+        </p:spPr>
+      </p:sp>
+      <p:sp>
+        <p:nvSpPr>
+          <p:cNvPr id="67" name="Square 63"/>
+          <p:cNvSpPr/>
+          <p:nvPr/>
+        </p:nvSpPr>
+        <p:spPr>
+          <a:xfrm>
+            <a:off x="8275320" y="3337560"/>
+            <a:ext cx="310896" cy="310896"/>
+          </a:xfrm>
+          <a:prstGeom prst="rect">
+            <a:avLst/>
+          </a:prstGeom>
+          <a:solidFill>
+            <a:srgbClr val="F6C9A0"/>
+          </a:solidFill>
+          <a:ln/>
+        </p:spPr>
+      </p:sp>
+      <p:sp>
+        <p:nvSpPr>
+          <p:cNvPr id="68" name="Square 64"/>
+          <p:cNvSpPr/>
+          <p:nvPr/>
+        </p:nvSpPr>
+        <p:spPr>
+          <a:xfrm>
+            <a:off x="8641080" y="3337560"/>
+            <a:ext cx="310896" cy="310896"/>
+          </a:xfrm>
+          <a:prstGeom prst="rect">
+            <a:avLst/>
+          </a:prstGeom>
+          <a:solidFill>
+            <a:srgbClr val="F6C9A0"/>
+          </a:solidFill>
+          <a:ln/>
+        </p:spPr>
+      </p:sp>
+      <p:sp>
+        <p:nvSpPr>
+          <p:cNvPr id="69" name="Square 65"/>
+          <p:cNvSpPr/>
+          <p:nvPr/>
+        </p:nvSpPr>
+        <p:spPr>
+          <a:xfrm>
+            <a:off x="9006840" y="3337560"/>
+            <a:ext cx="310896" cy="310896"/>
+          </a:xfrm>
+          <a:prstGeom prst="rect">
+            <a:avLst/>
+          </a:prstGeom>
+          <a:solidFill>
+            <a:srgbClr val="F6C9A0"/>
+          </a:solidFill>
+          <a:ln/>
+        </p:spPr>
+      </p:sp>
+      <p:sp>
+        <p:nvSpPr>
+          <p:cNvPr id="70" name="Square 66"/>
+          <p:cNvSpPr/>
+          <p:nvPr/>
+        </p:nvSpPr>
+        <p:spPr>
+          <a:xfrm>
+            <a:off x="9372600" y="3337560"/>
+            <a:ext cx="310896" cy="310896"/>
+          </a:xfrm>
+          <a:prstGeom prst="rect">
+            <a:avLst/>
+          </a:prstGeom>
+          <a:solidFill>
+            <a:srgbClr val="F6C9A0"/>
+          </a:solidFill>
+          <a:ln/>
+        </p:spPr>
+      </p:sp>
+      <p:sp>
+        <p:nvSpPr>
+          <p:cNvPr id="71" name="Square 67"/>
+          <p:cNvSpPr/>
+          <p:nvPr/>
+        </p:nvSpPr>
+        <p:spPr>
+          <a:xfrm>
+            <a:off x="9738360" y="3337560"/>
+            <a:ext cx="310896" cy="310896"/>
+          </a:xfrm>
+          <a:prstGeom prst="rect">
+            <a:avLst/>
+          </a:prstGeom>
+          <a:solidFill>
+            <a:srgbClr val="F6C9A0"/>
+          </a:solidFill>
+          <a:ln/>
+        </p:spPr>
+      </p:sp>
+      <p:sp>
+        <p:nvSpPr>
+          <p:cNvPr id="72" name="Square 68"/>
+          <p:cNvSpPr/>
+          <p:nvPr/>
+        </p:nvSpPr>
+        <p:spPr>
+          <a:xfrm>
+            <a:off x="10104120" y="3337560"/>
+            <a:ext cx="310896" cy="310896"/>
+          </a:xfrm>
+          <a:prstGeom prst="rect">
+            <a:avLst/>
+          </a:prstGeom>
+          <a:solidFill>
+            <a:srgbClr val="F6C9A0"/>
+          </a:solidFill>
+          <a:ln/>
+        </p:spPr>
+      </p:sp>
+      <p:sp>
+        <p:nvSpPr>
+          <p:cNvPr id="73" name="Square 69"/>
+          <p:cNvSpPr/>
+          <p:nvPr/>
+        </p:nvSpPr>
+        <p:spPr>
+          <a:xfrm>
+            <a:off x="10469880" y="3337560"/>
+            <a:ext cx="310896" cy="310896"/>
+          </a:xfrm>
+          <a:prstGeom prst="rect">
+            <a:avLst/>
+          </a:prstGeom>
+          <a:solidFill>
+            <a:srgbClr val="F6C9A0"/>
+          </a:solidFill>
+          <a:ln/>
+        </p:spPr>
+      </p:sp>
+      <p:sp>
+        <p:nvSpPr>
+          <p:cNvPr id="74" name="Square 70"/>
+          <p:cNvSpPr/>
+          <p:nvPr/>
+        </p:nvSpPr>
+        <p:spPr>
+          <a:xfrm>
+            <a:off x="10835640" y="3337560"/>
+            <a:ext cx="310896" cy="310896"/>
+          </a:xfrm>
+          <a:prstGeom prst="rect">
+            <a:avLst/>
+          </a:prstGeom>
+          <a:solidFill>
+            <a:srgbClr val="F6C9A0"/>
+          </a:solidFill>
+          <a:ln/>
+        </p:spPr>
+      </p:sp>
+      <p:sp>
+        <p:nvSpPr>
+          <p:cNvPr id="75" name="Square 71"/>
+          <p:cNvSpPr/>
+          <p:nvPr/>
+        </p:nvSpPr>
+        <p:spPr>
+          <a:xfrm>
+            <a:off x="7543800" y="3703320"/>
+            <a:ext cx="310896" cy="310896"/>
+          </a:xfrm>
+          <a:prstGeom prst="rect">
+            <a:avLst/>
+          </a:prstGeom>
+          <a:solidFill>
+            <a:srgbClr val="F6C9A0"/>
+          </a:solidFill>
+          <a:ln/>
+        </p:spPr>
+      </p:sp>
+      <p:sp>
+        <p:nvSpPr>
+          <p:cNvPr id="76" name="Square 72"/>
+          <p:cNvSpPr/>
+          <p:nvPr/>
+        </p:nvSpPr>
+        <p:spPr>
+          <a:xfrm>
+            <a:off x="7909560" y="3703320"/>
+            <a:ext cx="310896" cy="310896"/>
+          </a:xfrm>
+          <a:prstGeom prst="rect">
+            <a:avLst/>
+          </a:prstGeom>
+          <a:solidFill>
+            <a:srgbClr val="F6C9A0"/>
+          </a:solidFill>
+          <a:ln/>
+        </p:spPr>
+      </p:sp>
+      <p:sp>
+        <p:nvSpPr>
+          <p:cNvPr id="77" name="Square 73"/>
+          <p:cNvSpPr/>
+          <p:nvPr/>
+        </p:nvSpPr>
+        <p:spPr>
+          <a:xfrm>
+            <a:off x="8275320" y="3703320"/>
+            <a:ext cx="310896" cy="310896"/>
+          </a:xfrm>
+          <a:prstGeom prst="rect">
+            <a:avLst/>
+          </a:prstGeom>
+          <a:solidFill>
+            <a:srgbClr val="F6C9A0"/>
+          </a:solidFill>
+          <a:ln/>
+        </p:spPr>
+      </p:sp>
+      <p:sp>
+        <p:nvSpPr>
+          <p:cNvPr id="78" name="Square 74"/>
+          <p:cNvSpPr/>
+          <p:nvPr/>
+        </p:nvSpPr>
+        <p:spPr>
+          <a:xfrm>
+            <a:off x="8641080" y="3703320"/>
+            <a:ext cx="310896" cy="310896"/>
+          </a:xfrm>
+          <a:prstGeom prst="rect">
+            <a:avLst/>
+          </a:prstGeom>
+          <a:solidFill>
+            <a:srgbClr val="F6C9A0"/>
+          </a:solidFill>
+          <a:ln/>
+        </p:spPr>
+      </p:sp>
+      <p:sp>
+        <p:nvSpPr>
+          <p:cNvPr id="79" name="Square 75"/>
+          <p:cNvSpPr/>
+          <p:nvPr/>
+        </p:nvSpPr>
+        <p:spPr>
+          <a:xfrm>
+            <a:off x="9006840" y="3703320"/>
+            <a:ext cx="310896" cy="310896"/>
+          </a:xfrm>
+          <a:prstGeom prst="rect">
+            <a:avLst/>
+          </a:prstGeom>
+          <a:solidFill>
+            <a:srgbClr val="F6C9A0"/>
+          </a:solidFill>
+          <a:ln/>
+        </p:spPr>
+      </p:sp>
+      <p:sp>
+        <p:nvSpPr>
+          <p:cNvPr id="80" name="Square 76"/>
+          <p:cNvSpPr/>
+          <p:nvPr/>
+        </p:nvSpPr>
+        <p:spPr>
+          <a:xfrm>
+            <a:off x="9372600" y="3703320"/>
+            <a:ext cx="310896" cy="310896"/>
+          </a:xfrm>
+          <a:prstGeom prst="rect">
+            <a:avLst/>
+          </a:prstGeom>
+          <a:solidFill>
+            <a:srgbClr val="F6C9A0"/>
+          </a:solidFill>
+          <a:ln/>
+        </p:spPr>
+      </p:sp>
+      <p:sp>
+        <p:nvSpPr>
+          <p:cNvPr id="81" name="Square 77"/>
+          <p:cNvSpPr/>
+          <p:nvPr/>
+        </p:nvSpPr>
+        <p:spPr>
+          <a:xfrm>
+            <a:off x="9738360" y="3703320"/>
+            <a:ext cx="310896" cy="310896"/>
+          </a:xfrm>
+          <a:prstGeom prst="rect">
+            <a:avLst/>
+          </a:prstGeom>
+          <a:solidFill>
+            <a:srgbClr val="F6C9A0"/>
+          </a:solidFill>
+          <a:ln/>
+        </p:spPr>
+      </p:sp>
+      <p:sp>
+        <p:nvSpPr>
+          <p:cNvPr id="82" name="Square 78"/>
+          <p:cNvSpPr/>
+          <p:nvPr/>
+        </p:nvSpPr>
+        <p:spPr>
+          <a:xfrm>
+            <a:off x="10104120" y="3703320"/>
+            <a:ext cx="310896" cy="310896"/>
+          </a:xfrm>
+          <a:prstGeom prst="rect">
+            <a:avLst/>
+          </a:prstGeom>
+          <a:solidFill>
+            <a:srgbClr val="F6C9A0"/>
+          </a:solidFill>
+          <a:ln/>
+        </p:spPr>
+      </p:sp>
+      <p:sp>
+        <p:nvSpPr>
+          <p:cNvPr id="83" name="Square 79"/>
+          <p:cNvSpPr/>
+          <p:nvPr/>
+        </p:nvSpPr>
+        <p:spPr>
+          <a:xfrm>
+            <a:off x="10469880" y="3703320"/>
+            <a:ext cx="310896" cy="310896"/>
+          </a:xfrm>
+          <a:prstGeom prst="rect">
+            <a:avLst/>
+          </a:prstGeom>
+          <a:solidFill>
+            <a:srgbClr val="F6C9A0"/>
+          </a:solidFill>
+          <a:ln/>
+        </p:spPr>
+      </p:sp>
+      <p:sp>
+        <p:nvSpPr>
+          <p:cNvPr id="84" name="Square 80"/>
+          <p:cNvSpPr/>
+          <p:nvPr/>
+        </p:nvSpPr>
+        <p:spPr>
+          <a:xfrm>
+            <a:off x="10835640" y="3703320"/>
+            <a:ext cx="310896" cy="310896"/>
+          </a:xfrm>
+          <a:prstGeom prst="rect">
+            <a:avLst/>
+          </a:prstGeom>
+          <a:solidFill>
+            <a:srgbClr val="F6C9A0"/>
+          </a:solidFill>
+          <a:ln/>
+        </p:spPr>
+      </p:sp>
+      <p:sp>
+        <p:nvSpPr>
+          <p:cNvPr id="85" name="Square 81"/>
+          <p:cNvSpPr/>
+          <p:nvPr/>
+        </p:nvSpPr>
+        <p:spPr>
+          <a:xfrm>
+            <a:off x="7543800" y="4069080"/>
+            <a:ext cx="310896" cy="310896"/>
+          </a:xfrm>
+          <a:prstGeom prst="rect">
+            <a:avLst/>
+          </a:prstGeom>
+          <a:solidFill>
+            <a:srgbClr val="F6C9A0"/>
+          </a:solidFill>
+          <a:ln/>
+        </p:spPr>
+      </p:sp>
+      <p:sp>
+        <p:nvSpPr>
+          <p:cNvPr id="86" name="Square 82"/>
+          <p:cNvSpPr/>
+          <p:nvPr/>
+        </p:nvSpPr>
+        <p:spPr>
+          <a:xfrm>
+            <a:off x="7909560" y="4069080"/>
+            <a:ext cx="310896" cy="310896"/>
+          </a:xfrm>
+          <a:prstGeom prst="rect">
+            <a:avLst/>
+          </a:prstGeom>
+          <a:solidFill>
+            <a:srgbClr val="F6C9A0"/>
+          </a:solidFill>
+          <a:ln/>
+        </p:spPr>
+      </p:sp>
+      <p:sp>
+        <p:nvSpPr>
+          <p:cNvPr id="87" name="Square 83"/>
+          <p:cNvSpPr/>
+          <p:nvPr/>
+        </p:nvSpPr>
+        <p:spPr>
+          <a:xfrm>
+            <a:off x="8275320" y="4069080"/>
+            <a:ext cx="310896" cy="310896"/>
+          </a:xfrm>
+          <a:prstGeom prst="rect">
+            <a:avLst/>
+          </a:prstGeom>
+          <a:ln w="12700">
+            <a:solidFill>
+              <a:srgbClr val="F6C9A0"/>
+            </a:solidFill>
+            <a:prstDash val="solid"/>
+          </a:ln>
+        </p:spPr>
+      </p:sp>
+      <p:sp>
+        <p:nvSpPr>
+          <p:cNvPr id="88" name="Square 84"/>
+          <p:cNvSpPr/>
+          <p:nvPr/>
+        </p:nvSpPr>
+        <p:spPr>
+          <a:xfrm>
+            <a:off x="8641080" y="4069080"/>
+            <a:ext cx="310896" cy="310896"/>
+          </a:xfrm>
+          <a:prstGeom prst="rect">
+            <a:avLst/>
+          </a:prstGeom>
+          <a:ln w="12700">
+            <a:solidFill>
+              <a:srgbClr val="F6C9A0"/>
+            </a:solidFill>
+            <a:prstDash val="solid"/>
+          </a:ln>
+        </p:spPr>
+      </p:sp>
+      <p:sp>
+        <p:nvSpPr>
+          <p:cNvPr id="89" name="Square 85"/>
+          <p:cNvSpPr/>
+          <p:nvPr/>
+        </p:nvSpPr>
+        <p:spPr>
+          <a:xfrm>
+            <a:off x="9006840" y="4069080"/>
+            <a:ext cx="310896" cy="310896"/>
+          </a:xfrm>
+          <a:prstGeom prst="rect">
+            <a:avLst/>
+          </a:prstGeom>
+          <a:ln w="12700">
+            <a:solidFill>
+              <a:srgbClr val="F6C9A0"/>
+            </a:solidFill>
+            <a:prstDash val="solid"/>
+          </a:ln>
+        </p:spPr>
+      </p:sp>
+      <p:sp>
+        <p:nvSpPr>
+          <p:cNvPr id="90" name="Square 86"/>
+          <p:cNvSpPr/>
+          <p:nvPr/>
+        </p:nvSpPr>
+        <p:spPr>
+          <a:xfrm>
+            <a:off x="9372600" y="4069080"/>
+            <a:ext cx="310896" cy="310896"/>
+          </a:xfrm>
+          <a:prstGeom prst="rect">
+            <a:avLst/>
+          </a:prstGeom>
+          <a:ln w="12700">
+            <a:solidFill>
+              <a:srgbClr val="F6C9A0"/>
+            </a:solidFill>
+            <a:prstDash val="solid"/>
+          </a:ln>
+        </p:spPr>
+      </p:sp>
+      <p:sp>
+        <p:nvSpPr>
+          <p:cNvPr id="91" name="Square 87"/>
+          <p:cNvSpPr/>
+          <p:nvPr/>
+        </p:nvSpPr>
+        <p:spPr>
+          <a:xfrm>
+            <a:off x="9738360" y="4069080"/>
+            <a:ext cx="310896" cy="310896"/>
+          </a:xfrm>
+          <a:prstGeom prst="rect">
+            <a:avLst/>
+          </a:prstGeom>
+          <a:ln w="12700">
+            <a:solidFill>
+              <a:srgbClr val="F6C9A0"/>
+            </a:solidFill>
+            <a:prstDash val="solid"/>
+          </a:ln>
+        </p:spPr>
+      </p:sp>
+      <p:sp>
+        <p:nvSpPr>
+          <p:cNvPr id="92" name="Square 88"/>
+          <p:cNvSpPr/>
+          <p:nvPr/>
+        </p:nvSpPr>
+        <p:spPr>
+          <a:xfrm>
+            <a:off x="10104120" y="4069080"/>
+            <a:ext cx="310896" cy="310896"/>
+          </a:xfrm>
+          <a:prstGeom prst="rect">
+            <a:avLst/>
+          </a:prstGeom>
+          <a:ln w="12700">
+            <a:solidFill>
+              <a:srgbClr val="F6C9A0"/>
+            </a:solidFill>
+            <a:prstDash val="solid"/>
+          </a:ln>
+        </p:spPr>
+      </p:sp>
+      <p:sp>
+        <p:nvSpPr>
+          <p:cNvPr id="93" name="Square 89"/>
+          <p:cNvSpPr/>
+          <p:nvPr/>
+        </p:nvSpPr>
+        <p:spPr>
+          <a:xfrm>
+            <a:off x="10469880" y="4069080"/>
+            <a:ext cx="310896" cy="310896"/>
+          </a:xfrm>
+          <a:prstGeom prst="rect">
+            <a:avLst/>
+          </a:prstGeom>
+          <a:ln w="12700">
+            <a:solidFill>
+              <a:srgbClr val="F6C9A0"/>
+            </a:solidFill>
+            <a:prstDash val="solid"/>
+          </a:ln>
+        </p:spPr>
+      </p:sp>
+      <p:sp>
+        <p:nvSpPr>
+          <p:cNvPr id="94" name="Square 90"/>
+          <p:cNvSpPr/>
+          <p:nvPr/>
+        </p:nvSpPr>
+        <p:spPr>
+          <a:xfrm>
+            <a:off x="10835640" y="4069080"/>
+            <a:ext cx="310896" cy="310896"/>
+          </a:xfrm>
+          <a:prstGeom prst="rect">
+            <a:avLst/>
+          </a:prstGeom>
+          <a:ln w="12700">
+            <a:solidFill>
+              <a:srgbClr val="F6C9A0"/>
+            </a:solidFill>
+            <a:prstDash val="solid"/>
+          </a:ln>
+        </p:spPr>
+      </p:sp>
+      <p:sp>
+        <p:nvSpPr>
+          <p:cNvPr id="95" name="Square 91"/>
+          <p:cNvSpPr/>
+          <p:nvPr/>
+        </p:nvSpPr>
+        <p:spPr>
+          <a:xfrm>
+            <a:off x="7543800" y="4434840"/>
+            <a:ext cx="310896" cy="310896"/>
+          </a:xfrm>
+          <a:prstGeom prst="rect">
+            <a:avLst/>
+          </a:prstGeom>
+          <a:ln w="12700">
+            <a:solidFill>
+              <a:srgbClr val="F6C9A0"/>
+            </a:solidFill>
+            <a:prstDash val="solid"/>
+          </a:ln>
+        </p:spPr>
+      </p:sp>
+      <p:sp>
+        <p:nvSpPr>
+          <p:cNvPr id="96" name="Square 92"/>
+          <p:cNvSpPr/>
+          <p:nvPr/>
+        </p:nvSpPr>
+        <p:spPr>
+          <a:xfrm>
+            <a:off x="7909560" y="4434840"/>
+            <a:ext cx="310896" cy="310896"/>
+          </a:xfrm>
+          <a:prstGeom prst="rect">
+            <a:avLst/>
+          </a:prstGeom>
+          <a:ln w="12700">
+            <a:solidFill>
+              <a:srgbClr val="F6C9A0"/>
+            </a:solidFill>
+            <a:prstDash val="solid"/>
+          </a:ln>
+        </p:spPr>
+      </p:sp>
+      <p:sp>
+        <p:nvSpPr>
+          <p:cNvPr id="97" name="Square 93"/>
+          <p:cNvSpPr/>
+          <p:nvPr/>
+        </p:nvSpPr>
+        <p:spPr>
+          <a:xfrm>
+            <a:off x="8275320" y="4434840"/>
+            <a:ext cx="310896" cy="310896"/>
+          </a:xfrm>
+          <a:prstGeom prst="rect">
+            <a:avLst/>
+          </a:prstGeom>
+          <a:ln w="12700">
+            <a:solidFill>
+              <a:srgbClr val="F6C9A0"/>
+            </a:solidFill>
+            <a:prstDash val="solid"/>
+          </a:ln>
+        </p:spPr>
+      </p:sp>
+      <p:sp>
+        <p:nvSpPr>
+          <p:cNvPr id="98" name="Square 94"/>
+          <p:cNvSpPr/>
+          <p:nvPr/>
+        </p:nvSpPr>
+        <p:spPr>
+          <a:xfrm>
+            <a:off x="8641080" y="4434840"/>
+            <a:ext cx="310896" cy="310896"/>
+          </a:xfrm>
+          <a:prstGeom prst="rect">
+            <a:avLst/>
+          </a:prstGeom>
+          <a:ln w="12700">
+            <a:solidFill>
+              <a:srgbClr val="F6C9A0"/>
+            </a:solidFill>
+            <a:prstDash val="solid"/>
+          </a:ln>
+        </p:spPr>
+      </p:sp>
+      <p:sp>
+        <p:nvSpPr>
+          <p:cNvPr id="99" name="Square 95"/>
+          <p:cNvSpPr/>
+          <p:nvPr/>
+        </p:nvSpPr>
+        <p:spPr>
+          <a:xfrm>
+            <a:off x="9006840" y="4434840"/>
+            <a:ext cx="310896" cy="310896"/>
+          </a:xfrm>
+          <a:prstGeom prst="rect">
+            <a:avLst/>
+          </a:prstGeom>
+          <a:ln w="12700">
+            <a:solidFill>
+              <a:srgbClr val="F6C9A0"/>
+            </a:solidFill>
+            <a:prstDash val="solid"/>
+          </a:ln>
+        </p:spPr>
+      </p:sp>
+      <p:sp>
+        <p:nvSpPr>
+          <p:cNvPr id="100" name="Square 96"/>
+          <p:cNvSpPr/>
+          <p:nvPr/>
+        </p:nvSpPr>
+        <p:spPr>
+          <a:xfrm>
+            <a:off x="9372600" y="4434840"/>
+            <a:ext cx="310896" cy="310896"/>
+          </a:xfrm>
+          <a:prstGeom prst="rect">
+            <a:avLst/>
+          </a:prstGeom>
+          <a:ln w="12700">
+            <a:solidFill>
+              <a:srgbClr val="F6C9A0"/>
+            </a:solidFill>
+            <a:prstDash val="solid"/>
+          </a:ln>
+        </p:spPr>
+      </p:sp>
+      <p:sp>
+        <p:nvSpPr>
+          <p:cNvPr id="101" name="Square 97"/>
+          <p:cNvSpPr/>
+          <p:nvPr/>
+        </p:nvSpPr>
+        <p:spPr>
+          <a:xfrm>
+            <a:off x="9738360" y="4434840"/>
+            <a:ext cx="310896" cy="310896"/>
+          </a:xfrm>
+          <a:prstGeom prst="rect">
+            <a:avLst/>
+          </a:prstGeom>
+          <a:ln w="12700">
+            <a:solidFill>
+              <a:srgbClr val="F6C9A0"/>
+            </a:solidFill>
+            <a:prstDash val="solid"/>
+          </a:ln>
+        </p:spPr>
+      </p:sp>
+      <p:sp>
+        <p:nvSpPr>
+          <p:cNvPr id="102" name="Square 98"/>
+          <p:cNvSpPr/>
+          <p:nvPr/>
+        </p:nvSpPr>
+        <p:spPr>
+          <a:xfrm>
+            <a:off x="10104120" y="4434840"/>
+            <a:ext cx="310896" cy="310896"/>
+          </a:xfrm>
+          <a:prstGeom prst="rect">
+            <a:avLst/>
+          </a:prstGeom>
+          <a:ln w="12700">
+            <a:solidFill>
+              <a:srgbClr val="F6C9A0"/>
+            </a:solidFill>
+            <a:prstDash val="solid"/>
+          </a:ln>
+        </p:spPr>
+      </p:sp>
+      <p:sp>
+        <p:nvSpPr>
+          <p:cNvPr id="103" name="Square 99"/>
+          <p:cNvSpPr/>
+          <p:nvPr/>
+        </p:nvSpPr>
+        <p:spPr>
+          <a:xfrm>
+            <a:off x="10469880" y="4434840"/>
+            <a:ext cx="310896" cy="310896"/>
+          </a:xfrm>
+          <a:prstGeom prst="rect">
+            <a:avLst/>
+          </a:prstGeom>
+          <a:ln w="12700">
+            <a:solidFill>
+              <a:srgbClr val="F6C9A0"/>
+            </a:solidFill>
+            <a:prstDash val="solid"/>
+          </a:ln>
+        </p:spPr>
+      </p:sp>
+      <p:sp>
+        <p:nvSpPr>
+          <p:cNvPr id="104" name="Square 100"/>
+          <p:cNvSpPr/>
+          <p:nvPr/>
+        </p:nvSpPr>
+        <p:spPr>
+          <a:xfrm>
+            <a:off x="10835640" y="4434840"/>
+            <a:ext cx="310896" cy="310896"/>
+          </a:xfrm>
+          <a:prstGeom prst="rect">
+            <a:avLst/>
+          </a:prstGeom>
+          <a:ln w="12700">
+            <a:solidFill>
+              <a:srgbClr val="F6C9A0"/>
+            </a:solidFill>
+            <a:prstDash val="solid"/>
+          </a:ln>
+        </p:spPr>
+      </p:sp>
+      <p:sp>
+        <p:nvSpPr>
+          <p:cNvPr id="105" name="Grid key"/>
+          <p:cNvSpPr txBox="1"/>
+          <p:nvPr/>
+        </p:nvSpPr>
+        <p:spPr>
+          <a:xfrm>
+            <a:off x="7543800" y="4937760"/>
+            <a:ext cx="3657600" cy="594360"/>
+          </a:xfrm>
+          <a:prstGeom prst="rect">
+            <a:avLst/>
+          </a:prstGeom>
+          <a:noFill/>
+          <a:ln/>
+        </p:spPr>
+        <p:txBody>
+          <a:bodyPr wrap="square" lIns="0" tIns="0" rIns="0" bIns="0" rtlCol="0" anchor="t"/>
+          <a:lstStyle/>
+          <a:p>
+            <a:pPr indent="0" marL="0">
+              <a:buNone/>
+            </a:pPr>
+            <a:r>
+              <a:rPr lang="en-US" sz="1400" dirty="0">
+                <a:solidFill>
+                  <a:srgbClr val="F6C9A0"/>
+                </a:solidFill>
+              </a:rPr>
+              <a:t>Filled: same level as the day before</a:t>
+            </a:r>
+            <a:endParaRPr lang="en-US" sz="1400" dirty="0"/>
+          </a:p>
+          <a:p>
+            <a:pPr indent="0" marL="0">
+              <a:buNone/>
+            </a:pPr>
+            <a:r>
+              <a:rPr lang="en-US" sz="1400" dirty="0">
+                <a:solidFill>
+                  <a:srgbClr val="F6C9A0"/>
+                </a:solidFill>
+              </a:rPr>
+              <a:t>Empty: the level changed</a:t>
+            </a:r>
+            <a:endParaRPr lang="en-US" sz="1400" dirty="0"/>
           </a:p>
         </p:txBody>
       </p:sp>
@@ -10380,8 +12775,8 @@
         </p:nvSpPr>
         <p:spPr>
           <a:xfrm>
-            <a:off x="868680" y="2148840"/>
-            <a:ext cx="5097780" cy="3017520"/>
+            <a:off x="868680" y="2103120"/>
+            <a:ext cx="5097780" cy="3246120"/>
           </a:xfrm>
           <a:prstGeom prst="rect">
             <a:avLst/>
@@ -10400,8 +12795,8 @@
         </p:nvSpPr>
         <p:spPr>
           <a:xfrm>
-            <a:off x="1143000" y="2423160"/>
-            <a:ext cx="640080" cy="640080"/>
+            <a:off x="1188720" y="2423160"/>
+            <a:ext cx="685800" cy="685800"/>
           </a:xfrm>
           <a:prstGeom prst="ellipse">
             <a:avLst/>
@@ -10420,8 +12815,8 @@
         </p:nvSpPr>
         <p:spPr>
           <a:xfrm>
-            <a:off x="1143000" y="2423160"/>
-            <a:ext cx="640080" cy="640080"/>
+            <a:off x="1188720" y="2423160"/>
+            <a:ext cx="685800" cy="685800"/>
           </a:xfrm>
           <a:prstGeom prst="rect">
             <a:avLst/>
@@ -10437,7 +12832,7 @@
               <a:buNone/>
             </a:pPr>
             <a:r>
-              <a:rPr lang="en-US" sz="2600" dirty="0">
+              <a:rPr lang="en-US" sz="2800" dirty="0">
                 <a:solidFill>
                   <a:srgbClr val="FFFFFF"/>
                 </a:solidFill>
@@ -10447,20 +12842,44 @@
               </a:rPr>
               <a:t>A</a:t>
             </a:r>
-            <a:endParaRPr lang="en-US" sz="2600" dirty="0"/>
-          </a:p>
-        </p:txBody>
-      </p:sp>
-      <p:sp>
-        <p:nvSpPr>
-          <p:cNvPr id="7" name="Option text A"/>
+            <a:endParaRPr lang="en-US" sz="2800" dirty="0"/>
+          </a:p>
+        </p:txBody>
+      </p:sp>
+      <p:pic>
+        <p:nvPicPr>
+          <p:cNvPr id="7" name="Option icon A" descr="Missing a real Danger day">    </p:cNvPr>
+          <p:cNvPicPr>
+            <a:picLocks noChangeAspect="1"/>
+          </p:cNvPicPr>
+          <p:nvPr/>
+        </p:nvPicPr>
+        <p:blipFill>
+          <a:blip r:embed="rId1"/>
+          <a:stretch>
+            <a:fillRect/>
+          </a:stretch>
+        </p:blipFill>
+        <p:spPr>
+          <a:xfrm>
+            <a:off x="4732020" y="2377440"/>
+            <a:ext cx="914400" cy="914400"/>
+          </a:xfrm>
+          <a:prstGeom prst="rect">
+            <a:avLst/>
+          </a:prstGeom>
+        </p:spPr>
+      </p:pic>
+      <p:sp>
+        <p:nvSpPr>
+          <p:cNvPr id="8" name="Text 5"/>
           <p:cNvSpPr txBox="1"/>
           <p:nvPr/>
         </p:nvSpPr>
         <p:spPr>
           <a:xfrm>
-            <a:off x="1143000" y="3200400"/>
-            <a:ext cx="4549140" cy="1783080"/>
+            <a:off x="1188720" y="3291840"/>
+            <a:ext cx="4457700" cy="548640"/>
           </a:xfrm>
           <a:prstGeom prst="rect">
             <a:avLst/>
@@ -10469,113 +12888,212 @@
           <a:ln/>
         </p:spPr>
         <p:txBody>
-          <a:bodyPr wrap="square" lIns="0" tIns="0" rIns="0" bIns="0" rtlCol="0" anchor="t"/>
+          <a:bodyPr wrap="square" lIns="0" tIns="0" rIns="0" bIns="0" rtlCol="0" anchor="ctr"/>
           <a:lstStyle/>
           <a:p>
             <a:pPr indent="0" marL="0">
               <a:buNone/>
             </a:pPr>
             <a:r>
-              <a:rPr lang="en-US" sz="2000" dirty="0">
+              <a:rPr lang="en-US" sz="2800" dirty="0">
                 <a:solidFill>
                   <a:srgbClr val="2E1406"/>
-                </a:solidFill>
-              </a:rPr>
-              <a:t>Missing a real Danger day. Nobody prepares, and students play outside at 44 °C.</a:t>
-            </a:r>
-            <a:endParaRPr lang="en-US" sz="2000" dirty="0"/>
-          </a:p>
-        </p:txBody>
-      </p:sp>
-      <p:sp>
-        <p:nvSpPr>
-          <p:cNvPr id="8" name="Option B"/>
-          <p:cNvSpPr/>
-          <p:nvPr/>
-        </p:nvSpPr>
-        <p:spPr>
-          <a:xfrm>
-            <a:off x="6240780" y="2148840"/>
-            <a:ext cx="5097780" cy="3017520"/>
-          </a:xfrm>
-          <a:prstGeom prst="rect">
-            <a:avLst/>
-          </a:prstGeom>
-          <a:solidFill>
-            <a:srgbClr val="FDEBDC"/>
-          </a:solidFill>
-          <a:ln/>
-        </p:spPr>
-      </p:sp>
-      <p:sp>
-        <p:nvSpPr>
-          <p:cNvPr id="9" name="Option dot B"/>
-          <p:cNvSpPr/>
-          <p:nvPr/>
-        </p:nvSpPr>
-        <p:spPr>
-          <a:xfrm>
-            <a:off x="6515100" y="2423160"/>
-            <a:ext cx="640080" cy="640080"/>
-          </a:xfrm>
-          <a:prstGeom prst="ellipse">
-            <a:avLst/>
-          </a:prstGeom>
-          <a:solidFill>
-            <a:srgbClr val="A63A0C"/>
-          </a:solidFill>
-          <a:ln/>
-        </p:spPr>
-      </p:sp>
-      <p:sp>
-        <p:nvSpPr>
-          <p:cNvPr id="10" name="Text 8"/>
-          <p:cNvSpPr txBox="1"/>
-          <p:nvPr/>
-        </p:nvSpPr>
-        <p:spPr>
-          <a:xfrm>
-            <a:off x="6515100" y="2423160"/>
-            <a:ext cx="640080" cy="640080"/>
-          </a:xfrm>
-          <a:prstGeom prst="rect">
-            <a:avLst/>
-          </a:prstGeom>
-          <a:noFill/>
-          <a:ln/>
-        </p:spPr>
-        <p:txBody>
-          <a:bodyPr wrap="square" lIns="0" tIns="0" rIns="0" bIns="0" rtlCol="0" anchor="ctr"/>
-          <a:lstStyle/>
-          <a:p>
-            <a:pPr algn="ctr" indent="0" marL="0">
-              <a:buNone/>
-            </a:pPr>
-            <a:r>
-              <a:rPr lang="en-US" sz="2600" dirty="0">
-                <a:solidFill>
-                  <a:srgbClr val="FFFFFF"/>
                 </a:solidFill>
                 <a:latin typeface="Cambria" pitchFamily="34" charset="0"/>
                 <a:ea typeface="Cambria" pitchFamily="34" charset="-122"/>
                 <a:cs typeface="Cambria" pitchFamily="34" charset="-120"/>
               </a:rPr>
+              <a:t>Missing a real Danger day</a:t>
+            </a:r>
+            <a:endParaRPr lang="en-US" sz="2800" dirty="0"/>
+          </a:p>
+        </p:txBody>
+      </p:sp>
+      <p:sp>
+        <p:nvSpPr>
+          <p:cNvPr id="9" name="Text 6"/>
+          <p:cNvSpPr txBox="1"/>
+          <p:nvPr/>
+        </p:nvSpPr>
+        <p:spPr>
+          <a:xfrm>
+            <a:off x="1188720" y="3886200"/>
+            <a:ext cx="4457700" cy="685800"/>
+          </a:xfrm>
+          <a:prstGeom prst="rect">
+            <a:avLst/>
+          </a:prstGeom>
+          <a:noFill/>
+          <a:ln/>
+        </p:spPr>
+        <p:txBody>
+          <a:bodyPr wrap="square" lIns="0" tIns="0" rIns="0" bIns="0" rtlCol="0" anchor="t"/>
+          <a:lstStyle/>
+          <a:p>
+            <a:pPr indent="0" marL="0">
+              <a:buNone/>
+            </a:pPr>
+            <a:r>
+              <a:rPr lang="en-US" sz="1800" dirty="0">
+                <a:solidFill>
+                  <a:srgbClr val="2E1406"/>
+                </a:solidFill>
+              </a:rPr>
+              <a:t>Nobody prepares, and students play outside at 44 °C.</a:t>
+            </a:r>
+            <a:endParaRPr lang="en-US" sz="1800" dirty="0"/>
+          </a:p>
+        </p:txBody>
+      </p:sp>
+      <p:sp>
+        <p:nvSpPr>
+          <p:cNvPr id="10" name="Text 7"/>
+          <p:cNvSpPr txBox="1"/>
+          <p:nvPr/>
+        </p:nvSpPr>
+        <p:spPr>
+          <a:xfrm>
+            <a:off x="1188720" y="4617720"/>
+            <a:ext cx="4457700" cy="548640"/>
+          </a:xfrm>
+          <a:prstGeom prst="rect">
+            <a:avLst/>
+          </a:prstGeom>
+          <a:noFill/>
+          <a:ln/>
+        </p:spPr>
+        <p:txBody>
+          <a:bodyPr wrap="square" lIns="0" tIns="0" rIns="0" bIns="0" rtlCol="0" anchor="t"/>
+          <a:lstStyle/>
+          <a:p>
+            <a:pPr indent="0" marL="0">
+              <a:buNone/>
+            </a:pPr>
+            <a:r>
+              <a:rPr lang="en-US" sz="1600" b="1" dirty="0">
+                <a:solidFill>
+                  <a:srgbClr val="A63A0C"/>
+                </a:solidFill>
+              </a:rPr>
+              <a:t>The cost: someone may get heat exhaustion or heat stroke.</a:t>
+            </a:r>
+            <a:endParaRPr lang="en-US" sz="1600" dirty="0"/>
+          </a:p>
+        </p:txBody>
+      </p:sp>
+      <p:sp>
+        <p:nvSpPr>
+          <p:cNvPr id="11" name="Option B"/>
+          <p:cNvSpPr/>
+          <p:nvPr/>
+        </p:nvSpPr>
+        <p:spPr>
+          <a:xfrm>
+            <a:off x="6240780" y="2103120"/>
+            <a:ext cx="5097780" cy="3246120"/>
+          </a:xfrm>
+          <a:prstGeom prst="rect">
+            <a:avLst/>
+          </a:prstGeom>
+          <a:solidFill>
+            <a:srgbClr val="FDEBDC"/>
+          </a:solidFill>
+          <a:ln/>
+        </p:spPr>
+      </p:sp>
+      <p:sp>
+        <p:nvSpPr>
+          <p:cNvPr id="12" name="Option dot B"/>
+          <p:cNvSpPr/>
+          <p:nvPr/>
+        </p:nvSpPr>
+        <p:spPr>
+          <a:xfrm>
+            <a:off x="6560820" y="2423160"/>
+            <a:ext cx="685800" cy="685800"/>
+          </a:xfrm>
+          <a:prstGeom prst="ellipse">
+            <a:avLst/>
+          </a:prstGeom>
+          <a:solidFill>
+            <a:srgbClr val="A63A0C"/>
+          </a:solidFill>
+          <a:ln/>
+        </p:spPr>
+      </p:sp>
+      <p:sp>
+        <p:nvSpPr>
+          <p:cNvPr id="13" name="Text 10"/>
+          <p:cNvSpPr txBox="1"/>
+          <p:nvPr/>
+        </p:nvSpPr>
+        <p:spPr>
+          <a:xfrm>
+            <a:off x="6560820" y="2423160"/>
+            <a:ext cx="685800" cy="685800"/>
+          </a:xfrm>
+          <a:prstGeom prst="rect">
+            <a:avLst/>
+          </a:prstGeom>
+          <a:noFill/>
+          <a:ln/>
+        </p:spPr>
+        <p:txBody>
+          <a:bodyPr wrap="square" lIns="0" tIns="0" rIns="0" bIns="0" rtlCol="0" anchor="ctr"/>
+          <a:lstStyle/>
+          <a:p>
+            <a:pPr algn="ctr" indent="0" marL="0">
+              <a:buNone/>
+            </a:pPr>
+            <a:r>
+              <a:rPr lang="en-US" sz="2800" dirty="0">
+                <a:solidFill>
+                  <a:srgbClr val="FFFFFF"/>
+                </a:solidFill>
+                <a:latin typeface="Cambria" pitchFamily="34" charset="0"/>
+                <a:ea typeface="Cambria" pitchFamily="34" charset="-122"/>
+                <a:cs typeface="Cambria" pitchFamily="34" charset="-120"/>
+              </a:rPr>
               <a:t>B</a:t>
             </a:r>
-            <a:endParaRPr lang="en-US" sz="2600" dirty="0"/>
-          </a:p>
-        </p:txBody>
-      </p:sp>
-      <p:sp>
-        <p:nvSpPr>
-          <p:cNvPr id="11" name="Option text B"/>
+            <a:endParaRPr lang="en-US" sz="2800" dirty="0"/>
+          </a:p>
+        </p:txBody>
+      </p:sp>
+      <p:pic>
+        <p:nvPicPr>
+          <p:cNvPr id="14" name="Option icon B" descr="A false alarm">    </p:cNvPr>
+          <p:cNvPicPr>
+            <a:picLocks noChangeAspect="1"/>
+          </p:cNvPicPr>
+          <p:nvPr/>
+        </p:nvPicPr>
+        <p:blipFill>
+          <a:blip r:embed="rId2"/>
+          <a:stretch>
+            <a:fillRect/>
+          </a:stretch>
+        </p:blipFill>
+        <p:spPr>
+          <a:xfrm>
+            <a:off x="10104120" y="2377440"/>
+            <a:ext cx="914400" cy="914400"/>
+          </a:xfrm>
+          <a:prstGeom prst="rect">
+            <a:avLst/>
+          </a:prstGeom>
+        </p:spPr>
+      </p:pic>
+      <p:sp>
+        <p:nvSpPr>
+          <p:cNvPr id="15" name="Text 11"/>
           <p:cNvSpPr txBox="1"/>
           <p:nvPr/>
         </p:nvSpPr>
         <p:spPr>
           <a:xfrm>
-            <a:off x="6515100" y="3200400"/>
-            <a:ext cx="4549140" cy="1783080"/>
+            <a:off x="6560820" y="3291840"/>
+            <a:ext cx="4457700" cy="548640"/>
           </a:xfrm>
           <a:prstGeom prst="rect">
             <a:avLst/>
@@ -10584,6 +13102,45 @@
           <a:ln/>
         </p:spPr>
         <p:txBody>
+          <a:bodyPr wrap="square" lIns="0" tIns="0" rIns="0" bIns="0" rtlCol="0" anchor="ctr"/>
+          <a:lstStyle/>
+          <a:p>
+            <a:pPr indent="0" marL="0">
+              <a:buNone/>
+            </a:pPr>
+            <a:r>
+              <a:rPr lang="en-US" sz="2800" dirty="0">
+                <a:solidFill>
+                  <a:srgbClr val="2E1406"/>
+                </a:solidFill>
+                <a:latin typeface="Cambria" pitchFamily="34" charset="0"/>
+                <a:ea typeface="Cambria" pitchFamily="34" charset="-122"/>
+                <a:cs typeface="Cambria" pitchFamily="34" charset="-120"/>
+              </a:rPr>
+              <a:t>A false alarm</a:t>
+            </a:r>
+            <a:endParaRPr lang="en-US" sz="2800" dirty="0"/>
+          </a:p>
+        </p:txBody>
+      </p:sp>
+      <p:sp>
+        <p:nvSpPr>
+          <p:cNvPr id="16" name="Text 12"/>
+          <p:cNvSpPr txBox="1"/>
+          <p:nvPr/>
+        </p:nvSpPr>
+        <p:spPr>
+          <a:xfrm>
+            <a:off x="6560820" y="3886200"/>
+            <a:ext cx="4457700" cy="685800"/>
+          </a:xfrm>
+          <a:prstGeom prst="rect">
+            <a:avLst/>
+          </a:prstGeom>
+          <a:noFill/>
+          <a:ln/>
+        </p:spPr>
+        <p:txBody>
           <a:bodyPr wrap="square" lIns="0" tIns="0" rIns="0" bIns="0" rtlCol="0" anchor="t"/>
           <a:lstStyle/>
           <a:p>
@@ -10591,26 +13148,62 @@
               <a:buNone/>
             </a:pPr>
             <a:r>
-              <a:rPr lang="en-US" sz="2000" dirty="0">
+              <a:rPr lang="en-US" sz="1800" dirty="0">
                 <a:solidFill>
                   <a:srgbClr val="2E1406"/>
                 </a:solidFill>
               </a:rPr>
-              <a:t>A false alarm. Activities are moved indoors, but the day was not that hot.</a:t>
-            </a:r>
-            <a:endParaRPr lang="en-US" sz="2000" dirty="0"/>
-          </a:p>
-        </p:txBody>
-      </p:sp>
-      <p:sp>
-        <p:nvSpPr>
-          <p:cNvPr id="12" name="Our choice"/>
+              <a:t>Activities are moved indoors, but the day was not that hot.</a:t>
+            </a:r>
+            <a:endParaRPr lang="en-US" sz="1800" dirty="0"/>
+          </a:p>
+        </p:txBody>
+      </p:sp>
+      <p:sp>
+        <p:nvSpPr>
+          <p:cNvPr id="17" name="Text 13"/>
           <p:cNvSpPr txBox="1"/>
           <p:nvPr/>
         </p:nvSpPr>
         <p:spPr>
           <a:xfrm>
-            <a:off x="868680" y="5440680"/>
+            <a:off x="6560820" y="4617720"/>
+            <a:ext cx="4457700" cy="548640"/>
+          </a:xfrm>
+          <a:prstGeom prst="rect">
+            <a:avLst/>
+          </a:prstGeom>
+          <a:noFill/>
+          <a:ln/>
+        </p:spPr>
+        <p:txBody>
+          <a:bodyPr wrap="square" lIns="0" tIns="0" rIns="0" bIns="0" rtlCol="0" anchor="t"/>
+          <a:lstStyle/>
+          <a:p>
+            <a:pPr indent="0" marL="0">
+              <a:buNone/>
+            </a:pPr>
+            <a:r>
+              <a:rPr lang="en-US" sz="1600" b="1" dirty="0">
+                <a:solidFill>
+                  <a:srgbClr val="A63A0C"/>
+                </a:solidFill>
+              </a:rPr>
+              <a:t>The cost: a change of plans for nothing.</a:t>
+            </a:r>
+            <a:endParaRPr lang="en-US" sz="1600" dirty="0"/>
+          </a:p>
+        </p:txBody>
+      </p:sp>
+      <p:sp>
+        <p:nvSpPr>
+          <p:cNvPr id="18" name="Our choice"/>
+          <p:cNvSpPr txBox="1"/>
+          <p:nvPr/>
+        </p:nvSpPr>
+        <p:spPr>
+          <a:xfrm>
+            <a:off x="868680" y="5532120"/>
             <a:ext cx="10469880" cy="457200"/>
           </a:xfrm>
           <a:prstGeom prst="rect">
@@ -11317,7 +13910,7 @@
         </p:nvSpPr>
         <p:spPr>
           <a:xfrm>
-            <a:off x="1280160" y="2148840"/>
+            <a:off x="1280160" y="2011680"/>
             <a:ext cx="9631375" cy="914400"/>
           </a:xfrm>
           <a:prstGeom prst="rect">
@@ -11356,8 +13949,8 @@
         </p:nvSpPr>
         <p:spPr>
           <a:xfrm>
-            <a:off x="868680" y="3429000"/>
-            <a:ext cx="3307080" cy="2011680"/>
+            <a:off x="868680" y="3108960"/>
+            <a:ext cx="3307080" cy="1600200"/>
           </a:xfrm>
           <a:prstGeom prst="rect">
             <a:avLst/>
@@ -11376,7 +13969,7 @@
         </p:nvSpPr>
         <p:spPr>
           <a:xfrm>
-            <a:off x="1143000" y="3703320"/>
+            <a:off x="1143000" y="3383280"/>
             <a:ext cx="640080" cy="640080"/>
           </a:xfrm>
           <a:prstGeom prst="ellipse">
@@ -11396,7 +13989,7 @@
         </p:nvSpPr>
         <p:spPr>
           <a:xfrm>
-            <a:off x="1143000" y="3703320"/>
+            <a:off x="1143000" y="3383280"/>
             <a:ext cx="640080" cy="640080"/>
           </a:xfrm>
           <a:prstGeom prst="rect">
@@ -11435,8 +14028,8 @@
         </p:nvSpPr>
         <p:spPr>
           <a:xfrm>
-            <a:off x="1143000" y="4480560"/>
-            <a:ext cx="2758440" cy="777240"/>
+            <a:off x="1143000" y="4160520"/>
+            <a:ext cx="2758440" cy="365760"/>
           </a:xfrm>
           <a:prstGeom prst="rect">
             <a:avLst/>
@@ -11471,8 +14064,8 @@
         </p:nvSpPr>
         <p:spPr>
           <a:xfrm>
-            <a:off x="4450080" y="3429000"/>
-            <a:ext cx="3307080" cy="2011680"/>
+            <a:off x="4450080" y="3108960"/>
+            <a:ext cx="3307080" cy="1600200"/>
           </a:xfrm>
           <a:prstGeom prst="rect">
             <a:avLst/>
@@ -11491,7 +14084,7 @@
         </p:nvSpPr>
         <p:spPr>
           <a:xfrm>
-            <a:off x="4724400" y="3703320"/>
+            <a:off x="4724400" y="3383280"/>
             <a:ext cx="640080" cy="640080"/>
           </a:xfrm>
           <a:prstGeom prst="ellipse">
@@ -11511,7 +14104,7 @@
         </p:nvSpPr>
         <p:spPr>
           <a:xfrm>
-            <a:off x="4724400" y="3703320"/>
+            <a:off x="4724400" y="3383280"/>
             <a:ext cx="640080" cy="640080"/>
           </a:xfrm>
           <a:prstGeom prst="rect">
@@ -11550,8 +14143,8 @@
         </p:nvSpPr>
         <p:spPr>
           <a:xfrm>
-            <a:off x="4724400" y="4480560"/>
-            <a:ext cx="2758440" cy="777240"/>
+            <a:off x="4724400" y="4160520"/>
+            <a:ext cx="2758440" cy="365760"/>
           </a:xfrm>
           <a:prstGeom prst="rect">
             <a:avLst/>
@@ -11586,8 +14179,8 @@
         </p:nvSpPr>
         <p:spPr>
           <a:xfrm>
-            <a:off x="8031480" y="3429000"/>
-            <a:ext cx="3307080" cy="2011680"/>
+            <a:off x="8031480" y="3108960"/>
+            <a:ext cx="3307080" cy="1600200"/>
           </a:xfrm>
           <a:prstGeom prst="rect">
             <a:avLst/>
@@ -11606,7 +14199,7 @@
         </p:nvSpPr>
         <p:spPr>
           <a:xfrm>
-            <a:off x="8305800" y="3703320"/>
+            <a:off x="8305800" y="3383280"/>
             <a:ext cx="640080" cy="640080"/>
           </a:xfrm>
           <a:prstGeom prst="ellipse">
@@ -11626,7 +14219,7 @@
         </p:nvSpPr>
         <p:spPr>
           <a:xfrm>
-            <a:off x="8305800" y="3703320"/>
+            <a:off x="8305800" y="3383280"/>
             <a:ext cx="640080" cy="640080"/>
           </a:xfrm>
           <a:prstGeom prst="rect">
@@ -11665,8 +14258,8 @@
         </p:nvSpPr>
         <p:spPr>
           <a:xfrm>
-            <a:off x="8305800" y="4480560"/>
-            <a:ext cx="2758440" cy="777240"/>
+            <a:off x="8305800" y="4160520"/>
+            <a:ext cx="2758440" cy="365760"/>
           </a:xfrm>
           <a:prstGeom prst="rect">
             <a:avLst/>
@@ -11690,6 +14283,311 @@
               <a:t>About 300</a:t>
             </a:r>
             <a:endParaRPr lang="en-US" sz="2400" dirty="0"/>
+          </a:p>
+        </p:txBody>
+      </p:sp>
+      <p:sp>
+        <p:nvSpPr>
+          <p:cNvPr id="17" name="Text 15"/>
+          <p:cNvSpPr txBox="1"/>
+          <p:nvPr/>
+        </p:nvSpPr>
+        <p:spPr>
+          <a:xfrm>
+            <a:off x="868680" y="5212080"/>
+            <a:ext cx="365760" cy="320040"/>
+          </a:xfrm>
+          <a:prstGeom prst="rect">
+            <a:avLst/>
+          </a:prstGeom>
+          <a:noFill/>
+          <a:ln/>
+        </p:spPr>
+        <p:txBody>
+          <a:bodyPr wrap="square" lIns="0" tIns="0" rIns="0" bIns="0" rtlCol="0" anchor="ctr"/>
+          <a:lstStyle/>
+          <a:p>
+            <a:pPr algn="r" indent="0" marL="0">
+              <a:buNone/>
+            </a:pPr>
+            <a:r>
+              <a:rPr lang="en-US" sz="1400" dirty="0">
+                <a:solidFill>
+                  <a:srgbClr val="6F5C51"/>
+                </a:solidFill>
+              </a:rPr>
+              <a:t>0</a:t>
+            </a:r>
+            <a:endParaRPr lang="en-US" sz="1400" dirty="0"/>
+          </a:p>
+        </p:txBody>
+      </p:sp>
+      <p:sp>
+        <p:nvSpPr>
+          <p:cNvPr id="18" name="Text 16"/>
+          <p:cNvSpPr txBox="1"/>
+          <p:nvPr/>
+        </p:nvSpPr>
+        <p:spPr>
+          <a:xfrm>
+            <a:off x="10972800" y="5212080"/>
+            <a:ext cx="548640" cy="320040"/>
+          </a:xfrm>
+          <a:prstGeom prst="rect">
+            <a:avLst/>
+          </a:prstGeom>
+          <a:noFill/>
+          <a:ln/>
+        </p:spPr>
+        <p:txBody>
+          <a:bodyPr wrap="square" lIns="0" tIns="0" rIns="0" bIns="0" rtlCol="0" anchor="ctr"/>
+          <a:lstStyle/>
+          <a:p>
+            <a:pPr indent="0" marL="0">
+              <a:buNone/>
+            </a:pPr>
+            <a:r>
+              <a:rPr lang="en-US" sz="1400" dirty="0">
+                <a:solidFill>
+                  <a:srgbClr val="6F5C51"/>
+                </a:solidFill>
+              </a:rPr>
+              <a:t>347</a:t>
+            </a:r>
+            <a:endParaRPr lang="en-US" sz="1400" dirty="0"/>
+          </a:p>
+        </p:txBody>
+      </p:sp>
+      <p:sp>
+        <p:nvSpPr>
+          <p:cNvPr id="19" name="Scale"/>
+          <p:cNvSpPr/>
+          <p:nvPr/>
+        </p:nvSpPr>
+        <p:spPr>
+          <a:xfrm>
+            <a:off x="1325880" y="5257800"/>
+            <a:ext cx="9555480" cy="237744"/>
+          </a:xfrm>
+          <a:prstGeom prst="rect">
+            <a:avLst/>
+          </a:prstGeom>
+          <a:solidFill>
+            <a:srgbClr val="F6C9A0"/>
+          </a:solidFill>
+          <a:ln/>
+        </p:spPr>
+      </p:sp>
+      <p:sp>
+        <p:nvSpPr>
+          <p:cNvPr id="20" name="Tick A"/>
+          <p:cNvSpPr/>
+          <p:nvPr/>
+        </p:nvSpPr>
+        <p:spPr>
+          <a:xfrm>
+            <a:off x="4061333" y="5148072"/>
+            <a:ext cx="36576" cy="457200"/>
+          </a:xfrm>
+          <a:prstGeom prst="rect">
+            <a:avLst/>
+          </a:prstGeom>
+          <a:solidFill>
+            <a:srgbClr val="A63A0C"/>
+          </a:solidFill>
+          <a:ln/>
+        </p:spPr>
+      </p:sp>
+      <p:sp>
+        <p:nvSpPr>
+          <p:cNvPr id="21" name="Text 19"/>
+          <p:cNvSpPr txBox="1"/>
+          <p:nvPr/>
+        </p:nvSpPr>
+        <p:spPr>
+          <a:xfrm>
+            <a:off x="3805301" y="5605272"/>
+            <a:ext cx="548640" cy="292608"/>
+          </a:xfrm>
+          <a:prstGeom prst="rect">
+            <a:avLst/>
+          </a:prstGeom>
+          <a:noFill/>
+          <a:ln/>
+        </p:spPr>
+        <p:txBody>
+          <a:bodyPr wrap="square" lIns="0" tIns="0" rIns="0" bIns="0" rtlCol="0" anchor="ctr"/>
+          <a:lstStyle/>
+          <a:p>
+            <a:pPr algn="ctr" indent="0" marL="0">
+              <a:buNone/>
+            </a:pPr>
+            <a:r>
+              <a:rPr lang="en-US" sz="1600" b="1" dirty="0">
+                <a:solidFill>
+                  <a:srgbClr val="A63A0C"/>
+                </a:solidFill>
+                <a:latin typeface="Cambria" pitchFamily="34" charset="0"/>
+                <a:ea typeface="Cambria" pitchFamily="34" charset="-122"/>
+                <a:cs typeface="Cambria" pitchFamily="34" charset="-120"/>
+              </a:rPr>
+              <a:t>A</a:t>
+            </a:r>
+            <a:endParaRPr lang="en-US" sz="1600" dirty="0"/>
+          </a:p>
+        </p:txBody>
+      </p:sp>
+      <p:sp>
+        <p:nvSpPr>
+          <p:cNvPr id="22" name="Tick B"/>
+          <p:cNvSpPr/>
+          <p:nvPr/>
+        </p:nvSpPr>
+        <p:spPr>
+          <a:xfrm>
+            <a:off x="6815073" y="5148072"/>
+            <a:ext cx="36576" cy="457200"/>
+          </a:xfrm>
+          <a:prstGeom prst="rect">
+            <a:avLst/>
+          </a:prstGeom>
+          <a:solidFill>
+            <a:srgbClr val="A63A0C"/>
+          </a:solidFill>
+          <a:ln/>
+        </p:spPr>
+      </p:sp>
+      <p:sp>
+        <p:nvSpPr>
+          <p:cNvPr id="23" name="Text 21"/>
+          <p:cNvSpPr txBox="1"/>
+          <p:nvPr/>
+        </p:nvSpPr>
+        <p:spPr>
+          <a:xfrm>
+            <a:off x="6559041" y="5605272"/>
+            <a:ext cx="548640" cy="292608"/>
+          </a:xfrm>
+          <a:prstGeom prst="rect">
+            <a:avLst/>
+          </a:prstGeom>
+          <a:noFill/>
+          <a:ln/>
+        </p:spPr>
+        <p:txBody>
+          <a:bodyPr wrap="square" lIns="0" tIns="0" rIns="0" bIns="0" rtlCol="0" anchor="ctr"/>
+          <a:lstStyle/>
+          <a:p>
+            <a:pPr algn="ctr" indent="0" marL="0">
+              <a:buNone/>
+            </a:pPr>
+            <a:r>
+              <a:rPr lang="en-US" sz="1600" b="1" dirty="0">
+                <a:solidFill>
+                  <a:srgbClr val="A63A0C"/>
+                </a:solidFill>
+                <a:latin typeface="Cambria" pitchFamily="34" charset="0"/>
+                <a:ea typeface="Cambria" pitchFamily="34" charset="-122"/>
+                <a:cs typeface="Cambria" pitchFamily="34" charset="-120"/>
+              </a:rPr>
+              <a:t>B</a:t>
+            </a:r>
+            <a:endParaRPr lang="en-US" sz="1600" dirty="0"/>
+          </a:p>
+        </p:txBody>
+      </p:sp>
+      <p:sp>
+        <p:nvSpPr>
+          <p:cNvPr id="24" name="Tick C"/>
+          <p:cNvSpPr/>
+          <p:nvPr/>
+        </p:nvSpPr>
+        <p:spPr>
+          <a:xfrm>
+            <a:off x="9568814" y="5148072"/>
+            <a:ext cx="36576" cy="457200"/>
+          </a:xfrm>
+          <a:prstGeom prst="rect">
+            <a:avLst/>
+          </a:prstGeom>
+          <a:solidFill>
+            <a:srgbClr val="A63A0C"/>
+          </a:solidFill>
+          <a:ln/>
+        </p:spPr>
+      </p:sp>
+      <p:sp>
+        <p:nvSpPr>
+          <p:cNvPr id="25" name="Text 23"/>
+          <p:cNvSpPr txBox="1"/>
+          <p:nvPr/>
+        </p:nvSpPr>
+        <p:spPr>
+          <a:xfrm>
+            <a:off x="9312782" y="5605272"/>
+            <a:ext cx="548640" cy="292608"/>
+          </a:xfrm>
+          <a:prstGeom prst="rect">
+            <a:avLst/>
+          </a:prstGeom>
+          <a:noFill/>
+          <a:ln/>
+        </p:spPr>
+        <p:txBody>
+          <a:bodyPr wrap="square" lIns="0" tIns="0" rIns="0" bIns="0" rtlCol="0" anchor="ctr"/>
+          <a:lstStyle/>
+          <a:p>
+            <a:pPr algn="ctr" indent="0" marL="0">
+              <a:buNone/>
+            </a:pPr>
+            <a:r>
+              <a:rPr lang="en-US" sz="1600" b="1" dirty="0">
+                <a:solidFill>
+                  <a:srgbClr val="A63A0C"/>
+                </a:solidFill>
+                <a:latin typeface="Cambria" pitchFamily="34" charset="0"/>
+                <a:ea typeface="Cambria" pitchFamily="34" charset="-122"/>
+                <a:cs typeface="Cambria" pitchFamily="34" charset="-120"/>
+              </a:rPr>
+              <a:t>C</a:t>
+            </a:r>
+            <a:endParaRPr lang="en-US" sz="1600" dirty="0"/>
+          </a:p>
+        </p:txBody>
+      </p:sp>
+      <p:sp>
+        <p:nvSpPr>
+          <p:cNvPr id="26" name="Hint"/>
+          <p:cNvSpPr txBox="1"/>
+          <p:nvPr/>
+        </p:nvSpPr>
+        <p:spPr>
+          <a:xfrm>
+            <a:off x="1325880" y="5870448"/>
+            <a:ext cx="9555480" cy="292608"/>
+          </a:xfrm>
+          <a:prstGeom prst="rect">
+            <a:avLst/>
+          </a:prstGeom>
+          <a:noFill/>
+          <a:ln/>
+        </p:spPr>
+        <p:txBody>
+          <a:bodyPr wrap="square" lIns="0" tIns="0" rIns="0" bIns="0" rtlCol="0" anchor="ctr"/>
+          <a:lstStyle/>
+          <a:p>
+            <a:pPr algn="ctr" indent="0" marL="0">
+              <a:buNone/>
+            </a:pPr>
+            <a:r>
+              <a:rPr lang="en-US" sz="1400" i="1" dirty="0">
+                <a:solidFill>
+                  <a:srgbClr val="6F5C51"/>
+                </a:solidFill>
+              </a:rPr>
+              <a:t>Hint: the copy-today rule caught 207.</a:t>
+            </a:r>
+            <a:endParaRPr lang="en-US" sz="1400" dirty="0"/>
           </a:p>
         </p:txBody>
       </p:sp>

</xml_diff>

<commit_message>
Presentation: replace the audience questions with explained slides
Slide 2 shows the three ways tomorrow can go instead of asking for a show of
hands, slide 7 labels which mistake is worse instead of a vote, slide 9 shows
Danger days caught by copy-today and the Random Forest instead of a guess, and
the demo uses Manila instead of asking for a city. Speaker script updated.

Co-Authored-By: Claude Opus 5.5 <noreply@anthropic.com>
Claude-Session: https://claude.ai/code/session_01NSSQLuCunKxZVNza71ab7L
</commit_message>
<xml_diff>
--- a/presentation/HeatCast_NCR_Presentation.pptx
+++ b/presentation/HeatCast_NCR_Presentation.pptx
@@ -120,7 +120,7 @@
   <p:extLst>
     <p:ext uri="{521415D9-36F7-43E2-AB2F-B90AF26B5E84}">
       <p14:sectionLst xmlns:p14="http://schemas.microsoft.com/office/powerpoint/2010/main">
-        <p14:section name="Introduction" id="{3538d1c1-eef5-ad91-c4a2-a3a4a40bfbcd}">
+        <p14:section name="Introduction" id="{13ee896f-aa68-b3d4-e357-76b9dc7d1c0b}">
           <p14:sldIdLst>
             <p14:sldId id="256"/>
             <p14:sldId id="257"/>
@@ -128,26 +128,26 @@
             <p14:sldId id="259"/>
           </p14:sldIdLst>
         </p14:section>
-        <p14:section name="Data" id="{80136c03-d1cb-a20c-8e70-ea1bf42a4662}">
+        <p14:section name="Data" id="{642d9082-6aac-3bbe-fb1a-e9c7fcdd40b4}">
           <p14:sldIdLst>
             <p14:sldId id="260"/>
           </p14:sldIdLst>
         </p14:section>
-        <p14:section name="Method" id="{406ff36f-d6fd-2b78-def8-344786839f78}">
+        <p14:section name="Method" id="{0495b958-324b-85dc-21a3-edbbef41bb53}">
           <p14:sldIdLst>
             <p14:sldId id="261"/>
             <p14:sldId id="262"/>
             <p14:sldId id="263"/>
           </p14:sldIdLst>
         </p14:section>
-        <p14:section name="Results" id="{cea43a8e-b401-b285-ef3e-de463edee67d}">
+        <p14:section name="Results" id="{e35a4aea-8052-c222-ffb4-a01745e82e29}">
           <p14:sldIdLst>
             <p14:sldId id="264"/>
             <p14:sldId id="265"/>
             <p14:sldId id="266"/>
           </p14:sldIdLst>
         </p14:section>
-        <p14:section name="Conclusion" id="{887be380-5587-ae5c-a807-03710bdb4315}">
+        <p14:section name="Conclusion" id="{d96605fd-4073-b8b5-5faf-dfb3b0683aea}">
           <p14:sldIdLst>
             <p14:sldId id="267"/>
             <p14:sldId id="268"/>
@@ -1845,7 +1845,7 @@
             <a:r>
               <a:rPr lang="en-US" dirty="0"/>
               <a:t>EDRIAN (20 seconds)
-Good morning. We are Edrian, Harry and Marc, and this is HeatCast NCR. Our question: can machine learning predict tomorrow's heat level in Metro Manila better than just copying today's level? Before we answer, a quick question for you.</a:t>
+Good morning. We are Edrian, Harry and Marc, and this is HeatCast NCR. Our question: can machine learning predict tomorrow's heat level in Metro Manila better than just copying today's level? Let's start with a simple example.</a:t>
             </a:r>
             <a:endParaRPr lang="en-US" dirty="0"/>
           </a:p>
@@ -1934,7 +1934,7 @@
             <a:r>
               <a:rPr lang="en-US" dirty="0"/>
               <a:t>MARC (50 seconds)
-The answer is C: it caught 293 of the 347 Danger days, 84%. Copying today caught only 207, 60%. The price: when it warned Danger, it was right only 36% of the time, about two false alarms for every real Danger day. And its overall score, 0.61, is below copy-today's 0.68. Remember our vote: we said missing a Danger day is worse than a false alarm. So it is not a better all-round forecaster, but it is a good early warning. Edrian will show it live.</a:t>
+Here is the full picture. Catching 293 Danger days has a price: when it warned Danger, it was right only 36% of the time, about two false alarms for every real Danger day. And its overall score, 0.61, is below copy-today's 0.68. Remember our choice: we said missing a Danger day is worse than a false alarm. So it is not a better all-round forecaster, but it is a good early warning. Edrian will show it live.</a:t>
             </a:r>
             <a:endParaRPr lang="en-US" dirty="0"/>
           </a:p>
@@ -2024,7 +2024,7 @@
               <a:rPr lang="en-US" dirty="0"/>
               <a:t>EDRIAN (1 minute 45)
 BEFORE THE TALK: open heatcast-ncr.streamlit.app; the first load can take about a minute. If the internet fails, show this screenshot, or run it locally with: streamlit run app/streamlit_app.py.
-Let's try it. Can someone pick a city? (Choose it at the top; the city lights up blue on the map.) Let's say today was very hot there: heat index 45.5, lowest temperature 29, rain 0, pressure 1008, sunshine 7000. Click the button. It predicts the level for tomorrow with the probability of each level, and the city takes that level's colour on the map. It also reminds users it is a decision aid, not a PAGASA advisory. Now a mistake on purpose: rain of minus 5. The app refuses it and shows the accepted range. And if we clear the form and click, it names every missing value instead of guessing. This is the same saved model that took the final exam, and the input checks are covered by 51 automated tests.</a:t>
+Let's try it with Manila. (Choose it at the top; the city lights up blue on the map.) Say today was very hot there: heat index 45.5, lowest temperature 29, rain 0, pressure 1008, sunshine 7000. Click the button. It predicts the level for tomorrow with the probability of each level, and the city takes that level's colour on the map. It also reminds users it is a decision aid, not a PAGASA advisory. Now a mistake on purpose: rain of minus 5. The app refuses it and shows the accepted range. And if we clear the form and click, it names every missing value instead of guessing. This is the same saved model that took the final exam, and the input checks are covered by 51 automated tests.</a:t>
             </a:r>
             <a:endParaRPr lang="en-US" dirty="0"/>
           </a:p>
@@ -2380,7 +2380,7 @@
             <a:r>
               <a:rPr lang="en-US" dirty="0"/>
               <a:t>EDRIAN (30 seconds)
-Show of hands. Today Manila's heat index reached 44 degrees, which is Danger. Tomorrow will be: A, hotter, Extreme Danger; B, the same level, Danger again; C, cooler. Who says A? B? C? (Count quickly.) Let's see how often the same level is right.</a:t>
+Here is our question as an example. Today Manila's heat index reached 44 degrees, which is Danger. Tomorrow can go three ways: hotter, Extreme Danger; the same level, Danger again; or cooler. HeatCast NCR has to pick one of these, for each of the 16 cities, every day. So which one happens most often?</a:t>
             </a:r>
             <a:endParaRPr lang="en-US" dirty="0"/>
           </a:p>
@@ -2469,7 +2469,7 @@
             <a:r>
               <a:rPr lang="en-US" dirty="0"/>
               <a:t>EDRIAN (20 seconds)
-Each square here is one percent of the city-days in 2025. In 82 out of every 100, tomorrow's level was the same as today's. So the simplest forecast, copy today, is already right most of the time. We call it the copy-today rule, and the real question of our project is whether machine learning can beat it.</a:t>
+Most often, the same level. Each square here is one percent of the city-days in 2025. In 82 out of every 100, tomorrow's level was the same as today's. So the simplest forecast, copy today, is already right most of the time. We call it the copy-today rule, and the real question of our project is whether machine learning can beat it.</a:t>
             </a:r>
             <a:endParaRPr lang="en-US" dirty="0"/>
           </a:p>
@@ -2825,7 +2825,7 @@
             <a:r>
               <a:rPr lang="en-US" dirty="0"/>
               <a:t>MARC (40 seconds)
-Every forecast makes mistakes, so we had to decide which mistake hurts more. Vote with your hands: A, missing a real Danger day, so nobody prepares and someone may get sick; or B, a false alarm, activities are moved for nothing. Who says A? B? We agreed A is worse: a missed Danger day can hurt people, while a false alarm costs a change of plans. That is why our rule asks a model to catch more Danger days first. Keep this in mind for the results.</a:t>
+Every forecast is sometimes wrong, and it can be wrong in two ways. One: it misses a real Danger day, so nobody prepares, students play outside at 44 degrees, and someone may get sick. Two: a false alarm, so activities are moved indoors on a day that was not that hot. We decided the first mistake is worse: a missed Danger day can hurt people, while a false alarm only costs a change of plans. That is why our rule asks a model to catch more Danger days first. Keep this in mind for the results.</a:t>
             </a:r>
             <a:endParaRPr lang="en-US" dirty="0"/>
           </a:p>
@@ -3004,8 +3004,8 @@
           <a:p>
             <a:r>
               <a:rPr lang="en-US" dirty="0"/>
-              <a:t>MARC (20 seconds)
-Now the final exam, 2025, which we opened only once. There were 347 Danger days across the 16 cities. How many did our model catch: about 100, about 200 or about 300? A hint: copying today caught 207. Hands up for A... B... C...</a:t>
+              <a:t>MARC (25 seconds)
+Now the final exam, 2025, which we opened only once. There were 347 Danger days across the 16 cities. Copying today warned about 207 of them, 60%. Our Random Forest warned about 293, 84%. That is 86 more Danger days with a warning the day before.</a:t>
             </a:r>
             <a:endParaRPr lang="en-US" dirty="0"/>
           </a:p>
@@ -4665,7 +4665,7 @@
                 <a:ea typeface="Cambria" pitchFamily="34" charset="-122"/>
                 <a:cs typeface="Cambria" pitchFamily="34" charset="-120"/>
               </a:rPr>
-              <a:t>You pick a city</a:t>
+              <a:t>A hot day in Manila</a:t>
             </a:r>
             <a:endParaRPr lang="en-US" sz="2000" dirty="0"/>
           </a:p>
@@ -4679,7 +4679,7 @@
                   <a:srgbClr val="6F5C51"/>
                 </a:solidFill>
               </a:rPr>
-              <a:t>Call out a city. We type a hot day: heat index 45.5 °C, lowest 29 °C, no rain, 1,008 hPa, sunshine 7,000.</a:t>
+              <a:t>We choose Manila and type a hot day: heat index 45.5 °C, lowest 29 °C, no rain, 1,008 hPa, sunshine 7,000.</a:t>
             </a:r>
             <a:endParaRPr lang="en-US" sz="2000" dirty="0"/>
           </a:p>
@@ -7244,7 +7244,7 @@
                 <a:ea typeface="Cambria" pitchFamily="34" charset="-122"/>
                 <a:cs typeface="Cambria" pitchFamily="34" charset="-120"/>
               </a:rPr>
-              <a:t>QUICK QUESTION</a:t>
+              <a:t>OUR QUESTION</a:t>
             </a:r>
             <a:endParaRPr lang="en-US" sz="3400" dirty="0"/>
           </a:p>
@@ -7258,8 +7258,8 @@
         </p:nvSpPr>
         <p:spPr>
           <a:xfrm>
-            <a:off x="4632808" y="1417320"/>
-            <a:ext cx="2926080" cy="420624"/>
+            <a:off x="4449928" y="1417320"/>
+            <a:ext cx="3291840" cy="420624"/>
           </a:xfrm>
           <a:prstGeom prst="rect">
             <a:avLst/>
@@ -7277,12 +7277,12 @@
               <a:buNone/>
             </a:pPr>
             <a:r>
-              <a:rPr lang="en-US" sz="1500" b="1" spc="100" kern="0" dirty="0">
+              <a:rPr lang="en-US" sz="1500" spc="100" kern="0" dirty="0">
                 <a:solidFill>
                   <a:srgbClr val="2E1406"/>
                 </a:solidFill>
               </a:rPr>
-              <a:t>Raise your hand</a:t>
+              <a:t>One city, one day ahead</a:t>
             </a:r>
             <a:endParaRPr lang="en-US" sz="1500" dirty="0"/>
           </a:p>
@@ -7290,14 +7290,14 @@
       </p:sp>
       <p:sp>
         <p:nvSpPr>
-          <p:cNvPr id="4" name="Question text"/>
+          <p:cNvPr id="4" name="Example"/>
           <p:cNvSpPr txBox="1"/>
           <p:nvPr/>
         </p:nvSpPr>
         <p:spPr>
           <a:xfrm>
-            <a:off x="1280160" y="2011680"/>
-            <a:ext cx="9631375" cy="914400"/>
+            <a:off x="1097280" y="1965960"/>
+            <a:ext cx="9997135" cy="914400"/>
           </a:xfrm>
           <a:prstGeom prst="rect">
             <a:avLst/>
@@ -7321,7 +7321,7 @@
                 <a:ea typeface="Cambria" pitchFamily="34" charset="-122"/>
                 <a:cs typeface="Cambria" pitchFamily="34" charset="-120"/>
               </a:rPr>
-              <a:t>Today, Manila's heat index reached 44 °C, which is Danger. What will tomorrow's level be?</a:t>
+              <a:t>Today, Manila's heat index reached 44 °C, which is Danger. Tomorrow can go one of three ways:</a:t>
             </a:r>
             <a:endParaRPr lang="en-US" sz="2800" dirty="0"/>
           </a:p>
@@ -7329,14 +7329,14 @@
       </p:sp>
       <p:sp>
         <p:nvSpPr>
-          <p:cNvPr id="5" name="Option A"/>
-          <p:cNvSpPr/>
-          <p:nvPr/>
-        </p:nvSpPr>
-        <p:spPr>
-          <a:xfrm>
-            <a:off x="868680" y="3154680"/>
-            <a:ext cx="3374136" cy="2834640"/>
+          <p:cNvPr id="5" name="Outcome Hotter"/>
+          <p:cNvSpPr/>
+          <p:nvPr/>
+        </p:nvSpPr>
+        <p:spPr>
+          <a:xfrm>
+            <a:off x="868680" y="3063240"/>
+            <a:ext cx="3374136" cy="2377440"/>
           </a:xfrm>
           <a:prstGeom prst="rect">
             <a:avLst/>
@@ -7346,69 +7346,10 @@
           </a:solidFill>
           <a:ln/>
         </p:spPr>
-      </p:sp>
-      <p:sp>
-        <p:nvSpPr>
-          <p:cNvPr id="6" name="Option dot A"/>
-          <p:cNvSpPr/>
-          <p:nvPr/>
-        </p:nvSpPr>
-        <p:spPr>
-          <a:xfrm>
-            <a:off x="1143000" y="3429000"/>
-            <a:ext cx="640080" cy="640080"/>
-          </a:xfrm>
-          <a:prstGeom prst="ellipse">
-            <a:avLst/>
-          </a:prstGeom>
-          <a:solidFill>
-            <a:srgbClr val="A63A0C"/>
-          </a:solidFill>
-          <a:ln/>
-        </p:spPr>
-      </p:sp>
-      <p:sp>
-        <p:nvSpPr>
-          <p:cNvPr id="7" name="Text 5"/>
-          <p:cNvSpPr txBox="1"/>
-          <p:nvPr/>
-        </p:nvSpPr>
-        <p:spPr>
-          <a:xfrm>
-            <a:off x="1143000" y="3429000"/>
-            <a:ext cx="640080" cy="640080"/>
-          </a:xfrm>
-          <a:prstGeom prst="rect">
-            <a:avLst/>
-          </a:prstGeom>
-          <a:noFill/>
-          <a:ln/>
-        </p:spPr>
-        <p:txBody>
-          <a:bodyPr wrap="square" lIns="0" tIns="0" rIns="0" bIns="0" rtlCol="0" anchor="ctr"/>
-          <a:lstStyle/>
-          <a:p>
-            <a:pPr algn="ctr" indent="0" marL="0">
-              <a:buNone/>
-            </a:pPr>
-            <a:r>
-              <a:rPr lang="en-US" sz="2600" dirty="0">
-                <a:solidFill>
-                  <a:srgbClr val="FFFFFF"/>
-                </a:solidFill>
-                <a:latin typeface="Cambria" pitchFamily="34" charset="0"/>
-                <a:ea typeface="Cambria" pitchFamily="34" charset="-122"/>
-                <a:cs typeface="Cambria" pitchFamily="34" charset="-120"/>
-              </a:rPr>
-              <a:t>A</a:t>
-            </a:r>
-            <a:endParaRPr lang="en-US" sz="2600" dirty="0"/>
-          </a:p>
-        </p:txBody>
       </p:sp>
       <p:pic>
         <p:nvPicPr>
-          <p:cNvPr id="8" name="Option icon A" descr="Hotter">    </p:cNvPr>
+          <p:cNvPr id="6" name="Outcome icon 1" descr="Hotter">    </p:cNvPr>
           <p:cNvPicPr>
             <a:picLocks noChangeAspect="1"/>
           </p:cNvPicPr>
@@ -7422,7 +7363,7 @@
         </p:blipFill>
         <p:spPr>
           <a:xfrm>
-            <a:off x="3191256" y="3410712"/>
+            <a:off x="1143000" y="3337560"/>
             <a:ext cx="731520" cy="731520"/>
           </a:xfrm>
           <a:prstGeom prst="rect">
@@ -7432,14 +7373,14 @@
       </p:pic>
       <p:sp>
         <p:nvSpPr>
-          <p:cNvPr id="9" name="Option head A"/>
+          <p:cNvPr id="7" name="Outcome head 1"/>
           <p:cNvSpPr txBox="1"/>
           <p:nvPr/>
         </p:nvSpPr>
         <p:spPr>
           <a:xfrm>
-            <a:off x="1143000" y="4251960"/>
-            <a:ext cx="2825496" cy="548640"/>
+            <a:off x="2057400" y="3337560"/>
+            <a:ext cx="1911096" cy="731520"/>
           </a:xfrm>
           <a:prstGeom prst="rect">
             <a:avLst/>
@@ -7471,14 +7412,14 @@
       </p:sp>
       <p:sp>
         <p:nvSpPr>
-          <p:cNvPr id="10" name="Option level A"/>
+          <p:cNvPr id="8" name="Outcome level 1"/>
           <p:cNvSpPr txBox="1"/>
           <p:nvPr/>
         </p:nvSpPr>
         <p:spPr>
           <a:xfrm>
-            <a:off x="1143000" y="4937760"/>
-            <a:ext cx="2825496" cy="777240"/>
+            <a:off x="1143000" y="4343400"/>
+            <a:ext cx="2825496" cy="822960"/>
           </a:xfrm>
           <a:prstGeom prst="rect">
             <a:avLst/>
@@ -7496,41 +7437,41 @@
               <a:buNone/>
             </a:pPr>
             <a:r>
-              <a:rPr lang="en-US" sz="1600" b="1" dirty="0">
+              <a:rPr lang="en-US" sz="1700" b="1" dirty="0">
                 <a:solidFill>
                   <a:srgbClr val="FFFFFF"/>
                 </a:solidFill>
               </a:rPr>
               <a:t>Extreme Danger</a:t>
             </a:r>
-            <a:endParaRPr lang="en-US" sz="1600" dirty="0"/>
+            <a:endParaRPr lang="en-US" sz="1700" dirty="0"/>
           </a:p>
           <a:p>
             <a:pPr algn="ctr" indent="0" marL="0">
               <a:buNone/>
             </a:pPr>
             <a:r>
-              <a:rPr lang="en-US" sz="1600" dirty="0">
+              <a:rPr lang="en-US" sz="1700" dirty="0">
                 <a:solidFill>
                   <a:srgbClr val="FFFFFF"/>
                 </a:solidFill>
               </a:rPr>
-              <a:t>52 °C and up</a:t>
-            </a:r>
-            <a:endParaRPr lang="en-US" sz="1600" dirty="0"/>
-          </a:p>
-        </p:txBody>
-      </p:sp>
-      <p:sp>
-        <p:nvSpPr>
-          <p:cNvPr id="11" name="Option B"/>
-          <p:cNvSpPr/>
-          <p:nvPr/>
-        </p:nvSpPr>
-        <p:spPr>
-          <a:xfrm>
-            <a:off x="4416552" y="3154680"/>
-            <a:ext cx="3374136" cy="2834640"/>
+              <a:t>52 °C and up</a:t>
+            </a:r>
+            <a:endParaRPr lang="en-US" sz="1700" dirty="0"/>
+          </a:p>
+        </p:txBody>
+      </p:sp>
+      <p:sp>
+        <p:nvSpPr>
+          <p:cNvPr id="9" name="Outcome Same level"/>
+          <p:cNvSpPr/>
+          <p:nvPr/>
+        </p:nvSpPr>
+        <p:spPr>
+          <a:xfrm>
+            <a:off x="4416552" y="3063240"/>
+            <a:ext cx="3374136" cy="2377440"/>
           </a:xfrm>
           <a:prstGeom prst="rect">
             <a:avLst/>
@@ -7540,69 +7481,10 @@
           </a:solidFill>
           <a:ln/>
         </p:spPr>
-      </p:sp>
-      <p:sp>
-        <p:nvSpPr>
-          <p:cNvPr id="12" name="Option dot B"/>
-          <p:cNvSpPr/>
-          <p:nvPr/>
-        </p:nvSpPr>
-        <p:spPr>
-          <a:xfrm>
-            <a:off x="4690872" y="3429000"/>
-            <a:ext cx="640080" cy="640080"/>
-          </a:xfrm>
-          <a:prstGeom prst="ellipse">
-            <a:avLst/>
-          </a:prstGeom>
-          <a:solidFill>
-            <a:srgbClr val="A63A0C"/>
-          </a:solidFill>
-          <a:ln/>
-        </p:spPr>
-      </p:sp>
-      <p:sp>
-        <p:nvSpPr>
-          <p:cNvPr id="13" name="Text 10"/>
-          <p:cNvSpPr txBox="1"/>
-          <p:nvPr/>
-        </p:nvSpPr>
-        <p:spPr>
-          <a:xfrm>
-            <a:off x="4690872" y="3429000"/>
-            <a:ext cx="640080" cy="640080"/>
-          </a:xfrm>
-          <a:prstGeom prst="rect">
-            <a:avLst/>
-          </a:prstGeom>
-          <a:noFill/>
-          <a:ln/>
-        </p:spPr>
-        <p:txBody>
-          <a:bodyPr wrap="square" lIns="0" tIns="0" rIns="0" bIns="0" rtlCol="0" anchor="ctr"/>
-          <a:lstStyle/>
-          <a:p>
-            <a:pPr algn="ctr" indent="0" marL="0">
-              <a:buNone/>
-            </a:pPr>
-            <a:r>
-              <a:rPr lang="en-US" sz="2600" dirty="0">
-                <a:solidFill>
-                  <a:srgbClr val="FFFFFF"/>
-                </a:solidFill>
-                <a:latin typeface="Cambria" pitchFamily="34" charset="0"/>
-                <a:ea typeface="Cambria" pitchFamily="34" charset="-122"/>
-                <a:cs typeface="Cambria" pitchFamily="34" charset="-120"/>
-              </a:rPr>
-              <a:t>B</a:t>
-            </a:r>
-            <a:endParaRPr lang="en-US" sz="2600" dirty="0"/>
-          </a:p>
-        </p:txBody>
       </p:sp>
       <p:pic>
         <p:nvPicPr>
-          <p:cNvPr id="14" name="Option icon B" descr="The same level">    </p:cNvPr>
+          <p:cNvPr id="10" name="Outcome icon 2" descr="Same level">    </p:cNvPr>
           <p:cNvPicPr>
             <a:picLocks noChangeAspect="1"/>
           </p:cNvPicPr>
@@ -7616,7 +7498,7 @@
         </p:blipFill>
         <p:spPr>
           <a:xfrm>
-            <a:off x="6739128" y="3410712"/>
+            <a:off x="4690872" y="3337560"/>
             <a:ext cx="731520" cy="731520"/>
           </a:xfrm>
           <a:prstGeom prst="rect">
@@ -7626,14 +7508,14 @@
       </p:pic>
       <p:sp>
         <p:nvSpPr>
-          <p:cNvPr id="15" name="Option head B"/>
+          <p:cNvPr id="11" name="Outcome head 2"/>
           <p:cNvSpPr txBox="1"/>
           <p:nvPr/>
         </p:nvSpPr>
         <p:spPr>
           <a:xfrm>
-            <a:off x="4690872" y="4251960"/>
-            <a:ext cx="2825496" cy="548640"/>
+            <a:off x="5605272" y="3337560"/>
+            <a:ext cx="1911096" cy="731520"/>
           </a:xfrm>
           <a:prstGeom prst="rect">
             <a:avLst/>
@@ -7657,7 +7539,7 @@
                 <a:ea typeface="Cambria" pitchFamily="34" charset="-122"/>
                 <a:cs typeface="Cambria" pitchFamily="34" charset="-120"/>
               </a:rPr>
-              <a:t>The same level</a:t>
+              <a:t>Same level</a:t>
             </a:r>
             <a:endParaRPr lang="en-US" sz="2600" dirty="0"/>
           </a:p>
@@ -7665,14 +7547,14 @@
       </p:sp>
       <p:sp>
         <p:nvSpPr>
-          <p:cNvPr id="16" name="Option level B"/>
+          <p:cNvPr id="12" name="Outcome level 2"/>
           <p:cNvSpPr txBox="1"/>
           <p:nvPr/>
         </p:nvSpPr>
         <p:spPr>
           <a:xfrm>
-            <a:off x="4690872" y="4937760"/>
-            <a:ext cx="2825496" cy="777240"/>
+            <a:off x="4690872" y="4343400"/>
+            <a:ext cx="2825496" cy="822960"/>
           </a:xfrm>
           <a:prstGeom prst="rect">
             <a:avLst/>
@@ -7690,41 +7572,41 @@
               <a:buNone/>
             </a:pPr>
             <a:r>
-              <a:rPr lang="en-US" sz="1600" b="1" dirty="0">
+              <a:rPr lang="en-US" sz="1700" b="1" dirty="0">
                 <a:solidFill>
                   <a:srgbClr val="FFFFFF"/>
                 </a:solidFill>
               </a:rPr>
               <a:t>Danger again</a:t>
             </a:r>
-            <a:endParaRPr lang="en-US" sz="1600" dirty="0"/>
+            <a:endParaRPr lang="en-US" sz="1700" dirty="0"/>
           </a:p>
           <a:p>
             <a:pPr algn="ctr" indent="0" marL="0">
               <a:buNone/>
             </a:pPr>
             <a:r>
-              <a:rPr lang="en-US" sz="1600" dirty="0">
+              <a:rPr lang="en-US" sz="1700" dirty="0">
                 <a:solidFill>
                   <a:srgbClr val="FFFFFF"/>
                 </a:solidFill>
               </a:rPr>
-              <a:t>42 to 51 °C</a:t>
-            </a:r>
-            <a:endParaRPr lang="en-US" sz="1600" dirty="0"/>
-          </a:p>
-        </p:txBody>
-      </p:sp>
-      <p:sp>
-        <p:nvSpPr>
-          <p:cNvPr id="17" name="Option C"/>
-          <p:cNvSpPr/>
-          <p:nvPr/>
-        </p:nvSpPr>
-        <p:spPr>
-          <a:xfrm>
-            <a:off x="7964424" y="3154680"/>
-            <a:ext cx="3374136" cy="2834640"/>
+              <a:t>42 to 51 °C</a:t>
+            </a:r>
+            <a:endParaRPr lang="en-US" sz="1700" dirty="0"/>
+          </a:p>
+        </p:txBody>
+      </p:sp>
+      <p:sp>
+        <p:nvSpPr>
+          <p:cNvPr id="13" name="Outcome Cooler"/>
+          <p:cNvSpPr/>
+          <p:nvPr/>
+        </p:nvSpPr>
+        <p:spPr>
+          <a:xfrm>
+            <a:off x="7964424" y="3063240"/>
+            <a:ext cx="3374136" cy="2377440"/>
           </a:xfrm>
           <a:prstGeom prst="rect">
             <a:avLst/>
@@ -7734,69 +7616,10 @@
           </a:solidFill>
           <a:ln/>
         </p:spPr>
-      </p:sp>
-      <p:sp>
-        <p:nvSpPr>
-          <p:cNvPr id="18" name="Option dot C"/>
-          <p:cNvSpPr/>
-          <p:nvPr/>
-        </p:nvSpPr>
-        <p:spPr>
-          <a:xfrm>
-            <a:off x="8238744" y="3429000"/>
-            <a:ext cx="640080" cy="640080"/>
-          </a:xfrm>
-          <a:prstGeom prst="ellipse">
-            <a:avLst/>
-          </a:prstGeom>
-          <a:solidFill>
-            <a:srgbClr val="A63A0C"/>
-          </a:solidFill>
-          <a:ln/>
-        </p:spPr>
-      </p:sp>
-      <p:sp>
-        <p:nvSpPr>
-          <p:cNvPr id="19" name="Text 15"/>
-          <p:cNvSpPr txBox="1"/>
-          <p:nvPr/>
-        </p:nvSpPr>
-        <p:spPr>
-          <a:xfrm>
-            <a:off x="8238744" y="3429000"/>
-            <a:ext cx="640080" cy="640080"/>
-          </a:xfrm>
-          <a:prstGeom prst="rect">
-            <a:avLst/>
-          </a:prstGeom>
-          <a:noFill/>
-          <a:ln/>
-        </p:spPr>
-        <p:txBody>
-          <a:bodyPr wrap="square" lIns="0" tIns="0" rIns="0" bIns="0" rtlCol="0" anchor="ctr"/>
-          <a:lstStyle/>
-          <a:p>
-            <a:pPr algn="ctr" indent="0" marL="0">
-              <a:buNone/>
-            </a:pPr>
-            <a:r>
-              <a:rPr lang="en-US" sz="2600" dirty="0">
-                <a:solidFill>
-                  <a:srgbClr val="FFFFFF"/>
-                </a:solidFill>
-                <a:latin typeface="Cambria" pitchFamily="34" charset="0"/>
-                <a:ea typeface="Cambria" pitchFamily="34" charset="-122"/>
-                <a:cs typeface="Cambria" pitchFamily="34" charset="-120"/>
-              </a:rPr>
-              <a:t>C</a:t>
-            </a:r>
-            <a:endParaRPr lang="en-US" sz="2600" dirty="0"/>
-          </a:p>
-        </p:txBody>
       </p:sp>
       <p:pic>
         <p:nvPicPr>
-          <p:cNvPr id="20" name="Option icon C" descr="Cooler">    </p:cNvPr>
+          <p:cNvPr id="14" name="Outcome icon 3" descr="Cooler">    </p:cNvPr>
           <p:cNvPicPr>
             <a:picLocks noChangeAspect="1"/>
           </p:cNvPicPr>
@@ -7810,7 +7633,7 @@
         </p:blipFill>
         <p:spPr>
           <a:xfrm>
-            <a:off x="10287000" y="3410712"/>
+            <a:off x="8238744" y="3337560"/>
             <a:ext cx="731520" cy="731520"/>
           </a:xfrm>
           <a:prstGeom prst="rect">
@@ -7820,14 +7643,14 @@
       </p:pic>
       <p:sp>
         <p:nvSpPr>
-          <p:cNvPr id="21" name="Option head C"/>
+          <p:cNvPr id="15" name="Outcome head 3"/>
           <p:cNvSpPr txBox="1"/>
           <p:nvPr/>
         </p:nvSpPr>
         <p:spPr>
           <a:xfrm>
-            <a:off x="8238744" y="4251960"/>
-            <a:ext cx="2825496" cy="548640"/>
+            <a:off x="9153144" y="3337560"/>
+            <a:ext cx="1911096" cy="731520"/>
           </a:xfrm>
           <a:prstGeom prst="rect">
             <a:avLst/>
@@ -7859,14 +7682,14 @@
       </p:sp>
       <p:sp>
         <p:nvSpPr>
-          <p:cNvPr id="22" name="Option level C"/>
+          <p:cNvPr id="16" name="Outcome level 3"/>
           <p:cNvSpPr txBox="1"/>
           <p:nvPr/>
         </p:nvSpPr>
         <p:spPr>
           <a:xfrm>
-            <a:off x="8238744" y="4937760"/>
-            <a:ext cx="2825496" cy="777240"/>
+            <a:off x="8238744" y="4343400"/>
+            <a:ext cx="2825496" cy="822960"/>
           </a:xfrm>
           <a:prstGeom prst="rect">
             <a:avLst/>
@@ -7884,28 +7707,67 @@
               <a:buNone/>
             </a:pPr>
             <a:r>
-              <a:rPr lang="en-US" sz="1600" b="1" dirty="0">
+              <a:rPr lang="en-US" sz="1700" b="1" dirty="0">
                 <a:solidFill>
                   <a:srgbClr val="2E1406"/>
                 </a:solidFill>
               </a:rPr>
               <a:t>Extreme Caution or lower</a:t>
             </a:r>
-            <a:endParaRPr lang="en-US" sz="1600" dirty="0"/>
+            <a:endParaRPr lang="en-US" sz="1700" dirty="0"/>
           </a:p>
           <a:p>
             <a:pPr algn="ctr" indent="0" marL="0">
               <a:buNone/>
             </a:pPr>
             <a:r>
-              <a:rPr lang="en-US" sz="1600" dirty="0">
+              <a:rPr lang="en-US" sz="1700" dirty="0">
                 <a:solidFill>
                   <a:srgbClr val="2E1406"/>
                 </a:solidFill>
               </a:rPr>
-              <a:t>below 42 °C</a:t>
-            </a:r>
-            <a:endParaRPr lang="en-US" sz="1600" dirty="0"/>
+              <a:t>below 42 °C</a:t>
+            </a:r>
+            <a:endParaRPr lang="en-US" sz="1700" dirty="0"/>
+          </a:p>
+        </p:txBody>
+      </p:sp>
+      <p:sp>
+        <p:nvSpPr>
+          <p:cNvPr id="17" name="Our job"/>
+          <p:cNvSpPr txBox="1"/>
+          <p:nvPr/>
+        </p:nvSpPr>
+        <p:spPr>
+          <a:xfrm>
+            <a:off x="868680" y="5577840"/>
+            <a:ext cx="10469880" cy="411480"/>
+          </a:xfrm>
+          <a:prstGeom prst="rect">
+            <a:avLst/>
+          </a:prstGeom>
+          <a:noFill/>
+          <a:ln/>
+        </p:spPr>
+        <p:txBody>
+          <a:bodyPr wrap="square" rtlCol="0" anchor="ctr"/>
+          <a:lstStyle/>
+          <a:p>
+            <a:pPr algn="ctr" indent="0" marL="0">
+              <a:buNone/>
+            </a:pPr>
+            <a:r>
+              <a:rPr lang="en-US" sz="2000" i="1" dirty="0">
+                <a:solidFill>
+                  <a:srgbClr val="A63A0C"/>
+                </a:solidFill>
+                <a:latin typeface="Cambria" pitchFamily="34" charset="0"/>
+                <a:ea typeface="Cambria" pitchFamily="34" charset="-122"/>
+                <a:cs typeface="Cambria" pitchFamily="34" charset="-120"/>
+              </a:rPr>
+              <a:t>HeatCast NCR picks one of these for each of the 16 cities, every day.</a:t>
+            </a:r>
+            <a:endParaRPr lang="en-US" sz="2000" dirty="0"/>
           </a:p>
         </p:txBody>
       </p:sp>
@@ -12737,8 +12599,8 @@
         </p:nvSpPr>
         <p:spPr>
           <a:xfrm>
-            <a:off x="3992728" y="1417320"/>
-            <a:ext cx="4206240" cy="420624"/>
+            <a:off x="3078328" y="1417320"/>
+            <a:ext cx="6035040" cy="420624"/>
           </a:xfrm>
           <a:prstGeom prst="rect">
             <a:avLst/>
@@ -12756,12 +12618,12 @@
               <a:buNone/>
             </a:pPr>
             <a:r>
-              <a:rPr lang="en-US" sz="1500" b="1" spc="100" kern="0" dirty="0">
+              <a:rPr lang="en-US" sz="1500" spc="100" kern="0" dirty="0">
                 <a:solidFill>
                   <a:srgbClr val="2E1406"/>
                 </a:solidFill>
               </a:rPr>
-              <a:t>Vote: raise your hand for A or B</a:t>
+              <a:t>Every forecast is sometimes wrong, in one of two ways</a:t>
             </a:r>
             <a:endParaRPr lang="en-US" sz="1500" dirty="0"/>
           </a:p>
@@ -12769,7 +12631,7 @@
       </p:sp>
       <p:sp>
         <p:nvSpPr>
-          <p:cNvPr id="4" name="Option A"/>
+          <p:cNvPr id="4" name="Mistake 1"/>
           <p:cNvSpPr/>
           <p:nvPr/>
         </p:nvSpPr>
@@ -12787,68 +12649,9 @@
           <a:ln/>
         </p:spPr>
       </p:sp>
-      <p:sp>
-        <p:nvSpPr>
-          <p:cNvPr id="5" name="Option dot A"/>
-          <p:cNvSpPr/>
-          <p:nvPr/>
-        </p:nvSpPr>
-        <p:spPr>
-          <a:xfrm>
-            <a:off x="1188720" y="2423160"/>
-            <a:ext cx="685800" cy="685800"/>
-          </a:xfrm>
-          <a:prstGeom prst="ellipse">
-            <a:avLst/>
-          </a:prstGeom>
-          <a:solidFill>
-            <a:srgbClr val="A63A0C"/>
-          </a:solidFill>
-          <a:ln/>
-        </p:spPr>
-      </p:sp>
-      <p:sp>
-        <p:nvSpPr>
-          <p:cNvPr id="6" name="Text 4"/>
-          <p:cNvSpPr txBox="1"/>
-          <p:nvPr/>
-        </p:nvSpPr>
-        <p:spPr>
-          <a:xfrm>
-            <a:off x="1188720" y="2423160"/>
-            <a:ext cx="685800" cy="685800"/>
-          </a:xfrm>
-          <a:prstGeom prst="rect">
-            <a:avLst/>
-          </a:prstGeom>
-          <a:noFill/>
-          <a:ln/>
-        </p:spPr>
-        <p:txBody>
-          <a:bodyPr wrap="square" lIns="0" tIns="0" rIns="0" bIns="0" rtlCol="0" anchor="ctr"/>
-          <a:lstStyle/>
-          <a:p>
-            <a:pPr algn="ctr" indent="0" marL="0">
-              <a:buNone/>
-            </a:pPr>
-            <a:r>
-              <a:rPr lang="en-US" sz="2800" dirty="0">
-                <a:solidFill>
-                  <a:srgbClr val="FFFFFF"/>
-                </a:solidFill>
-                <a:latin typeface="Cambria" pitchFamily="34" charset="0"/>
-                <a:ea typeface="Cambria" pitchFamily="34" charset="-122"/>
-                <a:cs typeface="Cambria" pitchFamily="34" charset="-120"/>
-              </a:rPr>
-              <a:t>A</a:t>
-            </a:r>
-            <a:endParaRPr lang="en-US" sz="2800" dirty="0"/>
-          </a:p>
-        </p:txBody>
-      </p:sp>
       <p:pic>
         <p:nvPicPr>
-          <p:cNvPr id="7" name="Option icon A" descr="Missing a real Danger day">    </p:cNvPr>
+          <p:cNvPr id="5" name="Mistake icon 1" descr="Missing a real Danger day">    </p:cNvPr>
           <p:cNvPicPr>
             <a:picLocks noChangeAspect="1"/>
           </p:cNvPicPr>
@@ -12862,7 +12665,7 @@
         </p:blipFill>
         <p:spPr>
           <a:xfrm>
-            <a:off x="4732020" y="2377440"/>
+            <a:off x="1188720" y="2377440"/>
             <a:ext cx="914400" cy="914400"/>
           </a:xfrm>
           <a:prstGeom prst="rect">
@@ -12872,7 +12675,45 @@
       </p:pic>
       <p:sp>
         <p:nvSpPr>
-          <p:cNvPr id="8" name="Text 5"/>
+          <p:cNvPr id="6" name="Mistake tag 1"/>
+          <p:cNvSpPr txBox="1"/>
+          <p:nvPr/>
+        </p:nvSpPr>
+        <p:spPr>
+          <a:xfrm>
+            <a:off x="4137660" y="2423160"/>
+            <a:ext cx="1508760" cy="384048"/>
+          </a:xfrm>
+          <a:prstGeom prst="rect">
+            <a:avLst/>
+          </a:prstGeom>
+          <a:solidFill>
+            <a:srgbClr val="C0392B"/>
+          </a:solidFill>
+          <a:ln/>
+        </p:spPr>
+        <p:txBody>
+          <a:bodyPr wrap="square" lIns="0" tIns="0" rIns="0" bIns="0" rtlCol="0" anchor="ctr"/>
+          <a:lstStyle/>
+          <a:p>
+            <a:pPr algn="ctr" indent="0" marL="0">
+              <a:buNone/>
+            </a:pPr>
+            <a:r>
+              <a:rPr lang="en-US" sz="1300" b="1" spc="100" kern="0" dirty="0">
+                <a:solidFill>
+                  <a:srgbClr val="FFFFFF"/>
+                </a:solidFill>
+              </a:rPr>
+              <a:t>WORSE</a:t>
+            </a:r>
+            <a:endParaRPr lang="en-US" sz="1300" dirty="0"/>
+          </a:p>
+        </p:txBody>
+      </p:sp>
+      <p:sp>
+        <p:nvSpPr>
+          <p:cNvPr id="7" name="Text 4"/>
           <p:cNvSpPr txBox="1"/>
           <p:nvPr/>
         </p:nvSpPr>
@@ -12911,48 +12752,48 @@
       </p:sp>
       <p:sp>
         <p:nvSpPr>
+          <p:cNvPr id="8" name="Text 5"/>
+          <p:cNvSpPr txBox="1"/>
+          <p:nvPr/>
+        </p:nvSpPr>
+        <p:spPr>
+          <a:xfrm>
+            <a:off x="1188720" y="3886200"/>
+            <a:ext cx="4457700" cy="685800"/>
+          </a:xfrm>
+          <a:prstGeom prst="rect">
+            <a:avLst/>
+          </a:prstGeom>
+          <a:noFill/>
+          <a:ln/>
+        </p:spPr>
+        <p:txBody>
+          <a:bodyPr wrap="square" lIns="0" tIns="0" rIns="0" bIns="0" rtlCol="0" anchor="t"/>
+          <a:lstStyle/>
+          <a:p>
+            <a:pPr indent="0" marL="0">
+              <a:buNone/>
+            </a:pPr>
+            <a:r>
+              <a:rPr lang="en-US" sz="1800" dirty="0">
+                <a:solidFill>
+                  <a:srgbClr val="2E1406"/>
+                </a:solidFill>
+              </a:rPr>
+              <a:t>Nobody prepares, and students play outside at 44 °C.</a:t>
+            </a:r>
+            <a:endParaRPr lang="en-US" sz="1800" dirty="0"/>
+          </a:p>
+        </p:txBody>
+      </p:sp>
+      <p:sp>
+        <p:nvSpPr>
           <p:cNvPr id="9" name="Text 6"/>
           <p:cNvSpPr txBox="1"/>
           <p:nvPr/>
         </p:nvSpPr>
         <p:spPr>
           <a:xfrm>
-            <a:off x="1188720" y="3886200"/>
-            <a:ext cx="4457700" cy="685800"/>
-          </a:xfrm>
-          <a:prstGeom prst="rect">
-            <a:avLst/>
-          </a:prstGeom>
-          <a:noFill/>
-          <a:ln/>
-        </p:spPr>
-        <p:txBody>
-          <a:bodyPr wrap="square" lIns="0" tIns="0" rIns="0" bIns="0" rtlCol="0" anchor="t"/>
-          <a:lstStyle/>
-          <a:p>
-            <a:pPr indent="0" marL="0">
-              <a:buNone/>
-            </a:pPr>
-            <a:r>
-              <a:rPr lang="en-US" sz="1800" dirty="0">
-                <a:solidFill>
-                  <a:srgbClr val="2E1406"/>
-                </a:solidFill>
-              </a:rPr>
-              <a:t>Nobody prepares, and students play outside at 44 °C.</a:t>
-            </a:r>
-            <a:endParaRPr lang="en-US" sz="1800" dirty="0"/>
-          </a:p>
-        </p:txBody>
-      </p:sp>
-      <p:sp>
-        <p:nvSpPr>
-          <p:cNvPr id="10" name="Text 7"/>
-          <p:cNvSpPr txBox="1"/>
-          <p:nvPr/>
-        </p:nvSpPr>
-        <p:spPr>
-          <a:xfrm>
             <a:off x="1188720" y="4617720"/>
             <a:ext cx="4457700" cy="548640"/>
           </a:xfrm>
@@ -12983,7 +12824,7 @@
       </p:sp>
       <p:sp>
         <p:nvSpPr>
-          <p:cNvPr id="11" name="Option B"/>
+          <p:cNvPr id="10" name="Mistake 2"/>
           <p:cNvSpPr/>
           <p:nvPr/>
         </p:nvSpPr>
@@ -13001,68 +12842,9 @@
           <a:ln/>
         </p:spPr>
       </p:sp>
-      <p:sp>
-        <p:nvSpPr>
-          <p:cNvPr id="12" name="Option dot B"/>
-          <p:cNvSpPr/>
-          <p:nvPr/>
-        </p:nvSpPr>
-        <p:spPr>
-          <a:xfrm>
-            <a:off x="6560820" y="2423160"/>
-            <a:ext cx="685800" cy="685800"/>
-          </a:xfrm>
-          <a:prstGeom prst="ellipse">
-            <a:avLst/>
-          </a:prstGeom>
-          <a:solidFill>
-            <a:srgbClr val="A63A0C"/>
-          </a:solidFill>
-          <a:ln/>
-        </p:spPr>
-      </p:sp>
-      <p:sp>
-        <p:nvSpPr>
-          <p:cNvPr id="13" name="Text 10"/>
-          <p:cNvSpPr txBox="1"/>
-          <p:nvPr/>
-        </p:nvSpPr>
-        <p:spPr>
-          <a:xfrm>
-            <a:off x="6560820" y="2423160"/>
-            <a:ext cx="685800" cy="685800"/>
-          </a:xfrm>
-          <a:prstGeom prst="rect">
-            <a:avLst/>
-          </a:prstGeom>
-          <a:noFill/>
-          <a:ln/>
-        </p:spPr>
-        <p:txBody>
-          <a:bodyPr wrap="square" lIns="0" tIns="0" rIns="0" bIns="0" rtlCol="0" anchor="ctr"/>
-          <a:lstStyle/>
-          <a:p>
-            <a:pPr algn="ctr" indent="0" marL="0">
-              <a:buNone/>
-            </a:pPr>
-            <a:r>
-              <a:rPr lang="en-US" sz="2800" dirty="0">
-                <a:solidFill>
-                  <a:srgbClr val="FFFFFF"/>
-                </a:solidFill>
-                <a:latin typeface="Cambria" pitchFamily="34" charset="0"/>
-                <a:ea typeface="Cambria" pitchFamily="34" charset="-122"/>
-                <a:cs typeface="Cambria" pitchFamily="34" charset="-120"/>
-              </a:rPr>
-              <a:t>B</a:t>
-            </a:r>
-            <a:endParaRPr lang="en-US" sz="2800" dirty="0"/>
-          </a:p>
-        </p:txBody>
-      </p:sp>
       <p:pic>
         <p:nvPicPr>
-          <p:cNvPr id="14" name="Option icon B" descr="A false alarm">    </p:cNvPr>
+          <p:cNvPr id="11" name="Mistake icon 2" descr="A false alarm">    </p:cNvPr>
           <p:cNvPicPr>
             <a:picLocks noChangeAspect="1"/>
           </p:cNvPicPr>
@@ -13076,7 +12858,7 @@
         </p:blipFill>
         <p:spPr>
           <a:xfrm>
-            <a:off x="10104120" y="2377440"/>
+            <a:off x="6560820" y="2377440"/>
             <a:ext cx="914400" cy="914400"/>
           </a:xfrm>
           <a:prstGeom prst="rect">
@@ -13086,7 +12868,45 @@
       </p:pic>
       <p:sp>
         <p:nvSpPr>
-          <p:cNvPr id="15" name="Text 11"/>
+          <p:cNvPr id="12" name="Mistake tag 2"/>
+          <p:cNvSpPr txBox="1"/>
+          <p:nvPr/>
+        </p:nvSpPr>
+        <p:spPr>
+          <a:xfrm>
+            <a:off x="9509760" y="2423160"/>
+            <a:ext cx="1508760" cy="384048"/>
+          </a:xfrm>
+          <a:prstGeom prst="rect">
+            <a:avLst/>
+          </a:prstGeom>
+          <a:solidFill>
+            <a:srgbClr val="6F5C51"/>
+          </a:solidFill>
+          <a:ln/>
+        </p:spPr>
+        <p:txBody>
+          <a:bodyPr wrap="square" lIns="0" tIns="0" rIns="0" bIns="0" rtlCol="0" anchor="ctr"/>
+          <a:lstStyle/>
+          <a:p>
+            <a:pPr algn="ctr" indent="0" marL="0">
+              <a:buNone/>
+            </a:pPr>
+            <a:r>
+              <a:rPr lang="en-US" sz="1300" b="1" spc="100" kern="0" dirty="0">
+                <a:solidFill>
+                  <a:srgbClr val="FFFFFF"/>
+                </a:solidFill>
+              </a:rPr>
+              <a:t>LESS COSTLY</a:t>
+            </a:r>
+            <a:endParaRPr lang="en-US" sz="1300" dirty="0"/>
+          </a:p>
+        </p:txBody>
+      </p:sp>
+      <p:sp>
+        <p:nvSpPr>
+          <p:cNvPr id="13" name="Text 9"/>
           <p:cNvSpPr txBox="1"/>
           <p:nvPr/>
         </p:nvSpPr>
@@ -13125,7 +12945,7 @@
       </p:sp>
       <p:sp>
         <p:nvSpPr>
-          <p:cNvPr id="16" name="Text 12"/>
+          <p:cNvPr id="14" name="Text 10"/>
           <p:cNvSpPr txBox="1"/>
           <p:nvPr/>
         </p:nvSpPr>
@@ -13161,7 +12981,7 @@
       </p:sp>
       <p:sp>
         <p:nvSpPr>
-          <p:cNvPr id="17" name="Text 13"/>
+          <p:cNvPr id="15" name="Text 11"/>
           <p:cNvSpPr txBox="1"/>
           <p:nvPr/>
         </p:nvSpPr>
@@ -13197,7 +13017,7 @@
       </p:sp>
       <p:sp>
         <p:nvSpPr>
-          <p:cNvPr id="18" name="Our choice"/>
+          <p:cNvPr id="16" name="Our choice"/>
           <p:cNvSpPr txBox="1"/>
           <p:nvPr/>
         </p:nvSpPr>
@@ -13228,7 +13048,7 @@
                 <a:ea typeface="Cambria" pitchFamily="34" charset="-122"/>
                 <a:cs typeface="Cambria" pitchFamily="34" charset="-120"/>
               </a:rPr>
-              <a:t>Our choice: A is worse. That is why a model must first catch more Danger days than copy-today.</a:t>
+              <a:t>So our rule: a model must first catch more Danger days than copy-today.</a:t>
             </a:r>
             <a:endParaRPr lang="en-US" sz="2000" dirty="0"/>
           </a:p>
@@ -13858,7 +13678,7 @@
                 <a:ea typeface="Cambria" pitchFamily="34" charset="-122"/>
                 <a:cs typeface="Cambria" pitchFamily="34" charset="-120"/>
               </a:rPr>
-              <a:t>YOUR GUESS</a:t>
+              <a:t>DANGER DAYS CAUGHT</a:t>
             </a:r>
             <a:endParaRPr lang="en-US" sz="3400" dirty="0"/>
           </a:p>
@@ -13904,14 +13724,14 @@
       </p:sp>
       <p:sp>
         <p:nvSpPr>
-          <p:cNvPr id="4" name="Guess question"/>
+          <p:cNvPr id="4" name="Setup"/>
           <p:cNvSpPr txBox="1"/>
           <p:nvPr/>
         </p:nvSpPr>
         <p:spPr>
           <a:xfrm>
-            <a:off x="1280160" y="2011680"/>
-            <a:ext cx="9631375" cy="914400"/>
+            <a:off x="1097280" y="1965960"/>
+            <a:ext cx="9997135" cy="914400"/>
           </a:xfrm>
           <a:prstGeom prst="rect">
             <a:avLst/>
@@ -13935,7 +13755,7 @@
                 <a:ea typeface="Cambria" pitchFamily="34" charset="-122"/>
                 <a:cs typeface="Cambria" pitchFamily="34" charset="-120"/>
               </a:rPr>
-              <a:t>In 2025 there were 347 Danger days across the 16 cities. How many did our Random Forest catch?</a:t>
+              <a:t>In 2025 there were 347 Danger days across the 16 cities. Here is how many got a warning the day before.</a:t>
             </a:r>
             <a:endParaRPr lang="en-US" sz="2800" dirty="0"/>
           </a:p>
@@ -13943,54 +13763,14 @@
       </p:sp>
       <p:sp>
         <p:nvSpPr>
-          <p:cNvPr id="5" name="Option A"/>
-          <p:cNvSpPr/>
-          <p:nvPr/>
-        </p:nvSpPr>
-        <p:spPr>
-          <a:xfrm>
-            <a:off x="868680" y="3108960"/>
-            <a:ext cx="3307080" cy="1600200"/>
-          </a:xfrm>
-          <a:prstGeom prst="rect">
-            <a:avLst/>
-          </a:prstGeom>
-          <a:solidFill>
-            <a:srgbClr val="FDEBDC"/>
-          </a:solidFill>
-          <a:ln/>
-        </p:spPr>
-      </p:sp>
-      <p:sp>
-        <p:nvSpPr>
-          <p:cNvPr id="6" name="Option dot A"/>
-          <p:cNvSpPr/>
-          <p:nvPr/>
-        </p:nvSpPr>
-        <p:spPr>
-          <a:xfrm>
-            <a:off x="1143000" y="3383280"/>
-            <a:ext cx="640080" cy="640080"/>
-          </a:xfrm>
-          <a:prstGeom prst="ellipse">
-            <a:avLst/>
-          </a:prstGeom>
-          <a:solidFill>
-            <a:srgbClr val="A63A0C"/>
-          </a:solidFill>
-          <a:ln/>
-        </p:spPr>
-      </p:sp>
-      <p:sp>
-        <p:nvSpPr>
-          <p:cNvPr id="7" name="Text 5"/>
+          <p:cNvPr id="5" name="Bar label 1"/>
           <p:cNvSpPr txBox="1"/>
           <p:nvPr/>
         </p:nvSpPr>
         <p:spPr>
           <a:xfrm>
-            <a:off x="1143000" y="3383280"/>
-            <a:ext cx="640080" cy="640080"/>
+            <a:off x="868680" y="3154680"/>
+            <a:ext cx="2743200" cy="822960"/>
           </a:xfrm>
           <a:prstGeom prst="rect">
             <a:avLst/>
@@ -14002,149 +13782,120 @@
           <a:bodyPr wrap="square" lIns="0" tIns="0" rIns="0" bIns="0" rtlCol="0" anchor="ctr"/>
           <a:lstStyle/>
           <a:p>
-            <a:pPr algn="ctr" indent="0" marL="0">
-              <a:buNone/>
-            </a:pPr>
-            <a:r>
-              <a:rPr lang="en-US" sz="2600" dirty="0">
-                <a:solidFill>
-                  <a:srgbClr val="FFFFFF"/>
+            <a:pPr indent="0" marL="0">
+              <a:buNone/>
+            </a:pPr>
+            <a:r>
+              <a:rPr lang="en-US" sz="2200" dirty="0">
+                <a:solidFill>
+                  <a:srgbClr val="2E1406"/>
                 </a:solidFill>
                 <a:latin typeface="Cambria" pitchFamily="34" charset="0"/>
                 <a:ea typeface="Cambria" pitchFamily="34" charset="-122"/>
                 <a:cs typeface="Cambria" pitchFamily="34" charset="-120"/>
               </a:rPr>
-              <a:t>A</a:t>
-            </a:r>
-            <a:endParaRPr lang="en-US" sz="2600" dirty="0"/>
-          </a:p>
-        </p:txBody>
-      </p:sp>
-      <p:sp>
-        <p:nvSpPr>
-          <p:cNvPr id="8" name="Option text A"/>
+              <a:t>Copy-today rule</a:t>
+            </a:r>
+            <a:endParaRPr lang="en-US" sz="2200" dirty="0"/>
+          </a:p>
+          <a:p>
+            <a:pPr indent="0" marL="0">
+              <a:buNone/>
+            </a:pPr>
+            <a:r>
+              <a:rPr lang="en-US" sz="1400" dirty="0">
+                <a:solidFill>
+                  <a:srgbClr val="6F5C51"/>
+                </a:solidFill>
+              </a:rPr>
+              <a:t>the baseline</a:t>
+            </a:r>
+            <a:endParaRPr lang="en-US" sz="2200" dirty="0"/>
+          </a:p>
+        </p:txBody>
+      </p:sp>
+      <p:sp>
+        <p:nvSpPr>
+          <p:cNvPr id="6" name="Track 1"/>
+          <p:cNvSpPr/>
+          <p:nvPr/>
+        </p:nvSpPr>
+        <p:spPr>
+          <a:xfrm>
+            <a:off x="3749040" y="3154680"/>
+            <a:ext cx="7589520" cy="822960"/>
+          </a:xfrm>
+          <a:prstGeom prst="rect">
+            <a:avLst/>
+          </a:prstGeom>
+          <a:solidFill>
+            <a:srgbClr val="FDEBDC"/>
+          </a:solidFill>
+          <a:ln/>
+        </p:spPr>
+      </p:sp>
+      <p:sp>
+        <p:nvSpPr>
+          <p:cNvPr id="7" name="Bar 1"/>
           <p:cNvSpPr txBox="1"/>
           <p:nvPr/>
         </p:nvSpPr>
         <p:spPr>
           <a:xfrm>
-            <a:off x="1143000" y="4160520"/>
-            <a:ext cx="2758440" cy="365760"/>
-          </a:xfrm>
-          <a:prstGeom prst="rect">
-            <a:avLst/>
-          </a:prstGeom>
-          <a:noFill/>
-          <a:ln/>
-        </p:spPr>
-        <p:txBody>
-          <a:bodyPr wrap="square" lIns="0" tIns="0" rIns="0" bIns="0" rtlCol="0" anchor="t"/>
-          <a:lstStyle/>
-          <a:p>
-            <a:pPr indent="0" marL="0">
-              <a:buNone/>
-            </a:pPr>
-            <a:r>
-              <a:rPr lang="en-US" sz="2400" dirty="0">
+            <a:off x="3749040" y="3154680"/>
+            <a:ext cx="4527466" cy="822960"/>
+          </a:xfrm>
+          <a:prstGeom prst="rect">
+            <a:avLst/>
+          </a:prstGeom>
+          <a:solidFill>
+            <a:srgbClr val="F28C28"/>
+          </a:solidFill>
+          <a:ln/>
+        </p:spPr>
+        <p:txBody>
+          <a:bodyPr wrap="square" lIns="0" tIns="0" rIns="177800" bIns="0" rtlCol="0" anchor="ctr"/>
+          <a:lstStyle/>
+          <a:p>
+            <a:pPr algn="r" indent="0" marL="0">
+              <a:buNone/>
+            </a:pPr>
+            <a:r>
+              <a:rPr lang="en-US" sz="3000" b="1" dirty="0">
                 <a:solidFill>
                   <a:srgbClr val="2E1406"/>
-                </a:solidFill>
-              </a:rPr>
-              <a:t>About 100</a:t>
-            </a:r>
-            <a:endParaRPr lang="en-US" sz="2400" dirty="0"/>
-          </a:p>
-        </p:txBody>
-      </p:sp>
-      <p:sp>
-        <p:nvSpPr>
-          <p:cNvPr id="9" name="Option B"/>
-          <p:cNvSpPr/>
-          <p:nvPr/>
-        </p:nvSpPr>
-        <p:spPr>
-          <a:xfrm>
-            <a:off x="4450080" y="3108960"/>
-            <a:ext cx="3307080" cy="1600200"/>
-          </a:xfrm>
-          <a:prstGeom prst="rect">
-            <a:avLst/>
-          </a:prstGeom>
-          <a:solidFill>
-            <a:srgbClr val="FDEBDC"/>
-          </a:solidFill>
-          <a:ln/>
-        </p:spPr>
-      </p:sp>
-      <p:sp>
-        <p:nvSpPr>
-          <p:cNvPr id="10" name="Option dot B"/>
-          <p:cNvSpPr/>
-          <p:nvPr/>
-        </p:nvSpPr>
-        <p:spPr>
-          <a:xfrm>
-            <a:off x="4724400" y="3383280"/>
-            <a:ext cx="640080" cy="640080"/>
-          </a:xfrm>
-          <a:prstGeom prst="ellipse">
-            <a:avLst/>
-          </a:prstGeom>
-          <a:solidFill>
-            <a:srgbClr val="A63A0C"/>
-          </a:solidFill>
-          <a:ln/>
-        </p:spPr>
-      </p:sp>
-      <p:sp>
-        <p:nvSpPr>
-          <p:cNvPr id="11" name="Text 9"/>
-          <p:cNvSpPr txBox="1"/>
-          <p:nvPr/>
-        </p:nvSpPr>
-        <p:spPr>
-          <a:xfrm>
-            <a:off x="4724400" y="3383280"/>
-            <a:ext cx="640080" cy="640080"/>
-          </a:xfrm>
-          <a:prstGeom prst="rect">
-            <a:avLst/>
-          </a:prstGeom>
-          <a:noFill/>
-          <a:ln/>
-        </p:spPr>
-        <p:txBody>
-          <a:bodyPr wrap="square" lIns="0" tIns="0" rIns="0" bIns="0" rtlCol="0" anchor="ctr"/>
-          <a:lstStyle/>
-          <a:p>
-            <a:pPr algn="ctr" indent="0" marL="0">
-              <a:buNone/>
-            </a:pPr>
-            <a:r>
-              <a:rPr lang="en-US" sz="2600" dirty="0">
-                <a:solidFill>
-                  <a:srgbClr val="FFFFFF"/>
                 </a:solidFill>
                 <a:latin typeface="Cambria" pitchFamily="34" charset="0"/>
                 <a:ea typeface="Cambria" pitchFamily="34" charset="-122"/>
                 <a:cs typeface="Cambria" pitchFamily="34" charset="-120"/>
               </a:rPr>
-              <a:t>B</a:t>
-            </a:r>
-            <a:endParaRPr lang="en-US" sz="2600" dirty="0"/>
-          </a:p>
-        </p:txBody>
-      </p:sp>
-      <p:sp>
-        <p:nvSpPr>
-          <p:cNvPr id="12" name="Option text B"/>
+              <a:t>207</a:t>
+            </a:r>
+            <a:pPr algn="r" indent="0" marL="0">
+              <a:buNone/>
+            </a:pPr>
+            <a:r>
+              <a:rPr lang="en-US" sz="1500" dirty="0">
+                <a:solidFill>
+                  <a:srgbClr val="2E1406"/>
+                </a:solidFill>
+              </a:rPr>
+              <a:t>  of 347 (60%)</a:t>
+            </a:r>
+            <a:endParaRPr lang="en-US" sz="3000" dirty="0"/>
+          </a:p>
+        </p:txBody>
+      </p:sp>
+      <p:sp>
+        <p:nvSpPr>
+          <p:cNvPr id="8" name="Bar label 2"/>
           <p:cNvSpPr txBox="1"/>
           <p:nvPr/>
         </p:nvSpPr>
         <p:spPr>
           <a:xfrm>
-            <a:off x="4724400" y="4160520"/>
-            <a:ext cx="2758440" cy="365760"/>
+            <a:off x="868680" y="4206240"/>
+            <a:ext cx="2743200" cy="822960"/>
           </a:xfrm>
           <a:prstGeom prst="rect">
             <a:avLst/>
@@ -14153,441 +13904,165 @@
           <a:ln/>
         </p:spPr>
         <p:txBody>
-          <a:bodyPr wrap="square" lIns="0" tIns="0" rIns="0" bIns="0" rtlCol="0" anchor="t"/>
+          <a:bodyPr wrap="square" lIns="0" tIns="0" rIns="0" bIns="0" rtlCol="0" anchor="ctr"/>
           <a:lstStyle/>
           <a:p>
             <a:pPr indent="0" marL="0">
               <a:buNone/>
             </a:pPr>
             <a:r>
-              <a:rPr lang="en-US" sz="2400" dirty="0">
+              <a:rPr lang="en-US" sz="2200" dirty="0">
                 <a:solidFill>
                   <a:srgbClr val="2E1406"/>
-                </a:solidFill>
-              </a:rPr>
-              <a:t>About 200</a:t>
-            </a:r>
-            <a:endParaRPr lang="en-US" sz="2400" dirty="0"/>
-          </a:p>
-        </p:txBody>
-      </p:sp>
-      <p:sp>
-        <p:nvSpPr>
-          <p:cNvPr id="13" name="Option C"/>
-          <p:cNvSpPr/>
-          <p:nvPr/>
-        </p:nvSpPr>
-        <p:spPr>
-          <a:xfrm>
-            <a:off x="8031480" y="3108960"/>
-            <a:ext cx="3307080" cy="1600200"/>
-          </a:xfrm>
-          <a:prstGeom prst="rect">
-            <a:avLst/>
-          </a:prstGeom>
-          <a:solidFill>
-            <a:srgbClr val="FDEBDC"/>
-          </a:solidFill>
-          <a:ln/>
-        </p:spPr>
-      </p:sp>
-      <p:sp>
-        <p:nvSpPr>
-          <p:cNvPr id="14" name="Option dot C"/>
-          <p:cNvSpPr/>
-          <p:nvPr/>
-        </p:nvSpPr>
-        <p:spPr>
-          <a:xfrm>
-            <a:off x="8305800" y="3383280"/>
-            <a:ext cx="640080" cy="640080"/>
-          </a:xfrm>
-          <a:prstGeom prst="ellipse">
-            <a:avLst/>
-          </a:prstGeom>
-          <a:solidFill>
-            <a:srgbClr val="A63A0C"/>
-          </a:solidFill>
-          <a:ln/>
-        </p:spPr>
-      </p:sp>
-      <p:sp>
-        <p:nvSpPr>
-          <p:cNvPr id="15" name="Text 13"/>
-          <p:cNvSpPr txBox="1"/>
-          <p:nvPr/>
-        </p:nvSpPr>
-        <p:spPr>
-          <a:xfrm>
-            <a:off x="8305800" y="3383280"/>
-            <a:ext cx="640080" cy="640080"/>
-          </a:xfrm>
-          <a:prstGeom prst="rect">
-            <a:avLst/>
-          </a:prstGeom>
-          <a:noFill/>
-          <a:ln/>
-        </p:spPr>
-        <p:txBody>
-          <a:bodyPr wrap="square" lIns="0" tIns="0" rIns="0" bIns="0" rtlCol="0" anchor="ctr"/>
-          <a:lstStyle/>
-          <a:p>
-            <a:pPr algn="ctr" indent="0" marL="0">
-              <a:buNone/>
-            </a:pPr>
-            <a:r>
-              <a:rPr lang="en-US" sz="2600" dirty="0">
-                <a:solidFill>
-                  <a:srgbClr val="FFFFFF"/>
                 </a:solidFill>
                 <a:latin typeface="Cambria" pitchFamily="34" charset="0"/>
                 <a:ea typeface="Cambria" pitchFamily="34" charset="-122"/>
                 <a:cs typeface="Cambria" pitchFamily="34" charset="-120"/>
               </a:rPr>
-              <a:t>C</a:t>
-            </a:r>
-            <a:endParaRPr lang="en-US" sz="2600" dirty="0"/>
-          </a:p>
-        </p:txBody>
-      </p:sp>
-      <p:sp>
-        <p:nvSpPr>
-          <p:cNvPr id="16" name="Option text C"/>
+              <a:t>Our Random Forest</a:t>
+            </a:r>
+            <a:endParaRPr lang="en-US" sz="2200" dirty="0"/>
+          </a:p>
+          <a:p>
+            <a:pPr indent="0" marL="0">
+              <a:buNone/>
+            </a:pPr>
+            <a:r>
+              <a:rPr lang="en-US" sz="1400" dirty="0">
+                <a:solidFill>
+                  <a:srgbClr val="6F5C51"/>
+                </a:solidFill>
+              </a:rPr>
+              <a:t>the selected model</a:t>
+            </a:r>
+            <a:endParaRPr lang="en-US" sz="2200" dirty="0"/>
+          </a:p>
+        </p:txBody>
+      </p:sp>
+      <p:sp>
+        <p:nvSpPr>
+          <p:cNvPr id="9" name="Track 2"/>
+          <p:cNvSpPr/>
+          <p:nvPr/>
+        </p:nvSpPr>
+        <p:spPr>
+          <a:xfrm>
+            <a:off x="3749040" y="4206240"/>
+            <a:ext cx="7589520" cy="822960"/>
+          </a:xfrm>
+          <a:prstGeom prst="rect">
+            <a:avLst/>
+          </a:prstGeom>
+          <a:solidFill>
+            <a:srgbClr val="FDEBDC"/>
+          </a:solidFill>
+          <a:ln/>
+        </p:spPr>
+      </p:sp>
+      <p:sp>
+        <p:nvSpPr>
+          <p:cNvPr id="10" name="Bar 2"/>
           <p:cNvSpPr txBox="1"/>
           <p:nvPr/>
         </p:nvSpPr>
         <p:spPr>
           <a:xfrm>
-            <a:off x="8305800" y="4160520"/>
-            <a:ext cx="2758440" cy="365760"/>
-          </a:xfrm>
-          <a:prstGeom prst="rect">
-            <a:avLst/>
-          </a:prstGeom>
-          <a:noFill/>
-          <a:ln/>
-        </p:spPr>
-        <p:txBody>
-          <a:bodyPr wrap="square" lIns="0" tIns="0" rIns="0" bIns="0" rtlCol="0" anchor="t"/>
-          <a:lstStyle/>
-          <a:p>
-            <a:pPr indent="0" marL="0">
-              <a:buNone/>
-            </a:pPr>
-            <a:r>
-              <a:rPr lang="en-US" sz="2400" dirty="0">
-                <a:solidFill>
-                  <a:srgbClr val="2E1406"/>
-                </a:solidFill>
-              </a:rPr>
-              <a:t>About 300</a:t>
-            </a:r>
-            <a:endParaRPr lang="en-US" sz="2400" dirty="0"/>
-          </a:p>
-        </p:txBody>
-      </p:sp>
-      <p:sp>
-        <p:nvSpPr>
-          <p:cNvPr id="17" name="Text 15"/>
-          <p:cNvSpPr txBox="1"/>
-          <p:nvPr/>
-        </p:nvSpPr>
-        <p:spPr>
-          <a:xfrm>
-            <a:off x="868680" y="5212080"/>
-            <a:ext cx="365760" cy="320040"/>
-          </a:xfrm>
-          <a:prstGeom prst="rect">
-            <a:avLst/>
-          </a:prstGeom>
-          <a:noFill/>
-          <a:ln/>
-        </p:spPr>
-        <p:txBody>
-          <a:bodyPr wrap="square" lIns="0" tIns="0" rIns="0" bIns="0" rtlCol="0" anchor="ctr"/>
+            <a:off x="3749040" y="4206240"/>
+            <a:ext cx="6408442" cy="822960"/>
+          </a:xfrm>
+          <a:prstGeom prst="rect">
+            <a:avLst/>
+          </a:prstGeom>
+          <a:solidFill>
+            <a:srgbClr val="C0392B"/>
+          </a:solidFill>
+          <a:ln/>
+        </p:spPr>
+        <p:txBody>
+          <a:bodyPr wrap="square" lIns="0" tIns="0" rIns="177800" bIns="0" rtlCol="0" anchor="ctr"/>
           <a:lstStyle/>
           <a:p>
             <a:pPr algn="r" indent="0" marL="0">
               <a:buNone/>
             </a:pPr>
             <a:r>
-              <a:rPr lang="en-US" sz="1400" dirty="0">
-                <a:solidFill>
-                  <a:srgbClr val="6F5C51"/>
-                </a:solidFill>
-              </a:rPr>
-              <a:t>0</a:t>
-            </a:r>
-            <a:endParaRPr lang="en-US" sz="1400" dirty="0"/>
-          </a:p>
-        </p:txBody>
-      </p:sp>
-      <p:sp>
-        <p:nvSpPr>
-          <p:cNvPr id="18" name="Text 16"/>
-          <p:cNvSpPr txBox="1"/>
-          <p:nvPr/>
-        </p:nvSpPr>
-        <p:spPr>
-          <a:xfrm>
-            <a:off x="10972800" y="5212080"/>
-            <a:ext cx="548640" cy="320040"/>
-          </a:xfrm>
-          <a:prstGeom prst="rect">
-            <a:avLst/>
-          </a:prstGeom>
-          <a:noFill/>
-          <a:ln/>
-        </p:spPr>
-        <p:txBody>
-          <a:bodyPr wrap="square" lIns="0" tIns="0" rIns="0" bIns="0" rtlCol="0" anchor="ctr"/>
-          <a:lstStyle/>
-          <a:p>
-            <a:pPr indent="0" marL="0">
-              <a:buNone/>
-            </a:pPr>
-            <a:r>
-              <a:rPr lang="en-US" sz="1400" dirty="0">
-                <a:solidFill>
-                  <a:srgbClr val="6F5C51"/>
-                </a:solidFill>
-              </a:rPr>
-              <a:t>347</a:t>
-            </a:r>
-            <a:endParaRPr lang="en-US" sz="1400" dirty="0"/>
-          </a:p>
-        </p:txBody>
-      </p:sp>
-      <p:sp>
-        <p:nvSpPr>
-          <p:cNvPr id="19" name="Scale"/>
-          <p:cNvSpPr/>
-          <p:nvPr/>
-        </p:nvSpPr>
-        <p:spPr>
-          <a:xfrm>
-            <a:off x="1325880" y="5257800"/>
-            <a:ext cx="9555480" cy="237744"/>
-          </a:xfrm>
-          <a:prstGeom prst="rect">
-            <a:avLst/>
-          </a:prstGeom>
-          <a:solidFill>
-            <a:srgbClr val="F6C9A0"/>
-          </a:solidFill>
-          <a:ln/>
-        </p:spPr>
-      </p:sp>
-      <p:sp>
-        <p:nvSpPr>
-          <p:cNvPr id="20" name="Tick A"/>
-          <p:cNvSpPr/>
-          <p:nvPr/>
-        </p:nvSpPr>
-        <p:spPr>
-          <a:xfrm>
-            <a:off x="4061333" y="5148072"/>
-            <a:ext cx="36576" cy="457200"/>
-          </a:xfrm>
-          <a:prstGeom prst="rect">
-            <a:avLst/>
-          </a:prstGeom>
-          <a:solidFill>
-            <a:srgbClr val="A63A0C"/>
-          </a:solidFill>
-          <a:ln/>
-        </p:spPr>
-      </p:sp>
-      <p:sp>
-        <p:nvSpPr>
-          <p:cNvPr id="21" name="Text 19"/>
-          <p:cNvSpPr txBox="1"/>
-          <p:nvPr/>
-        </p:nvSpPr>
-        <p:spPr>
-          <a:xfrm>
-            <a:off x="3805301" y="5605272"/>
-            <a:ext cx="548640" cy="292608"/>
-          </a:xfrm>
-          <a:prstGeom prst="rect">
-            <a:avLst/>
-          </a:prstGeom>
-          <a:noFill/>
-          <a:ln/>
-        </p:spPr>
-        <p:txBody>
-          <a:bodyPr wrap="square" lIns="0" tIns="0" rIns="0" bIns="0" rtlCol="0" anchor="ctr"/>
-          <a:lstStyle/>
-          <a:p>
-            <a:pPr algn="ctr" indent="0" marL="0">
-              <a:buNone/>
-            </a:pPr>
-            <a:r>
-              <a:rPr lang="en-US" sz="1600" b="1" dirty="0">
-                <a:solidFill>
-                  <a:srgbClr val="A63A0C"/>
+              <a:rPr lang="en-US" sz="3000" b="1" dirty="0">
+                <a:solidFill>
+                  <a:srgbClr val="FFFFFF"/>
                 </a:solidFill>
                 <a:latin typeface="Cambria" pitchFamily="34" charset="0"/>
                 <a:ea typeface="Cambria" pitchFamily="34" charset="-122"/>
                 <a:cs typeface="Cambria" pitchFamily="34" charset="-120"/>
               </a:rPr>
-              <a:t>A</a:t>
-            </a:r>
-            <a:endParaRPr lang="en-US" sz="1600" dirty="0"/>
-          </a:p>
-        </p:txBody>
-      </p:sp>
-      <p:sp>
-        <p:nvSpPr>
-          <p:cNvPr id="22" name="Tick B"/>
-          <p:cNvSpPr/>
-          <p:nvPr/>
-        </p:nvSpPr>
-        <p:spPr>
-          <a:xfrm>
-            <a:off x="6815073" y="5148072"/>
-            <a:ext cx="36576" cy="457200"/>
-          </a:xfrm>
-          <a:prstGeom prst="rect">
-            <a:avLst/>
-          </a:prstGeom>
-          <a:solidFill>
-            <a:srgbClr val="A63A0C"/>
-          </a:solidFill>
-          <a:ln/>
-        </p:spPr>
-      </p:sp>
-      <p:sp>
-        <p:nvSpPr>
-          <p:cNvPr id="23" name="Text 21"/>
+              <a:t>293</a:t>
+            </a:r>
+            <a:pPr algn="r" indent="0" marL="0">
+              <a:buNone/>
+            </a:pPr>
+            <a:r>
+              <a:rPr lang="en-US" sz="1500" dirty="0">
+                <a:solidFill>
+                  <a:srgbClr val="FFFFFF"/>
+                </a:solidFill>
+              </a:rPr>
+              <a:t>  of 347 (84%)</a:t>
+            </a:r>
+            <a:endParaRPr lang="en-US" sz="3000" dirty="0"/>
+          </a:p>
+        </p:txBody>
+      </p:sp>
+      <p:sp>
+        <p:nvSpPr>
+          <p:cNvPr id="11" name="Difference"/>
           <p:cNvSpPr txBox="1"/>
           <p:nvPr/>
         </p:nvSpPr>
         <p:spPr>
           <a:xfrm>
-            <a:off x="6559041" y="5605272"/>
-            <a:ext cx="548640" cy="292608"/>
-          </a:xfrm>
-          <a:prstGeom prst="rect">
-            <a:avLst/>
-          </a:prstGeom>
-          <a:noFill/>
-          <a:ln/>
-        </p:spPr>
-        <p:txBody>
-          <a:bodyPr wrap="square" lIns="0" tIns="0" rIns="0" bIns="0" rtlCol="0" anchor="ctr"/>
+            <a:off x="868680" y="5440680"/>
+            <a:ext cx="10469880" cy="566928"/>
+          </a:xfrm>
+          <a:prstGeom prst="rect">
+            <a:avLst/>
+          </a:prstGeom>
+          <a:solidFill>
+            <a:srgbClr val="2E1406"/>
+          </a:solidFill>
+          <a:ln/>
+        </p:spPr>
+        <p:txBody>
+          <a:bodyPr wrap="square" lIns="76200" tIns="76200" rIns="76200" bIns="76200" rtlCol="0" anchor="ctr"/>
           <a:lstStyle/>
           <a:p>
             <a:pPr algn="ctr" indent="0" marL="0">
               <a:buNone/>
             </a:pPr>
             <a:r>
-              <a:rPr lang="en-US" sz="1600" b="1" dirty="0">
-                <a:solidFill>
-                  <a:srgbClr val="A63A0C"/>
+              <a:rPr lang="en-US" sz="2000" b="1" dirty="0">
+                <a:solidFill>
+                  <a:srgbClr val="FBF4EC"/>
                 </a:solidFill>
                 <a:latin typeface="Cambria" pitchFamily="34" charset="0"/>
                 <a:ea typeface="Cambria" pitchFamily="34" charset="-122"/>
                 <a:cs typeface="Cambria" pitchFamily="34" charset="-120"/>
               </a:rPr>
-              <a:t>B</a:t>
-            </a:r>
-            <a:endParaRPr lang="en-US" sz="1600" dirty="0"/>
-          </a:p>
-        </p:txBody>
-      </p:sp>
-      <p:sp>
-        <p:nvSpPr>
-          <p:cNvPr id="24" name="Tick C"/>
-          <p:cNvSpPr/>
-          <p:nvPr/>
-        </p:nvSpPr>
-        <p:spPr>
-          <a:xfrm>
-            <a:off x="9568814" y="5148072"/>
-            <a:ext cx="36576" cy="457200"/>
-          </a:xfrm>
-          <a:prstGeom prst="rect">
-            <a:avLst/>
-          </a:prstGeom>
-          <a:solidFill>
-            <a:srgbClr val="A63A0C"/>
-          </a:solidFill>
-          <a:ln/>
-        </p:spPr>
-      </p:sp>
-      <p:sp>
-        <p:nvSpPr>
-          <p:cNvPr id="25" name="Text 23"/>
-          <p:cNvSpPr txBox="1"/>
-          <p:nvPr/>
-        </p:nvSpPr>
-        <p:spPr>
-          <a:xfrm>
-            <a:off x="9312782" y="5605272"/>
-            <a:ext cx="548640" cy="292608"/>
-          </a:xfrm>
-          <a:prstGeom prst="rect">
-            <a:avLst/>
-          </a:prstGeom>
-          <a:noFill/>
-          <a:ln/>
-        </p:spPr>
-        <p:txBody>
-          <a:bodyPr wrap="square" lIns="0" tIns="0" rIns="0" bIns="0" rtlCol="0" anchor="ctr"/>
-          <a:lstStyle/>
-          <a:p>
+              <a:t>86 more Danger days</a:t>
+            </a:r>
             <a:pPr algn="ctr" indent="0" marL="0">
               <a:buNone/>
             </a:pPr>
             <a:r>
-              <a:rPr lang="en-US" sz="1600" b="1" dirty="0">
-                <a:solidFill>
-                  <a:srgbClr val="A63A0C"/>
+              <a:rPr lang="en-US" sz="2000" dirty="0">
+                <a:solidFill>
+                  <a:srgbClr val="FBF4EC"/>
                 </a:solidFill>
                 <a:latin typeface="Cambria" pitchFamily="34" charset="0"/>
                 <a:ea typeface="Cambria" pitchFamily="34" charset="-122"/>
                 <a:cs typeface="Cambria" pitchFamily="34" charset="-120"/>
               </a:rPr>
-              <a:t>C</a:t>
-            </a:r>
-            <a:endParaRPr lang="en-US" sz="1600" dirty="0"/>
-          </a:p>
-        </p:txBody>
-      </p:sp>
-      <p:sp>
-        <p:nvSpPr>
-          <p:cNvPr id="26" name="Hint"/>
-          <p:cNvSpPr txBox="1"/>
-          <p:nvPr/>
-        </p:nvSpPr>
-        <p:spPr>
-          <a:xfrm>
-            <a:off x="1325880" y="5870448"/>
-            <a:ext cx="9555480" cy="292608"/>
-          </a:xfrm>
-          <a:prstGeom prst="rect">
-            <a:avLst/>
-          </a:prstGeom>
-          <a:noFill/>
-          <a:ln/>
-        </p:spPr>
-        <p:txBody>
-          <a:bodyPr wrap="square" lIns="0" tIns="0" rIns="0" bIns="0" rtlCol="0" anchor="ctr"/>
-          <a:lstStyle/>
-          <a:p>
-            <a:pPr algn="ctr" indent="0" marL="0">
-              <a:buNone/>
-            </a:pPr>
-            <a:r>
-              <a:rPr lang="en-US" sz="1400" i="1" dirty="0">
-                <a:solidFill>
-                  <a:srgbClr val="6F5C51"/>
-                </a:solidFill>
-              </a:rPr>
-              <a:t>Hint: the copy-today rule caught 207.</a:t>
-            </a:r>
-            <a:endParaRPr lang="en-US" sz="1400" dirty="0"/>
+              <a:t> got a warning the day before, compared with copying today.</a:t>
+            </a:r>
+            <a:endParaRPr lang="en-US" sz="2000" dirty="0"/>
           </a:p>
         </p:txBody>
       </p:sp>

</xml_diff>